<commit_message>
slides: 本人の編集版を更新 (10-05 18:12)
</commit_message>
<xml_diff>
--- a/slides/2026-10-09_研究報告_10枚版.pptx
+++ b/slides/2026-10-09_研究報告_10枚版.pptx
@@ -1164,6 +1164,11 @@
               <a:t>図: 青＝本研究 (名目)、赤＝Totani Fig. 9 (NFW-ρ²)、緑＝何も無い空のクセ 1.2〜1.3 で割った値 (14〜15σ)。露出マップを公式の方法で作り直した結果 (results/mcmc_allbins_gasICS_v20t_irf)。Totani との比は 1.23 倍。</a:t>
             </a:r>
           </a:p>
+          <a:p>
+            <a:r>
+              <a:t>② の根拠: ICS の型紙をバブルの長方形 (|l|&lt;22°, 10°&lt;|b|&lt;55°) の内側と外側に分け、別々の強さを許すと、ハローなしでも内側が外側の 2.1 倍になり、ハローの有意度は 17.6σ → 5.7σ に下がる (ハローが良くした点数の 93% を説明; results/ics_inner_boost_irf)。だから『型紙のずれ』と『ハロー』はまだ区別できない。</a:t>
+            </a:r>
+          </a:p>
         </p:txBody>
       </p:sp>
       <p:sp>
@@ -4984,7 +4989,7 @@
         </p:nvSpPr>
         <p:spPr>
           <a:xfrm>
-            <a:off x="548640" y="1280160"/>
+            <a:off x="548640" y="1463040"/>
             <a:ext cx="11155680" cy="4572000"/>
           </a:xfrm>
           <a:prstGeom prst="rect">
@@ -4998,13 +5003,13 @@
           </a:bodyPr>
           <a:lstStyle/>
           <a:p>
-            <a:pPr>
+            <a:pPr marL="274320" indent="-274320">
               <a:spcAft>
                 <a:spcPts val="500"/>
               </a:spcAft>
             </a:pPr>
             <a:r>
-              <a:rPr sz="1900" b="1" lang="ja-JP">
+              <a:rPr sz="2200" b="1" lang="ja-JP">
                 <a:latin typeface="+mn-lt"/>
                 <a:ea typeface="+mn-ea"/>
               </a:rPr>
@@ -5012,27 +5017,27 @@
             </a:r>
           </a:p>
           <a:p>
-            <a:pPr>
+            <a:pPr marL="548640" indent="0">
               <a:spcAft>
                 <a:spcPts val="500"/>
               </a:spcAft>
             </a:pPr>
             <a:r>
-              <a:rPr sz="1600" b="0" lang="ja-JP">
+              <a:rPr sz="1900" b="0" lang="ja-JP">
                 <a:latin typeface="+mn-lt"/>
                 <a:ea typeface="+mn-ea"/>
               </a:rPr>
-              <a:t>　　シミュレーションの誤差を統計に入れる方法（データ同化）で扱いたい</a:t>
-            </a:r>
-          </a:p>
-          <a:p>
-            <a:pPr>
+              <a:t>シミュレーションの誤差を統計に入れる方法（データ同化）で扱いたい</a:t>
+            </a:r>
+          </a:p>
+          <a:p>
+            <a:pPr marL="274320" indent="-274320">
               <a:spcAft>
                 <a:spcPts val="500"/>
               </a:spcAft>
             </a:pPr>
             <a:r>
-              <a:rPr sz="1900" b="0" lang="ja-JP">
+              <a:rPr sz="2200" b="0" lang="ja-JP">
                 <a:latin typeface="+mn-lt"/>
                 <a:ea typeface="+mn-ea"/>
               </a:rPr>
@@ -5040,13 +5045,13 @@
             </a:r>
           </a:p>
           <a:p>
-            <a:pPr>
+            <a:pPr marL="274320" indent="-274320">
               <a:spcAft>
                 <a:spcPts val="500"/>
               </a:spcAft>
             </a:pPr>
             <a:r>
-              <a:rPr sz="1900" b="0" lang="ja-JP">
+              <a:rPr sz="2200" b="0" lang="ja-JP">
                 <a:latin typeface="+mn-lt"/>
                 <a:ea typeface="+mn-ea"/>
               </a:rPr>
@@ -5054,27 +5059,27 @@
             </a:r>
           </a:p>
           <a:p>
-            <a:pPr>
+            <a:pPr marL="274320" indent="-274320">
               <a:spcAft>
                 <a:spcPts val="500"/>
               </a:spcAft>
             </a:pPr>
             <a:r>
-              <a:rPr sz="1900" b="0" lang="ja-JP">
+              <a:rPr sz="2200" b="0" lang="ja-JP">
                 <a:latin typeface="+mn-lt"/>
                 <a:ea typeface="+mn-ea"/>
               </a:rPr>
-              <a:t>・ICS の「空での形」のずれは、まだ否定できていない</a:t>
-            </a:r>
-          </a:p>
-          <a:p>
-            <a:pPr>
+              <a:t>・ICS の型紙の形のずれ（中心付近 2 倍）は、まだ否定できていない</a:t>
+            </a:r>
+          </a:p>
+          <a:p>
+            <a:pPr marL="274320" indent="-274320">
               <a:spcAft>
                 <a:spcPts val="500"/>
               </a:spcAft>
             </a:pPr>
             <a:r>
-              <a:rPr sz="1900" b="1" lang="ja-JP">
+              <a:rPr sz="2200" b="1" lang="ja-JP">
                 <a:latin typeface="+mn-lt"/>
                 <a:ea typeface="+mn-ea"/>
               </a:rPr>
@@ -5134,7 +5139,7 @@
         </p:nvSpPr>
         <p:spPr>
           <a:xfrm>
-            <a:off x="548640" y="1280160"/>
+            <a:off x="548640" y="1463040"/>
             <a:ext cx="6035040" cy="4754880"/>
           </a:xfrm>
           <a:prstGeom prst="rect">
@@ -5148,7 +5153,7 @@
           </a:bodyPr>
           <a:lstStyle/>
           <a:p>
-            <a:pPr>
+            <a:pPr marL="274320" indent="-274320">
               <a:spcAft>
                 <a:spcPts val="500"/>
               </a:spcAft>
@@ -5162,7 +5167,7 @@
             </a:r>
           </a:p>
           <a:p>
-            <a:pPr>
+            <a:pPr marL="274320" indent="-274320">
               <a:spcAft>
                 <a:spcPts val="500"/>
               </a:spcAft>
@@ -5176,7 +5181,7 @@
             </a:r>
           </a:p>
           <a:p>
-            <a:pPr>
+            <a:pPr marL="548640" indent="0">
               <a:spcAft>
                 <a:spcPts val="500"/>
               </a:spcAft>
@@ -5186,11 +5191,11 @@
                 <a:latin typeface="+mn-lt"/>
                 <a:ea typeface="+mn-ea"/>
               </a:rPr>
-              <a:t>　　20.8 GeV で 17.6σ（Totani の同じ形は 14.3σ）</a:t>
-            </a:r>
-          </a:p>
-          <a:p>
-            <a:pPr>
+              <a:t>20.8 GeV で 17.6σ（Totani の同じ形は 14.3σ）</a:t>
+            </a:r>
+          </a:p>
+          <a:p>
+            <a:pPr marL="548640" indent="0">
               <a:spcAft>
                 <a:spcPts val="500"/>
               </a:spcAft>
@@ -5200,11 +5205,11 @@
                 <a:latin typeface="+mn-lt"/>
                 <a:ea typeface="+mn-ea"/>
               </a:rPr>
-              <a:t>　　山の位置・形・一番合うハローの形が一致</a:t>
-            </a:r>
-          </a:p>
-          <a:p>
-            <a:pPr>
+              <a:t>山の位置・形・一番合うハローの形が一致</a:t>
+            </a:r>
+          </a:p>
+          <a:p>
+            <a:pPr marL="274320" indent="-274320">
               <a:spcAft>
                 <a:spcPts val="500"/>
               </a:spcAft>
@@ -5214,11 +5219,11 @@
                 <a:latin typeface="+mn-lt"/>
                 <a:ea typeface="+mn-ea"/>
               </a:rPr>
-              <a:t>・② 背景（ICS・バブル）の計算の間違いでは説明できない</a:t>
-            </a:r>
-          </a:p>
-          <a:p>
-            <a:pPr>
+              <a:t>・② でも、暗黒物質とはまだ決められない</a:t>
+            </a:r>
+          </a:p>
+          <a:p>
+            <a:pPr marL="548640" indent="0">
               <a:spcAft>
                 <a:spcPts val="500"/>
               </a:spcAft>
@@ -5228,11 +5233,11 @@
                 <a:latin typeface="+mn-lt"/>
                 <a:ea typeface="+mn-ea"/>
               </a:rPr>
-              <a:t>　　ただし、暗黒物質の証拠とまでは言えない</a:t>
-            </a:r>
-          </a:p>
-          <a:p>
-            <a:pPr>
+              <a:t>背景の光（ICS）の型紙が中心付近で 2 倍ずれていても、ほぼ同じ結果になる</a:t>
+            </a:r>
+          </a:p>
+          <a:p>
+            <a:pPr marL="274320" indent="-274320">
               <a:spcAft>
                 <a:spcPts val="500"/>
               </a:spcAft>
@@ -5246,7 +5251,7 @@
             </a:r>
           </a:p>
           <a:p>
-            <a:pPr>
+            <a:pPr marL="548640" indent="0">
               <a:spcAft>
                 <a:spcPts val="500"/>
               </a:spcAft>
@@ -5256,7 +5261,7 @@
                 <a:latin typeface="+mn-lt"/>
                 <a:ea typeface="+mn-ea"/>
               </a:rPr>
-              <a:t>　　でも「無い」とも言えない（判定できない）</a:t>
+              <a:t>でも「無い」とも言えない（判定できない）</a:t>
             </a:r>
           </a:p>
         </p:txBody>
@@ -5323,7 +5328,7 @@
                 <a:latin typeface="+mj-lt"/>
                 <a:ea typeface="+mj-ea"/>
               </a:rPr>
-              <a:t>先週の疑問①：1.2〜1.3 は「引く」？「割る」？</a:t>
+              <a:t>疑問①：1.2〜1.3 は「引く」？「割る」？</a:t>
             </a:r>
           </a:p>
         </p:txBody>
@@ -5336,7 +5341,7 @@
         </p:nvSpPr>
         <p:spPr>
           <a:xfrm>
-            <a:off x="548640" y="1280160"/>
+            <a:off x="548640" y="1463040"/>
             <a:ext cx="5852160" cy="4937760"/>
           </a:xfrm>
           <a:prstGeom prst="rect">
@@ -5350,7 +5355,7 @@
           </a:bodyPr>
           <a:lstStyle/>
           <a:p>
-            <a:pPr>
+            <a:pPr marL="274320" indent="-274320">
               <a:spcAft>
                 <a:spcPts val="500"/>
               </a:spcAft>
@@ -5364,7 +5369,7 @@
             </a:r>
           </a:p>
           <a:p>
-            <a:pPr>
+            <a:pPr marL="274320" indent="-274320">
               <a:spcAft>
                 <a:spcPts val="500"/>
               </a:spcAft>
@@ -5378,7 +5383,7 @@
             </a:r>
           </a:p>
           <a:p>
-            <a:pPr>
+            <a:pPr marL="548640" indent="0">
               <a:spcAft>
                 <a:spcPts val="500"/>
               </a:spcAft>
@@ -5388,11 +5393,11 @@
                 <a:latin typeface="+mn-lt"/>
                 <a:ea typeface="+mn-ea"/>
               </a:rPr>
-              <a:t>　　たとえ：目盛りが 1.2 倍に伸びた定規。引き算では直らず、1.2 で割ると直る</a:t>
-            </a:r>
-          </a:p>
-          <a:p>
-            <a:pPr>
+              <a:t>たとえ：目盛りが 1.2 倍に伸びた定規。引き算では直らず、1.2 で割ると直る</a:t>
+            </a:r>
+          </a:p>
+          <a:p>
+            <a:pPr marL="274320" indent="-274320">
               <a:spcAft>
                 <a:spcPts val="500"/>
               </a:spcAft>
@@ -5406,7 +5411,7 @@
             </a:r>
           </a:p>
           <a:p>
-            <a:pPr>
+            <a:pPr marL="274320" indent="-274320">
               <a:spcAft>
                 <a:spcPts val="500"/>
               </a:spcAft>
@@ -5420,7 +5425,7 @@
             </a:r>
           </a:p>
           <a:p>
-            <a:pPr>
+            <a:pPr marL="274320" indent="-274320">
               <a:spcAft>
                 <a:spcPts val="500"/>
               </a:spcAft>
@@ -5497,7 +5502,7 @@
                 <a:latin typeface="+mj-lt"/>
                 <a:ea typeface="+mj-ea"/>
               </a:rPr>
-              <a:t>先週の疑問②：何も無い空はどこから？パラメータ 0 ではだめ？</a:t>
+              <a:t>疑問②：何も無い空はどこから？　0 ではだめ？</a:t>
             </a:r>
           </a:p>
         </p:txBody>
@@ -5510,7 +5515,7 @@
         </p:nvSpPr>
         <p:spPr>
           <a:xfrm>
-            <a:off x="548640" y="1280160"/>
+            <a:off x="548640" y="1463040"/>
             <a:ext cx="5852160" cy="4937760"/>
           </a:xfrm>
           <a:prstGeom prst="rect">
@@ -5524,7 +5529,7 @@
           </a:bodyPr>
           <a:lstStyle/>
           <a:p>
-            <a:pPr>
+            <a:pPr marL="274320" indent="-274320">
               <a:spcAft>
                 <a:spcPts val="500"/>
               </a:spcAft>
@@ -5538,7 +5543,7 @@
             </a:r>
           </a:p>
           <a:p>
-            <a:pPr>
+            <a:pPr marL="548640" indent="0">
               <a:spcAft>
                 <a:spcPts val="500"/>
               </a:spcAft>
@@ -5548,11 +5553,11 @@
                 <a:latin typeface="+mn-lt"/>
                 <a:ea typeface="+mn-ea"/>
               </a:rPr>
-              <a:t>　　「何も無い」＝探している天体が無い。背景の光（ガス・ICS・遠い銀河）はどこにでもある → だから係数を合わせる</a:t>
-            </a:r>
-          </a:p>
-          <a:p>
-            <a:pPr>
+              <a:t>「何も無い」＝探している天体が無い。背景の光（ガス・ICS・遠い銀河）はどこにでもある → だから係数を合わせる</a:t>
+            </a:r>
+          </a:p>
+          <a:p>
+            <a:pPr marL="274320" indent="-274320">
               <a:spcAft>
                 <a:spcPts val="500"/>
               </a:spcAft>
@@ -5566,7 +5571,7 @@
             </a:r>
           </a:p>
           <a:p>
-            <a:pPr>
+            <a:pPr marL="548640" indent="0">
               <a:spcAft>
                 <a:spcPts val="500"/>
               </a:spcAft>
@@ -5576,11 +5581,11 @@
                 <a:latin typeface="+mn-lt"/>
                 <a:ea typeface="+mn-ea"/>
               </a:rPr>
-              <a:t>　　→ 計算のやり方そのものは正しい</a:t>
-            </a:r>
-          </a:p>
-          <a:p>
-            <a:pPr>
+              <a:t>→ 計算のやり方そのものは正しい</a:t>
+            </a:r>
+          </a:p>
+          <a:p>
+            <a:pPr marL="274320" indent="-274320">
               <a:spcAft>
                 <a:spcPts val="500"/>
               </a:spcAft>
@@ -5594,7 +5599,7 @@
             </a:r>
           </a:p>
           <a:p>
-            <a:pPr>
+            <a:pPr marL="548640" indent="0">
               <a:spcAft>
                 <a:spcPts val="500"/>
               </a:spcAft>
@@ -5604,11 +5609,11 @@
                 <a:latin typeface="+mn-lt"/>
                 <a:ea typeface="+mn-ea"/>
               </a:rPr>
-              <a:t>　　型紙のずれ・まだ見つかっていない暗い天体</a:t>
-            </a:r>
-          </a:p>
-          <a:p>
-            <a:pPr>
+              <a:t>型紙のずれ・まだ見つかっていない暗い天体</a:t>
+            </a:r>
+          </a:p>
+          <a:p>
+            <a:pPr marL="274320" indent="-274320">
               <a:spcAft>
                 <a:spcPts val="500"/>
               </a:spcAft>
@@ -5685,7 +5690,7 @@
                 <a:latin typeface="+mj-lt"/>
                 <a:ea typeface="+mj-ea"/>
               </a:rPr>
-              <a:t>先週の疑問③：何も無い空で、係数は変になっていない？</a:t>
+              <a:t>疑問③：何も無い空で、係数は変になっていない？</a:t>
             </a:r>
           </a:p>
         </p:txBody>
@@ -5698,7 +5703,7 @@
         </p:nvSpPr>
         <p:spPr>
           <a:xfrm>
-            <a:off x="548640" y="1234440"/>
+            <a:off x="548640" y="1463040"/>
             <a:ext cx="11155680" cy="2103120"/>
           </a:xfrm>
           <a:prstGeom prst="rect">
@@ -5712,7 +5717,7 @@
           </a:bodyPr>
           <a:lstStyle/>
           <a:p>
-            <a:pPr>
+            <a:pPr marL="274320" indent="-274320">
               <a:spcAft>
                 <a:spcPts val="500"/>
               </a:spcAft>
@@ -5726,7 +5731,7 @@
             </a:r>
           </a:p>
           <a:p>
-            <a:pPr>
+            <a:pPr marL="274320" indent="-274320">
               <a:spcAft>
                 <a:spcPts val="500"/>
               </a:spcAft>
@@ -5740,7 +5745,7 @@
             </a:r>
           </a:p>
           <a:p>
-            <a:pPr>
+            <a:pPr marL="274320" indent="-274320">
               <a:spcAft>
                 <a:spcPts val="500"/>
               </a:spcAft>
@@ -5754,7 +5759,7 @@
             </a:r>
           </a:p>
           <a:p>
-            <a:pPr>
+            <a:pPr marL="274320" indent="-274320">
               <a:spcAft>
                 <a:spcPts val="500"/>
               </a:spcAft>
@@ -5785,8 +5790,8 @@
         </p:blipFill>
         <p:spPr>
           <a:xfrm>
-            <a:off x="1097280" y="3429000"/>
-            <a:ext cx="9875520" cy="3385893"/>
+            <a:off x="1463040" y="3611880"/>
+            <a:ext cx="9334500" cy="3200400"/>
           </a:xfrm>
           <a:prstGeom prst="rect">
             <a:avLst/>
@@ -5831,7 +5836,7 @@
                 <a:latin typeface="+mj-lt"/>
                 <a:ea typeface="+mj-ea"/>
               </a:rPr>
-              <a:t>先週の疑問④：ICS とハローは本当に似ている？ガスの方が似てない？</a:t>
+              <a:t>疑問④：ICS とハローは本当に似ている？</a:t>
             </a:r>
           </a:p>
         </p:txBody>
@@ -5844,7 +5849,7 @@
         </p:nvSpPr>
         <p:spPr>
           <a:xfrm>
-            <a:off x="548640" y="1234440"/>
+            <a:off x="548640" y="1463040"/>
             <a:ext cx="11155680" cy="2286000"/>
           </a:xfrm>
           <a:prstGeom prst="rect">
@@ -5858,7 +5863,7 @@
           </a:bodyPr>
           <a:lstStyle/>
           <a:p>
-            <a:pPr>
+            <a:pPr marL="274320" indent="-274320">
               <a:spcAft>
                 <a:spcPts val="500"/>
               </a:spcAft>
@@ -5872,7 +5877,7 @@
             </a:r>
           </a:p>
           <a:p>
-            <a:pPr>
+            <a:pPr marL="274320" indent="-274320">
               <a:spcAft>
                 <a:spcPts val="500"/>
               </a:spcAft>
@@ -5886,7 +5891,7 @@
             </a:r>
           </a:p>
           <a:p>
-            <a:pPr>
+            <a:pPr marL="274320" indent="-274320">
               <a:spcAft>
                 <a:spcPts val="500"/>
               </a:spcAft>
@@ -5900,7 +5905,7 @@
             </a:r>
           </a:p>
           <a:p>
-            <a:pPr>
+            <a:pPr marL="274320" indent="-274320">
               <a:spcAft>
                 <a:spcPts val="500"/>
               </a:spcAft>
@@ -5931,8 +5936,8 @@
         </p:blipFill>
         <p:spPr>
           <a:xfrm>
-            <a:off x="1280160" y="3520440"/>
-            <a:ext cx="9509760" cy="3622766"/>
+            <a:off x="1828800" y="3703320"/>
+            <a:ext cx="8041005" cy="3063240"/>
           </a:xfrm>
           <a:prstGeom prst="rect">
             <a:avLst/>
@@ -5977,7 +5982,7 @@
                 <a:latin typeface="+mj-lt"/>
                 <a:ea typeface="+mj-ea"/>
               </a:rPr>
-              <a:t>矮小銀河：このやり方で当てはめていいのか（標準の方法と比べる）</a:t>
+              <a:t>疑問⑤：矮小銀河にこのやり方を使っていい？</a:t>
             </a:r>
           </a:p>
         </p:txBody>
@@ -5991,7 +5996,7 @@
           <p:nvPr/>
         </p:nvGraphicFramePr>
         <p:xfrm>
-          <a:off x="457200" y="1280160"/>
+          <a:off x="457200" y="1463040"/>
           <a:ext cx="11247120" cy="2057400"/>
         </p:xfrm>
         <a:graphic>
@@ -6267,7 +6272,7 @@
         </p:nvSpPr>
         <p:spPr>
           <a:xfrm>
-            <a:off x="548640" y="3840480"/>
+            <a:off x="548640" y="4023360"/>
             <a:ext cx="11155680" cy="2194560"/>
           </a:xfrm>
           <a:prstGeom prst="rect">
@@ -6281,7 +6286,7 @@
           </a:bodyPr>
           <a:lstStyle/>
           <a:p>
-            <a:pPr>
+            <a:pPr marL="274320" indent="-274320">
               <a:spcAft>
                 <a:spcPts val="500"/>
               </a:spcAft>
@@ -6295,7 +6300,7 @@
             </a:r>
           </a:p>
           <a:p>
-            <a:pPr>
+            <a:pPr marL="274320" indent="-274320">
               <a:spcAft>
                 <a:spcPts val="500"/>
               </a:spcAft>
@@ -6309,7 +6314,7 @@
             </a:r>
           </a:p>
           <a:p>
-            <a:pPr>
+            <a:pPr marL="274320" indent="-274320">
               <a:spcAft>
                 <a:spcPts val="500"/>
               </a:spcAft>
@@ -6375,7 +6380,7 @@
         </p:nvSpPr>
         <p:spPr>
           <a:xfrm>
-            <a:off x="731520" y="1371600"/>
+            <a:off x="731520" y="1554480"/>
             <a:ext cx="3840480" cy="1280160"/>
           </a:xfrm>
           <a:prstGeom prst="roundRect">
@@ -6430,7 +6435,7 @@
         </p:nvSpPr>
         <p:spPr>
           <a:xfrm>
-            <a:off x="7589520" y="1371600"/>
+            <a:off x="7589520" y="1554480"/>
             <a:ext cx="3840480" cy="1280160"/>
           </a:xfrm>
           <a:prstGeom prst="roundRect">
@@ -6485,7 +6490,7 @@
         </p:nvSpPr>
         <p:spPr>
           <a:xfrm>
-            <a:off x="4754880" y="1737360"/>
+            <a:off x="4754880" y="1920240"/>
             <a:ext cx="2651760" cy="548640"/>
           </a:xfrm>
           <a:prstGeom prst="leftRightArrow">
@@ -6528,8 +6533,8 @@
         </p:nvSpPr>
         <p:spPr>
           <a:xfrm>
-            <a:off x="548640" y="2926080"/>
-            <a:ext cx="11155680" cy="3200400"/>
+            <a:off x="548640" y="3108960"/>
+            <a:ext cx="11155680" cy="3474720"/>
           </a:xfrm>
           <a:prstGeom prst="rect">
             <a:avLst/>
@@ -6542,7 +6547,7 @@
           </a:bodyPr>
           <a:lstStyle/>
           <a:p>
-            <a:pPr>
+            <a:pPr marL="274320" indent="-274320">
               <a:spcAft>
                 <a:spcPts val="500"/>
               </a:spcAft>
@@ -6556,7 +6561,7 @@
             </a:r>
           </a:p>
           <a:p>
-            <a:pPr>
+            <a:pPr marL="274320" indent="-274320">
               <a:spcAft>
                 <a:spcPts val="500"/>
               </a:spcAft>
@@ -6570,7 +6575,7 @@
             </a:r>
           </a:p>
           <a:p>
-            <a:pPr>
+            <a:pPr marL="274320" indent="-274320">
               <a:spcAft>
                 <a:spcPts val="500"/>
               </a:spcAft>
@@ -6584,7 +6589,21 @@
             </a:r>
           </a:p>
           <a:p>
-            <a:pPr>
+            <a:pPr marL="548640" indent="0">
+              <a:spcAft>
+                <a:spcPts val="500"/>
+              </a:spcAft>
+            </a:pPr>
+            <a:r>
+              <a:rPr sz="1500" b="0" lang="ja-JP">
+                <a:latin typeface="+mn-lt"/>
+                <a:ea typeface="+mn-ea"/>
+              </a:rPr>
+              <a:t>たとえ：宝の地図の「ここに 10 個」が 3 個の間違いかもしれない。掘って 0 個でも、宝が無いとは言い切れない</a:t>
+            </a:r>
+          </a:p>
+          <a:p>
+            <a:pPr marL="274320" indent="-274320">
               <a:spcAft>
                 <a:spcPts val="500"/>
               </a:spcAft>
@@ -6650,7 +6669,7 @@
         </p:nvSpPr>
         <p:spPr>
           <a:xfrm>
-            <a:off x="548640" y="1280160"/>
+            <a:off x="548640" y="1463040"/>
             <a:ext cx="11155680" cy="2377440"/>
           </a:xfrm>
           <a:prstGeom prst="rect">
@@ -6664,7 +6683,7 @@
           </a:bodyPr>
           <a:lstStyle/>
           <a:p>
-            <a:pPr>
+            <a:pPr marL="274320" indent="-274320">
               <a:spcAft>
                 <a:spcPts val="500"/>
               </a:spcAft>
@@ -6678,7 +6697,7 @@
             </a:r>
           </a:p>
           <a:p>
-            <a:pPr>
+            <a:pPr marL="274320" indent="-274320">
               <a:spcAft>
                 <a:spcPts val="500"/>
               </a:spcAft>
@@ -6692,7 +6711,7 @@
             </a:r>
           </a:p>
           <a:p>
-            <a:pPr>
+            <a:pPr marL="274320" indent="-274320">
               <a:spcAft>
                 <a:spcPts val="500"/>
               </a:spcAft>
@@ -6706,7 +6725,7 @@
             </a:r>
           </a:p>
           <a:p>
-            <a:pPr>
+            <a:pPr marL="274320" indent="-274320">
               <a:spcAft>
                 <a:spcPts val="500"/>
               </a:spcAft>

</xml_diff>

<commit_message>
slides: 本人の編集版を更新 (10-05 18:13)
</commit_message>
<xml_diff>
--- a/slides/2026-10-09_研究報告_10枚版.pptx
+++ b/slides/2026-10-09_研究報告_10枚版.pptx
@@ -1376,7 +1376,7 @@
           <a:lstStyle/>
           <a:p>
             <a:r>
-              <a:t>results/targets_v20_totani_fixneg_irf の control_*_spectrum.json の f_other (ハローありの最良値) と f_halo。20.8 GeV: ガス中央値 1.12、点源 0.99、ハロー (光子換算) 中央値 −0.85、範囲 −6.4〜+11.7、負が 52%。ビン 2〜10 で ガス・ICS・点源が下限 0 に張り付いた件数は 0。ハローの係数が負になれるのは、あるか分からないものを探すので偏りを作らないため (Totani §2.3)。予測の光子数が負になる組は選ばない規則にしている。</a:t>
+              <a:t>results/targets_v20_totani_fixneg_irf の control_*_spectrum.json の f_other (ハローありの最良値) と f_halo。20.8 GeV: ガス中央値 1.12、点源 0.99、ハロー (光子換算) 中央値 −0.85、範囲 −6.4〜+11.7、負が 52%。全 299 件 (23 か所 × 13 ビン) で、ガス・ICS・点源が下限 0 に張り付いた件数は 0。等方だけ、光子が 2〜13 個しかない最高 2 ビン (300 GeV 以上) で 5 件が 0 に張り付いた。ガスは 20.8 GeV でも 4 か所が 0.02〜0.06 と小さい (高緯度でガスが薄い所)。ICS は 20.8 GeV で 0.2〜5、全ビンでは最大 28、ガスは最大 17 (どちらも光子が数個〜数十個のビン)。これは背景どうしの形が似ていて分け方が決まらないため。それでも何も無い空の σ の分布は平均 +0.08 で、ハローの判定に片寄りは出ていない。ハローの係数が負になれるのは、あるか分からないものを探すので偏りを作らないため (Totani §2.3)。予測の光子数が負になる組は選ばない規則にしている。</a:t>
             </a:r>
           </a:p>
         </p:txBody>
@@ -5727,7 +5727,7 @@
                 <a:latin typeface="+mn-lt"/>
                 <a:ea typeface="+mn-ea"/>
               </a:rPr>
-              <a:t>・ガス：真ん中 1.1、点源：真ん中 1.0（どちらも予想どおりなら 1）</a:t>
+              <a:t>・20.8 GeV で、ガス：真ん中 1.1、点源：真ん中 1.0（予想どおりなら 1）</a:t>
             </a:r>
           </a:p>
           <a:p>
@@ -5737,11 +5737,11 @@
               </a:spcAft>
             </a:pPr>
             <a:r>
-              <a:rPr sz="1700" b="0" lang="ja-JP">
+              <a:rPr sz="1700" b="1" lang="ja-JP">
                 <a:latin typeface="+mn-lt"/>
                 <a:ea typeface="+mn-ea"/>
               </a:rPr>
-              <a:t>・ハロー：0 のまわりでプラス・マイナスがほぼ半々（光子 −6〜+12 個分）→ 片寄りなし</a:t>
+              <a:t>・ハロー：0 のまわりでプラス・マイナスがほぼ半々 → 片寄りなし</a:t>
             </a:r>
           </a:p>
           <a:p>
@@ -5751,11 +5751,11 @@
               </a:spcAft>
             </a:pPr>
             <a:r>
-              <a:rPr sz="1700" b="1" lang="ja-JP">
+              <a:rPr sz="1700" b="0" lang="ja-JP">
                 <a:latin typeface="+mn-lt"/>
                 <a:ea typeface="+mn-ea"/>
               </a:rPr>
-              <a:t>・0 に張り付いたり、とんでもない値になったものは無い（23 か所 × 13 ビン ＝ 299 件すべて確認）</a:t>
+              <a:t>・ガス・ICS・等方は、狭い空では形が似ていて分け方が決まらない → 1 つずつは大きく振れる（光子が数個しかない高いエネルギーでは特に）</a:t>
             </a:r>
           </a:p>
           <a:p>
@@ -5765,11 +5765,11 @@
               </a:spcAft>
             </a:pPr>
             <a:r>
-              <a:rPr sz="1700" b="0" lang="ja-JP">
+              <a:rPr sz="1700" b="1" lang="ja-JP">
                 <a:latin typeface="+mn-lt"/>
                 <a:ea typeface="+mn-ea"/>
               </a:rPr>
-              <a:t>・ICS だけ 0.2〜5 と幅が広い：狭い範囲では等方とほぼ同じ形で、分け方が決まらないため（ハローには効かない）</a:t>
+              <a:t>・それでも何も無い空の σ は真ん中 0（疑問①の図）→ 振れても、ハローの答えは片寄らない</a:t>
             </a:r>
           </a:p>
         </p:txBody>
@@ -5915,7 +5915,21 @@
                 <a:latin typeface="+mn-lt"/>
                 <a:ea typeface="+mn-ea"/>
               </a:rPr>
-              <a:t>・横方向は違う（ICS は横に広い）→ 完全には区別できなくならず、ハローは 17.6σ で残る。バブルは似ていない（0.53）</a:t>
+              <a:t>・横方向は違う（ICS は横に広い）→ 型紙どおりなら区別でき、ハローは 17.6σ。ただし ICS が中心で 2 倍ずれていれば 5.7σ に下がる</a:t>
+            </a:r>
+          </a:p>
+          <a:p>
+            <a:pPr marL="274320" indent="-274320">
+              <a:spcAft>
+                <a:spcPts val="500"/>
+              </a:spcAft>
+            </a:pPr>
+            <a:r>
+              <a:rPr sz="1600" b="0" lang="ja-JP">
+                <a:latin typeface="+mn-lt"/>
+                <a:ea typeface="+mn-ea"/>
+              </a:rPr>
+              <a:t>・バブルはハローに似ていない（0.53）→ 先週のご指摘どおり</a:t>
             </a:r>
           </a:p>
         </p:txBody>

</xml_diff>

<commit_message>
slides: 本人の編集版を更新 (10-05 19:12)
</commit_message>
<xml_diff>
--- a/slides/2026-10-09_研究報告_10枚版.pptx
+++ b/slides/2026-10-09_研究報告_10枚版.pptx
@@ -1236,7 +1236,7 @@
           <a:lstStyle/>
           <a:p>
             <a:r>
-              <a:t>何も無い空 23 か所 × ビン 2〜10 (207 個): 平均 +0.08、ばらつき 1.19。平均が 0 からずれていない (＝引く量は無い) のに、幅が広い (＝割る量がある)。定義: 較正後の σ ＝ 名目の σ ÷ 1.2〜1.3。同じことを『名目 5 × 1.2〜1.3 ≈ 6〜6.5σ 以上を本当の 5σ とみなす』と言い換えられる。限界: 23 か所 (207 個) では 3σ くらいまでの分布しか見えない。17σ のような大きい値でも同じ倍率かは仮定。標準の方法: McDaniel ほか (2024, arXiv:2311.04982) とその更新 (2026, arXiv:2605.25586) は、高緯度の何も無い方向 6,500 か所を解析し、その結果の分布で『信号が無いときの分布』を決めて有意度を出す。理由は『名目の計算は背景モデルのずれや見えない天体を考えていないので、信号が無い場合の分布として不十分』。</a:t>
+              <a:t>何も無い空 23 か所 × ビン 2〜10 (207 個): 平均 +0.08、ばらつき 1.19。平均が 0 からずれていない (＝引く量は無い) のに、幅が広い (＝割る量がある)。定義: 較正後の σ ＝ 名目の σ ÷ 1.2〜1.3。同じことを『名目 5 × 1.2〜1.3 ≈ 6〜6.5σ 以上を本当の 5σ とみなす』と言い換えられる。限界: 23 か所 (207 個) では 3σ くらいまでの分布しか見えない。17σ のような大きい値でも同じ倍率かは仮定。追加 (10/5 夜): 別の乱数で 23 か所の組を 3 つ作り直し、計 92 か所。20.8 GeV のばらつき 1.235 (天体単位ブートストラップ 68%: 1.15〜1.32)、ビン 2〜10 で 1.14。組ごと: 元 1.26、追加 1.32 / 1.20 / 1.16。新しい組は元の組と中心が 7° 程度しか離れない所が多く (空の広さの限界)、独立な 92 か所ではない。だから幅は少し狭く見えている。較正後の 20.8 GeV: 17.6 ÷ 1.235 = 14.2σ (13.3〜15.3σ)。results/control_spread_all_sets/summary.json標準の方法: McDaniel ほか (2024, arXiv:2311.04982) とその更新 (2026, arXiv:2605.25586) は、高緯度の何も無い方向 6,500 か所を解析し、その結果の分布で『信号が無いときの分布』を決めて有意度を出す。理由は『名目の計算は背景モデルのずれや見えない天体を考えていないので、信号が無い場合の分布として不十分』。</a:t>
             </a:r>
           </a:p>
         </p:txBody>
@@ -5041,7 +5041,7 @@
                 <a:latin typeface="+mn-lt"/>
                 <a:ea typeface="+mn-ea"/>
               </a:rPr>
-              <a:t>・何も無い空を 23 → 数百か所に増やす（標準は 6,500 か所）</a:t>
+              <a:t>・何も無い空は 92 か所で 1.24 倍を確認。でも 17σ のような大きい値で同じ倍率かは、まだ仮定</a:t>
             </a:r>
           </a:p>
           <a:p>
@@ -5624,6 +5624,20 @@
                 <a:ea typeface="+mn-ea"/>
               </a:rPr>
               <a:t>・本物の空を使うのは、それを測るため（Fermi チームの標準と同じ）</a:t>
+            </a:r>
+          </a:p>
+          <a:p>
+            <a:pPr marL="274320" indent="-274320">
+              <a:spcAft>
+                <a:spcPts val="500"/>
+              </a:spcAft>
+            </a:pPr>
+            <a:r>
+              <a:rPr sz="1700" b="1" lang="ja-JP">
+                <a:latin typeface="+mn-lt"/>
+                <a:ea typeface="+mn-ea"/>
+              </a:rPr>
+              <a:t>・置き方を変えて 92 か所に増やしても、20.8 GeV で 1.24 倍（1.15〜1.32）→ 変わらない</a:t>
             </a:r>
           </a:p>
         </p:txBody>

</xml_diff>

<commit_message>
slides: 本人の編集版を更新 (10-06 14:49)
</commit_message>
<xml_diff>
--- a/slides/2026-10-09_研究報告_10枚版.pptx
+++ b/slides/2026-10-09_研究報告_10枚版.pptx
@@ -5,19 +5,19 @@
     <p:sldMasterId id="2147483648" r:id="rId1"/>
   </p:sldMasterIdLst>
   <p:notesMasterIdLst>
-    <p:notesMasterId r:id="rId53"/>
+    <p:notesMasterId r:id="rId12"/>
   </p:notesMasterIdLst>
   <p:sldIdLst>
-    <p:sldId id="256" r:id="rId9"/>
-    <p:sldId id="257" r:id="rId10"/>
-    <p:sldId id="258" r:id="rId11"/>
-    <p:sldId id="259" r:id="rId12"/>
-    <p:sldId id="260" r:id="rId13"/>
-    <p:sldId id="261" r:id="rId14"/>
-    <p:sldId id="262" r:id="rId15"/>
-    <p:sldId id="263" r:id="rId16"/>
-    <p:sldId id="264" r:id="rId17"/>
-    <p:sldId id="265" r:id="rId18"/>
+    <p:sldId id="256" r:id="rId2"/>
+    <p:sldId id="257" r:id="rId3"/>
+    <p:sldId id="258" r:id="rId4"/>
+    <p:sldId id="259" r:id="rId5"/>
+    <p:sldId id="260" r:id="rId6"/>
+    <p:sldId id="261" r:id="rId7"/>
+    <p:sldId id="262" r:id="rId8"/>
+    <p:sldId id="263" r:id="rId9"/>
+    <p:sldId id="264" r:id="rId10"/>
+    <p:sldId id="265" r:id="rId11"/>
   </p:sldIdLst>
   <p:sldSz cx="12192000" cy="6858000"/>
   <p:notesSz cx="6858000" cy="9144000"/>
@@ -135,29 +135,29 @@
 </p:presentation>
 </file>
 
-<file path=ppt/revisionInfo.xml><?xml version="1.0" encoding="utf-8"?>
-<p1510:revInfo xmlns:a="http://schemas.openxmlformats.org/drawingml/2006/main" xmlns:r="http://schemas.openxmlformats.org/officeDocument/2006/relationships" xmlns:p1510="http://schemas.microsoft.com/office/powerpoint/2015/10/main">
-  <p1510:revLst>
-    <p1510:client id="{00028602-DADF-4A12-9718-18B16E5CE366}" v="1" dt="2026-10-05T03:38:29.240"/>
-  </p1510:revLst>
-</p1510:revInfo>
-</file>
-
 <file path=ppt/changesInfos/changesInfo1.xml><?xml version="1.0" encoding="utf-8"?>
 <pc:chgInfo xmlns:a="http://schemas.openxmlformats.org/drawingml/2006/main" xmlns:r="http://schemas.openxmlformats.org/officeDocument/2006/relationships" xmlns:ac="http://schemas.microsoft.com/office/drawing/2013/main/command" xmlns:pc="http://schemas.microsoft.com/office/powerpoint/2013/main/command">
   <pc:docChgLst>
     <pc:chgData name="202304239" userId="ab1adf7a-b8eb-4038-b404-de23e20d8a3a" providerId="ADAL" clId="{6C0E59ED-D716-49AF-B2FA-B94E7B8E5A8C}"/>
     <pc:docChg chg="undo custSel addSld delSld modSld sldOrd">
-      <pc:chgData name="202304239" userId="ab1adf7a-b8eb-4038-b404-de23e20d8a3a" providerId="ADAL" clId="{6C0E59ED-D716-49AF-B2FA-B94E7B8E5A8C}" dt="2026-10-05T05:57:59.931" v="864" actId="20577"/>
+      <pc:chgData name="202304239" userId="ab1adf7a-b8eb-4038-b404-de23e20d8a3a" providerId="ADAL" clId="{6C0E59ED-D716-49AF-B2FA-B94E7B8E5A8C}" dt="2026-10-06T05:48:43.412" v="866" actId="20577"/>
       <pc:docMkLst>
         <pc:docMk/>
       </pc:docMkLst>
       <pc:sldChg chg="modSp mod">
-        <pc:chgData name="202304239" userId="ab1adf7a-b8eb-4038-b404-de23e20d8a3a" providerId="ADAL" clId="{6C0E59ED-D716-49AF-B2FA-B94E7B8E5A8C}" dt="2026-10-02T01:41:32.636" v="29" actId="20577"/>
+        <pc:chgData name="202304239" userId="ab1adf7a-b8eb-4038-b404-de23e20d8a3a" providerId="ADAL" clId="{6C0E59ED-D716-49AF-B2FA-B94E7B8E5A8C}" dt="2026-10-06T05:48:43.412" v="866" actId="20577"/>
         <pc:sldMkLst>
           <pc:docMk/>
           <pc:sldMk cId="0" sldId="257"/>
         </pc:sldMkLst>
+        <pc:spChg chg="mod">
+          <ac:chgData name="202304239" userId="ab1adf7a-b8eb-4038-b404-de23e20d8a3a" providerId="ADAL" clId="{6C0E59ED-D716-49AF-B2FA-B94E7B8E5A8C}" dt="2026-10-06T05:48:43.412" v="866" actId="20577"/>
+          <ac:spMkLst>
+            <pc:docMk/>
+            <pc:sldMk cId="0" sldId="257"/>
+            <ac:spMk id="2" creationId="{00000000-0000-0000-0000-000000000000}"/>
+          </ac:spMkLst>
+        </pc:spChg>
         <pc:spChg chg="mod">
           <ac:chgData name="202304239" userId="ab1adf7a-b8eb-4038-b404-de23e20d8a3a" providerId="ADAL" clId="{6C0E59ED-D716-49AF-B2FA-B94E7B8E5A8C}" dt="2026-10-02T01:41:32.636" v="29" actId="20577"/>
           <ac:spMkLst>
@@ -173,14 +173,6 @@
           <pc:docMk/>
           <pc:sldMk cId="0" sldId="258"/>
         </pc:sldMkLst>
-        <pc:spChg chg="mod">
-          <ac:chgData name="202304239" userId="ab1adf7a-b8eb-4038-b404-de23e20d8a3a" providerId="ADAL" clId="{6C0E59ED-D716-49AF-B2FA-B94E7B8E5A8C}" dt="2026-10-02T01:15:41.310" v="14" actId="1076"/>
-          <ac:spMkLst>
-            <pc:docMk/>
-            <pc:sldMk cId="0" sldId="258"/>
-            <ac:spMk id="7" creationId="{0C0F810D-B137-252F-B137-69AD8335E4B7}"/>
-          </ac:spMkLst>
-        </pc:spChg>
       </pc:sldChg>
       <pc:sldChg chg="modSp mod">
         <pc:chgData name="202304239" userId="ab1adf7a-b8eb-4038-b404-de23e20d8a3a" providerId="ADAL" clId="{6C0E59ED-D716-49AF-B2FA-B94E7B8E5A8C}" dt="2026-10-05T03:38:03.028" v="92" actId="20577"/>
@@ -369,37 +361,6 @@
             <ac:spMk id="2" creationId="{00000000-0000-0000-0000-000000000000}"/>
           </ac:spMkLst>
         </pc:spChg>
-        <pc:picChg chg="add mod">
-          <ac:chgData name="202304239" userId="ab1adf7a-b8eb-4038-b404-de23e20d8a3a" providerId="ADAL" clId="{6C0E59ED-D716-49AF-B2FA-B94E7B8E5A8C}" dt="2026-10-03T04:13:39.011" v="59" actId="27614"/>
-          <ac:picMkLst>
-            <pc:docMk/>
-            <pc:sldMk cId="0" sldId="295"/>
-            <ac:picMk id="5" creationId="{960CE5B3-4BC1-0B00-D670-CAC2F1397BD5}"/>
-          </ac:picMkLst>
-        </pc:picChg>
-      </pc:sldChg>
-      <pc:sldChg chg="addSp delSp modSp mod">
-        <pc:chgData name="202304239" userId="ab1adf7a-b8eb-4038-b404-de23e20d8a3a" providerId="ADAL" clId="{6C0E59ED-D716-49AF-B2FA-B94E7B8E5A8C}" dt="2026-10-03T04:16:37.708" v="74" actId="14100"/>
-        <pc:sldMkLst>
-          <pc:docMk/>
-          <pc:sldMk cId="0" sldId="296"/>
-        </pc:sldMkLst>
-        <pc:spChg chg="mod">
-          <ac:chgData name="202304239" userId="ab1adf7a-b8eb-4038-b404-de23e20d8a3a" providerId="ADAL" clId="{6C0E59ED-D716-49AF-B2FA-B94E7B8E5A8C}" dt="2026-10-03T04:16:37.708" v="74" actId="14100"/>
-          <ac:spMkLst>
-            <pc:docMk/>
-            <pc:sldMk cId="0" sldId="296"/>
-            <ac:spMk id="3" creationId="{00000000-0000-0000-0000-000000000000}"/>
-          </ac:spMkLst>
-        </pc:spChg>
-        <pc:picChg chg="add mod">
-          <ac:chgData name="202304239" userId="ab1adf7a-b8eb-4038-b404-de23e20d8a3a" providerId="ADAL" clId="{6C0E59ED-D716-49AF-B2FA-B94E7B8E5A8C}" dt="2026-10-03T04:16:30.783" v="72" actId="1076"/>
-          <ac:picMkLst>
-            <pc:docMk/>
-            <pc:sldMk cId="0" sldId="296"/>
-            <ac:picMk id="7" creationId="{DBE7D927-8B33-8CDB-1BC3-DBD46AE4DF3A}"/>
-          </ac:picMkLst>
-        </pc:picChg>
       </pc:sldChg>
       <pc:sldChg chg="addSp modSp mod">
         <pc:chgData name="202304239" userId="ab1adf7a-b8eb-4038-b404-de23e20d8a3a" providerId="ADAL" clId="{6C0E59ED-D716-49AF-B2FA-B94E7B8E5A8C}" dt="2026-10-05T05:09:57.079" v="571" actId="1076"/>
@@ -430,21 +391,6 @@
             <ac:spMk id="8" creationId="{F85CD606-E3CE-F314-B3EE-F3D7028115CB}"/>
           </ac:spMkLst>
         </pc:spChg>
-        <pc:picChg chg="add mod">
-          <ac:chgData name="202304239" userId="ab1adf7a-b8eb-4038-b404-de23e20d8a3a" providerId="ADAL" clId="{6C0E59ED-D716-49AF-B2FA-B94E7B8E5A8C}" dt="2026-10-03T06:10:08.014" v="80" actId="27614"/>
-          <ac:picMkLst>
-            <pc:docMk/>
-            <pc:sldMk cId="0" sldId="299"/>
-            <ac:picMk id="5" creationId="{4380DBC0-9AA7-8727-D6C3-C05AE0BF39C9}"/>
-          </ac:picMkLst>
-        </pc:picChg>
-      </pc:sldChg>
-      <pc:sldChg chg="addSp delSp modSp mod">
-        <pc:chgData name="202304239" userId="ab1adf7a-b8eb-4038-b404-de23e20d8a3a" providerId="ADAL" clId="{6C0E59ED-D716-49AF-B2FA-B94E7B8E5A8C}" dt="2026-10-03T06:10:09.262" v="81" actId="478"/>
-        <pc:sldMkLst>
-          <pc:docMk/>
-          <pc:sldMk cId="0" sldId="300"/>
-        </pc:sldMkLst>
       </pc:sldChg>
       <pc:sldChg chg="addSp modSp mod">
         <pc:chgData name="202304239" userId="ab1adf7a-b8eb-4038-b404-de23e20d8a3a" providerId="ADAL" clId="{6C0E59ED-D716-49AF-B2FA-B94E7B8E5A8C}" dt="2026-10-05T03:47:04.200" v="139" actId="1076"/>
@@ -709,7 +655,7 @@
           <a:p>
             <a:fld id="{B414FD46-9C41-4E77-8212-EE695A2FE528}" type="datetimeFigureOut">
               <a:rPr lang="en-US" smtClean="0"/>
-              <a:t>10/5/2026</a:t>
+              <a:t>10/6/2026</a:t>
             </a:fld>
             <a:endParaRPr lang="en-US"/>
           </a:p>
@@ -977,7 +923,7 @@
 </file>
 
 <file path=ppt/notesSlides/notesSlide1.xml><?xml version="1.0" encoding="utf-8"?>
-<p:notes xmlns:a="http://schemas.openxmlformats.org/drawingml/2006/main" xmlns:p="http://schemas.openxmlformats.org/presentationml/2006/main" xmlns:r="http://schemas.openxmlformats.org/officeDocument/2006/relationships">
+<p:notes xmlns:a="http://schemas.openxmlformats.org/drawingml/2006/main" xmlns:r="http://schemas.openxmlformats.org/officeDocument/2006/relationships" xmlns:p="http://schemas.openxmlformats.org/presentationml/2006/main">
   <p:cSld>
     <p:spTree>
       <p:nvGrpSpPr>
@@ -997,7 +943,7 @@
         <p:nvSpPr>
           <p:cNvPr id="2" name="Slide Image Placeholder 1"/>
           <p:cNvSpPr>
-            <a:spLocks noGrp="1"/>
+            <a:spLocks noGrp="1" noRot="1" noChangeAspect="1"/>
           </p:cNvSpPr>
           <p:nvPr>
             <p:ph type="sldImg" idx="2"/>
@@ -1012,7 +958,7 @@
             <a:spLocks noGrp="1"/>
           </p:cNvSpPr>
           <p:nvPr>
-            <p:ph type="body" idx="3" sz="quarter"/>
+            <p:ph type="body" sz="quarter" idx="3"/>
           </p:nvPr>
         </p:nvSpPr>
         <p:spPr/>
@@ -1033,7 +979,7 @@
             <a:spLocks noGrp="1"/>
           </p:cNvSpPr>
           <p:nvPr>
-            <p:ph type="sldNum" idx="5" sz="quarter"/>
+            <p:ph type="sldNum" sz="quarter" idx="5"/>
           </p:nvPr>
         </p:nvSpPr>
         <p:spPr/>
@@ -1047,7 +993,7 @@
 </file>
 
 <file path=ppt/notesSlides/notesSlide10.xml><?xml version="1.0" encoding="utf-8"?>
-<p:notes xmlns:a="http://schemas.openxmlformats.org/drawingml/2006/main" xmlns:p="http://schemas.openxmlformats.org/presentationml/2006/main" xmlns:r="http://schemas.openxmlformats.org/officeDocument/2006/relationships">
+<p:notes xmlns:a="http://schemas.openxmlformats.org/drawingml/2006/main" xmlns:r="http://schemas.openxmlformats.org/officeDocument/2006/relationships" xmlns:p="http://schemas.openxmlformats.org/presentationml/2006/main">
   <p:cSld>
     <p:spTree>
       <p:nvGrpSpPr>
@@ -1067,7 +1013,7 @@
         <p:nvSpPr>
           <p:cNvPr id="2" name="Slide Image Placeholder 1"/>
           <p:cNvSpPr>
-            <a:spLocks noGrp="1"/>
+            <a:spLocks noGrp="1" noRot="1" noChangeAspect="1"/>
           </p:cNvSpPr>
           <p:nvPr>
             <p:ph type="sldImg" idx="2"/>
@@ -1082,7 +1028,7 @@
             <a:spLocks noGrp="1"/>
           </p:cNvSpPr>
           <p:nvPr>
-            <p:ph type="body" idx="3" sz="quarter"/>
+            <p:ph type="body" sz="quarter" idx="3"/>
           </p:nvPr>
         </p:nvSpPr>
         <p:spPr/>
@@ -1103,7 +1049,7 @@
             <a:spLocks noGrp="1"/>
           </p:cNvSpPr>
           <p:nvPr>
-            <p:ph type="sldNum" idx="5" sz="quarter"/>
+            <p:ph type="sldNum" sz="quarter" idx="5"/>
           </p:nvPr>
         </p:nvSpPr>
         <p:spPr/>
@@ -1117,7 +1063,7 @@
 </file>
 
 <file path=ppt/notesSlides/notesSlide2.xml><?xml version="1.0" encoding="utf-8"?>
-<p:notes xmlns:a="http://schemas.openxmlformats.org/drawingml/2006/main" xmlns:p="http://schemas.openxmlformats.org/presentationml/2006/main" xmlns:r="http://schemas.openxmlformats.org/officeDocument/2006/relationships">
+<p:notes xmlns:a="http://schemas.openxmlformats.org/drawingml/2006/main" xmlns:r="http://schemas.openxmlformats.org/officeDocument/2006/relationships" xmlns:p="http://schemas.openxmlformats.org/presentationml/2006/main">
   <p:cSld>
     <p:spTree>
       <p:nvGrpSpPr>
@@ -1137,7 +1083,7 @@
         <p:nvSpPr>
           <p:cNvPr id="2" name="Slide Image Placeholder 1"/>
           <p:cNvSpPr>
-            <a:spLocks noGrp="1"/>
+            <a:spLocks noGrp="1" noRot="1" noChangeAspect="1"/>
           </p:cNvSpPr>
           <p:nvPr>
             <p:ph type="sldImg" idx="2"/>
@@ -1152,7 +1098,7 @@
             <a:spLocks noGrp="1"/>
           </p:cNvSpPr>
           <p:nvPr>
-            <p:ph type="body" idx="3" sz="quarter"/>
+            <p:ph type="body" sz="quarter" idx="3"/>
           </p:nvPr>
         </p:nvSpPr>
         <p:spPr/>
@@ -1178,7 +1124,7 @@
             <a:spLocks noGrp="1"/>
           </p:cNvSpPr>
           <p:nvPr>
-            <p:ph type="sldNum" idx="5" sz="quarter"/>
+            <p:ph type="sldNum" sz="quarter" idx="5"/>
           </p:nvPr>
         </p:nvSpPr>
         <p:spPr/>
@@ -1192,7 +1138,7 @@
 </file>
 
 <file path=ppt/notesSlides/notesSlide3.xml><?xml version="1.0" encoding="utf-8"?>
-<p:notes xmlns:a="http://schemas.openxmlformats.org/drawingml/2006/main" xmlns:p="http://schemas.openxmlformats.org/presentationml/2006/main" xmlns:r="http://schemas.openxmlformats.org/officeDocument/2006/relationships">
+<p:notes xmlns:a="http://schemas.openxmlformats.org/drawingml/2006/main" xmlns:r="http://schemas.openxmlformats.org/officeDocument/2006/relationships" xmlns:p="http://schemas.openxmlformats.org/presentationml/2006/main">
   <p:cSld>
     <p:spTree>
       <p:nvGrpSpPr>
@@ -1212,7 +1158,7 @@
         <p:nvSpPr>
           <p:cNvPr id="2" name="Slide Image Placeholder 1"/>
           <p:cNvSpPr>
-            <a:spLocks noGrp="1"/>
+            <a:spLocks noGrp="1" noRot="1" noChangeAspect="1"/>
           </p:cNvSpPr>
           <p:nvPr>
             <p:ph type="sldImg" idx="2"/>
@@ -1227,7 +1173,7 @@
             <a:spLocks noGrp="1"/>
           </p:cNvSpPr>
           <p:nvPr>
-            <p:ph type="body" idx="3" sz="quarter"/>
+            <p:ph type="body" sz="quarter" idx="3"/>
           </p:nvPr>
         </p:nvSpPr>
         <p:spPr/>
@@ -1248,7 +1194,7 @@
             <a:spLocks noGrp="1"/>
           </p:cNvSpPr>
           <p:nvPr>
-            <p:ph type="sldNum" idx="5" sz="quarter"/>
+            <p:ph type="sldNum" sz="quarter" idx="5"/>
           </p:nvPr>
         </p:nvSpPr>
         <p:spPr/>
@@ -1262,7 +1208,7 @@
 </file>
 
 <file path=ppt/notesSlides/notesSlide4.xml><?xml version="1.0" encoding="utf-8"?>
-<p:notes xmlns:a="http://schemas.openxmlformats.org/drawingml/2006/main" xmlns:p="http://schemas.openxmlformats.org/presentationml/2006/main" xmlns:r="http://schemas.openxmlformats.org/officeDocument/2006/relationships">
+<p:notes xmlns:a="http://schemas.openxmlformats.org/drawingml/2006/main" xmlns:r="http://schemas.openxmlformats.org/officeDocument/2006/relationships" xmlns:p="http://schemas.openxmlformats.org/presentationml/2006/main">
   <p:cSld>
     <p:spTree>
       <p:nvGrpSpPr>
@@ -1282,7 +1228,7 @@
         <p:nvSpPr>
           <p:cNvPr id="2" name="Slide Image Placeholder 1"/>
           <p:cNvSpPr>
-            <a:spLocks noGrp="1"/>
+            <a:spLocks noGrp="1" noRot="1" noChangeAspect="1"/>
           </p:cNvSpPr>
           <p:nvPr>
             <p:ph type="sldImg" idx="2"/>
@@ -1297,7 +1243,7 @@
             <a:spLocks noGrp="1"/>
           </p:cNvSpPr>
           <p:nvPr>
-            <p:ph type="body" idx="3" sz="quarter"/>
+            <p:ph type="body" sz="quarter" idx="3"/>
           </p:nvPr>
         </p:nvSpPr>
         <p:spPr/>
@@ -1318,7 +1264,7 @@
             <a:spLocks noGrp="1"/>
           </p:cNvSpPr>
           <p:nvPr>
-            <p:ph type="sldNum" idx="5" sz="quarter"/>
+            <p:ph type="sldNum" sz="quarter" idx="5"/>
           </p:nvPr>
         </p:nvSpPr>
         <p:spPr/>
@@ -1332,7 +1278,7 @@
 </file>
 
 <file path=ppt/notesSlides/notesSlide5.xml><?xml version="1.0" encoding="utf-8"?>
-<p:notes xmlns:a="http://schemas.openxmlformats.org/drawingml/2006/main" xmlns:p="http://schemas.openxmlformats.org/presentationml/2006/main" xmlns:r="http://schemas.openxmlformats.org/officeDocument/2006/relationships">
+<p:notes xmlns:a="http://schemas.openxmlformats.org/drawingml/2006/main" xmlns:r="http://schemas.openxmlformats.org/officeDocument/2006/relationships" xmlns:p="http://schemas.openxmlformats.org/presentationml/2006/main">
   <p:cSld>
     <p:spTree>
       <p:nvGrpSpPr>
@@ -1352,7 +1298,7 @@
         <p:nvSpPr>
           <p:cNvPr id="2" name="Slide Image Placeholder 1"/>
           <p:cNvSpPr>
-            <a:spLocks noGrp="1"/>
+            <a:spLocks noGrp="1" noRot="1" noChangeAspect="1"/>
           </p:cNvSpPr>
           <p:nvPr>
             <p:ph type="sldImg" idx="2"/>
@@ -1367,7 +1313,7 @@
             <a:spLocks noGrp="1"/>
           </p:cNvSpPr>
           <p:nvPr>
-            <p:ph type="body" idx="3" sz="quarter"/>
+            <p:ph type="body" sz="quarter" idx="3"/>
           </p:nvPr>
         </p:nvSpPr>
         <p:spPr/>
@@ -1388,7 +1334,7 @@
             <a:spLocks noGrp="1"/>
           </p:cNvSpPr>
           <p:nvPr>
-            <p:ph type="sldNum" idx="5" sz="quarter"/>
+            <p:ph type="sldNum" sz="quarter" idx="5"/>
           </p:nvPr>
         </p:nvSpPr>
         <p:spPr/>
@@ -1402,7 +1348,7 @@
 </file>
 
 <file path=ppt/notesSlides/notesSlide6.xml><?xml version="1.0" encoding="utf-8"?>
-<p:notes xmlns:a="http://schemas.openxmlformats.org/drawingml/2006/main" xmlns:p="http://schemas.openxmlformats.org/presentationml/2006/main" xmlns:r="http://schemas.openxmlformats.org/officeDocument/2006/relationships">
+<p:notes xmlns:a="http://schemas.openxmlformats.org/drawingml/2006/main" xmlns:r="http://schemas.openxmlformats.org/officeDocument/2006/relationships" xmlns:p="http://schemas.openxmlformats.org/presentationml/2006/main">
   <p:cSld>
     <p:spTree>
       <p:nvGrpSpPr>
@@ -1422,7 +1368,7 @@
         <p:nvSpPr>
           <p:cNvPr id="2" name="Slide Image Placeholder 1"/>
           <p:cNvSpPr>
-            <a:spLocks noGrp="1"/>
+            <a:spLocks noGrp="1" noRot="1" noChangeAspect="1"/>
           </p:cNvSpPr>
           <p:nvPr>
             <p:ph type="sldImg" idx="2"/>
@@ -1437,7 +1383,7 @@
             <a:spLocks noGrp="1"/>
           </p:cNvSpPr>
           <p:nvPr>
-            <p:ph type="body" idx="3" sz="quarter"/>
+            <p:ph type="body" sz="quarter" idx="3"/>
           </p:nvPr>
         </p:nvSpPr>
         <p:spPr/>
@@ -1458,7 +1404,7 @@
             <a:spLocks noGrp="1"/>
           </p:cNvSpPr>
           <p:nvPr>
-            <p:ph type="sldNum" idx="5" sz="quarter"/>
+            <p:ph type="sldNum" sz="quarter" idx="5"/>
           </p:nvPr>
         </p:nvSpPr>
         <p:spPr/>
@@ -1472,7 +1418,7 @@
 </file>
 
 <file path=ppt/notesSlides/notesSlide7.xml><?xml version="1.0" encoding="utf-8"?>
-<p:notes xmlns:a="http://schemas.openxmlformats.org/drawingml/2006/main" xmlns:p="http://schemas.openxmlformats.org/presentationml/2006/main" xmlns:r="http://schemas.openxmlformats.org/officeDocument/2006/relationships">
+<p:notes xmlns:a="http://schemas.openxmlformats.org/drawingml/2006/main" xmlns:r="http://schemas.openxmlformats.org/officeDocument/2006/relationships" xmlns:p="http://schemas.openxmlformats.org/presentationml/2006/main">
   <p:cSld>
     <p:spTree>
       <p:nvGrpSpPr>
@@ -1492,7 +1438,7 @@
         <p:nvSpPr>
           <p:cNvPr id="2" name="Slide Image Placeholder 1"/>
           <p:cNvSpPr>
-            <a:spLocks noGrp="1"/>
+            <a:spLocks noGrp="1" noRot="1" noChangeAspect="1"/>
           </p:cNvSpPr>
           <p:nvPr>
             <p:ph type="sldImg" idx="2"/>
@@ -1507,7 +1453,7 @@
             <a:spLocks noGrp="1"/>
           </p:cNvSpPr>
           <p:nvPr>
-            <p:ph type="body" idx="3" sz="quarter"/>
+            <p:ph type="body" sz="quarter" idx="3"/>
           </p:nvPr>
         </p:nvSpPr>
         <p:spPr/>
@@ -1528,7 +1474,7 @@
             <a:spLocks noGrp="1"/>
           </p:cNvSpPr>
           <p:nvPr>
-            <p:ph type="sldNum" idx="5" sz="quarter"/>
+            <p:ph type="sldNum" sz="quarter" idx="5"/>
           </p:nvPr>
         </p:nvSpPr>
         <p:spPr/>
@@ -1542,7 +1488,7 @@
 </file>
 
 <file path=ppt/notesSlides/notesSlide8.xml><?xml version="1.0" encoding="utf-8"?>
-<p:notes xmlns:a="http://schemas.openxmlformats.org/drawingml/2006/main" xmlns:p="http://schemas.openxmlformats.org/presentationml/2006/main" xmlns:r="http://schemas.openxmlformats.org/officeDocument/2006/relationships">
+<p:notes xmlns:a="http://schemas.openxmlformats.org/drawingml/2006/main" xmlns:r="http://schemas.openxmlformats.org/officeDocument/2006/relationships" xmlns:p="http://schemas.openxmlformats.org/presentationml/2006/main">
   <p:cSld>
     <p:spTree>
       <p:nvGrpSpPr>
@@ -1562,7 +1508,7 @@
         <p:nvSpPr>
           <p:cNvPr id="2" name="Slide Image Placeholder 1"/>
           <p:cNvSpPr>
-            <a:spLocks noGrp="1"/>
+            <a:spLocks noGrp="1" noRot="1" noChangeAspect="1"/>
           </p:cNvSpPr>
           <p:nvPr>
             <p:ph type="sldImg" idx="2"/>
@@ -1577,7 +1523,7 @@
             <a:spLocks noGrp="1"/>
           </p:cNvSpPr>
           <p:nvPr>
-            <p:ph type="body" idx="3" sz="quarter"/>
+            <p:ph type="body" sz="quarter" idx="3"/>
           </p:nvPr>
         </p:nvSpPr>
         <p:spPr/>
@@ -1598,7 +1544,7 @@
             <a:spLocks noGrp="1"/>
           </p:cNvSpPr>
           <p:nvPr>
-            <p:ph type="sldNum" idx="5" sz="quarter"/>
+            <p:ph type="sldNum" sz="quarter" idx="5"/>
           </p:nvPr>
         </p:nvSpPr>
         <p:spPr/>
@@ -1612,7 +1558,7 @@
 </file>
 
 <file path=ppt/notesSlides/notesSlide9.xml><?xml version="1.0" encoding="utf-8"?>
-<p:notes xmlns:a="http://schemas.openxmlformats.org/drawingml/2006/main" xmlns:p="http://schemas.openxmlformats.org/presentationml/2006/main" xmlns:r="http://schemas.openxmlformats.org/officeDocument/2006/relationships">
+<p:notes xmlns:a="http://schemas.openxmlformats.org/drawingml/2006/main" xmlns:r="http://schemas.openxmlformats.org/officeDocument/2006/relationships" xmlns:p="http://schemas.openxmlformats.org/presentationml/2006/main">
   <p:cSld>
     <p:spTree>
       <p:nvGrpSpPr>
@@ -1632,7 +1578,7 @@
         <p:nvSpPr>
           <p:cNvPr id="2" name="Slide Image Placeholder 1"/>
           <p:cNvSpPr>
-            <a:spLocks noGrp="1"/>
+            <a:spLocks noGrp="1" noRot="1" noChangeAspect="1"/>
           </p:cNvSpPr>
           <p:nvPr>
             <p:ph type="sldImg" idx="2"/>
@@ -1647,7 +1593,7 @@
             <a:spLocks noGrp="1"/>
           </p:cNvSpPr>
           <p:nvPr>
-            <p:ph type="body" idx="3" sz="quarter"/>
+            <p:ph type="body" sz="quarter" idx="3"/>
           </p:nvPr>
         </p:nvSpPr>
         <p:spPr/>
@@ -1668,7 +1614,7 @@
             <a:spLocks noGrp="1"/>
           </p:cNvSpPr>
           <p:nvPr>
-            <p:ph type="sldNum" idx="5" sz="quarter"/>
+            <p:ph type="sldNum" sz="quarter" idx="5"/>
           </p:nvPr>
         </p:nvSpPr>
         <p:spPr/>
@@ -1828,7 +1774,7 @@
           <a:p>
             <a:fld id="{030FFF5C-2D96-4D39-AE5C-E4AC30C80AB5}" type="datetimeFigureOut">
               <a:rPr lang="en-US" smtClean="0"/>
-              <a:t>10/5/2026</a:t>
+              <a:t>10/6/2026</a:t>
             </a:fld>
             <a:endParaRPr lang="en-US"/>
           </a:p>
@@ -2026,7 +1972,7 @@
           <a:p>
             <a:fld id="{030FFF5C-2D96-4D39-AE5C-E4AC30C80AB5}" type="datetimeFigureOut">
               <a:rPr lang="en-US" smtClean="0"/>
-              <a:t>10/5/2026</a:t>
+              <a:t>10/6/2026</a:t>
             </a:fld>
             <a:endParaRPr lang="en-US"/>
           </a:p>
@@ -2234,7 +2180,7 @@
           <a:p>
             <a:fld id="{030FFF5C-2D96-4D39-AE5C-E4AC30C80AB5}" type="datetimeFigureOut">
               <a:rPr lang="en-US" smtClean="0"/>
-              <a:t>10/5/2026</a:t>
+              <a:t>10/6/2026</a:t>
             </a:fld>
             <a:endParaRPr lang="en-US"/>
           </a:p>
@@ -2432,7 +2378,7 @@
           <a:p>
             <a:fld id="{030FFF5C-2D96-4D39-AE5C-E4AC30C80AB5}" type="datetimeFigureOut">
               <a:rPr lang="en-US" smtClean="0"/>
-              <a:t>10/5/2026</a:t>
+              <a:t>10/6/2026</a:t>
             </a:fld>
             <a:endParaRPr lang="en-US"/>
           </a:p>
@@ -2707,7 +2653,7 @@
           <a:p>
             <a:fld id="{030FFF5C-2D96-4D39-AE5C-E4AC30C80AB5}" type="datetimeFigureOut">
               <a:rPr lang="en-US" smtClean="0"/>
-              <a:t>10/5/2026</a:t>
+              <a:t>10/6/2026</a:t>
             </a:fld>
             <a:endParaRPr lang="en-US"/>
           </a:p>
@@ -2972,7 +2918,7 @@
           <a:p>
             <a:fld id="{030FFF5C-2D96-4D39-AE5C-E4AC30C80AB5}" type="datetimeFigureOut">
               <a:rPr lang="en-US" smtClean="0"/>
-              <a:t>10/5/2026</a:t>
+              <a:t>10/6/2026</a:t>
             </a:fld>
             <a:endParaRPr lang="en-US"/>
           </a:p>
@@ -3384,7 +3330,7 @@
           <a:p>
             <a:fld id="{030FFF5C-2D96-4D39-AE5C-E4AC30C80AB5}" type="datetimeFigureOut">
               <a:rPr lang="en-US" smtClean="0"/>
-              <a:t>10/5/2026</a:t>
+              <a:t>10/6/2026</a:t>
             </a:fld>
             <a:endParaRPr lang="en-US"/>
           </a:p>
@@ -3525,7 +3471,7 @@
           <a:p>
             <a:fld id="{030FFF5C-2D96-4D39-AE5C-E4AC30C80AB5}" type="datetimeFigureOut">
               <a:rPr lang="en-US" smtClean="0"/>
-              <a:t>10/5/2026</a:t>
+              <a:t>10/6/2026</a:t>
             </a:fld>
             <a:endParaRPr lang="en-US"/>
           </a:p>
@@ -3638,7 +3584,7 @@
           <a:p>
             <a:fld id="{030FFF5C-2D96-4D39-AE5C-E4AC30C80AB5}" type="datetimeFigureOut">
               <a:rPr lang="en-US" smtClean="0"/>
-              <a:t>10/5/2026</a:t>
+              <a:t>10/6/2026</a:t>
             </a:fld>
             <a:endParaRPr lang="en-US"/>
           </a:p>
@@ -3949,7 +3895,7 @@
           <a:p>
             <a:fld id="{030FFF5C-2D96-4D39-AE5C-E4AC30C80AB5}" type="datetimeFigureOut">
               <a:rPr lang="en-US" smtClean="0"/>
-              <a:t>10/5/2026</a:t>
+              <a:t>10/6/2026</a:t>
             </a:fld>
             <a:endParaRPr lang="en-US"/>
           </a:p>
@@ -4237,7 +4183,7 @@
           <a:p>
             <a:fld id="{030FFF5C-2D96-4D39-AE5C-E4AC30C80AB5}" type="datetimeFigureOut">
               <a:rPr lang="en-US" smtClean="0"/>
-              <a:t>10/5/2026</a:t>
+              <a:t>10/6/2026</a:t>
             </a:fld>
             <a:endParaRPr lang="en-US"/>
           </a:p>
@@ -4478,7 +4424,7 @@
           <a:p>
             <a:fld id="{030FFF5C-2D96-4D39-AE5C-E4AC30C80AB5}" type="datetimeFigureOut">
               <a:rPr lang="en-US" smtClean="0"/>
-              <a:t>10/5/2026</a:t>
+              <a:t>10/6/2026</a:t>
             </a:fld>
             <a:endParaRPr lang="en-US"/>
           </a:p>
@@ -4879,7 +4825,7 @@
 </file>
 
 <file path=ppt/slides/slide1.xml><?xml version="1.0" encoding="utf-8"?>
-<p:sld xmlns:a="http://schemas.openxmlformats.org/drawingml/2006/main" xmlns:p="http://schemas.openxmlformats.org/presentationml/2006/main" xmlns:r="http://schemas.openxmlformats.org/officeDocument/2006/relationships">
+<p:sld xmlns:a="http://schemas.openxmlformats.org/drawingml/2006/main" xmlns:r="http://schemas.openxmlformats.org/officeDocument/2006/relationships" xmlns:p="http://schemas.openxmlformats.org/presentationml/2006/main">
   <p:cSld>
     <p:spTree>
       <p:nvGrpSpPr>
@@ -4887,7 +4833,14 @@
         <p:cNvGrpSpPr/>
         <p:nvPr/>
       </p:nvGrpSpPr>
-      <p:grpSpPr/>
+      <p:grpSpPr>
+        <a:xfrm>
+          <a:off x="0" y="0"/>
+          <a:ext cx="0" cy="0"/>
+          <a:chOff x="0" y="0"/>
+          <a:chExt cx="0" cy="0"/>
+        </a:xfrm>
+      </p:grpSpPr>
       <p:sp>
         <p:nvSpPr>
           <p:cNvPr id="2" name="Title 1"/>
@@ -4947,7 +4900,7 @@
 </file>
 
 <file path=ppt/slides/slide10.xml><?xml version="1.0" encoding="utf-8"?>
-<p:sld xmlns:a="http://schemas.openxmlformats.org/drawingml/2006/main" xmlns:p="http://schemas.openxmlformats.org/presentationml/2006/main" xmlns:r="http://schemas.openxmlformats.org/officeDocument/2006/relationships">
+<p:sld xmlns:a="http://schemas.openxmlformats.org/drawingml/2006/main" xmlns:r="http://schemas.openxmlformats.org/officeDocument/2006/relationships" xmlns:p="http://schemas.openxmlformats.org/presentationml/2006/main">
   <p:cSld>
     <p:spTree>
       <p:nvGrpSpPr>
@@ -4955,7 +4908,14 @@
         <p:cNvGrpSpPr/>
         <p:nvPr/>
       </p:nvGrpSpPr>
-      <p:grpSpPr/>
+      <p:grpSpPr>
+        <a:xfrm>
+          <a:off x="0" y="0"/>
+          <a:ext cx="0" cy="0"/>
+          <a:chOff x="0" y="0"/>
+          <a:chExt cx="0" cy="0"/>
+        </a:xfrm>
+      </p:grpSpPr>
       <p:sp>
         <p:nvSpPr>
           <p:cNvPr id="2" name="Title 1"/>
@@ -4972,7 +4932,7 @@
           <a:lstStyle/>
           <a:p>
             <a:r>
-              <a:rPr sz="3000" lang="ja-JP">
+              <a:rPr lang="ja-JP" sz="3000">
                 <a:latin typeface="+mj-lt"/>
                 <a:ea typeface="+mj-ea"/>
               </a:rPr>
@@ -5009,7 +4969,7 @@
               </a:spcAft>
             </a:pPr>
             <a:r>
-              <a:rPr sz="2200" b="1" lang="ja-JP">
+              <a:rPr lang="ja-JP" sz="2200" b="1">
                 <a:latin typeface="+mn-lt"/>
                 <a:ea typeface="+mn-ea"/>
               </a:rPr>
@@ -5023,7 +4983,7 @@
               </a:spcAft>
             </a:pPr>
             <a:r>
-              <a:rPr sz="1900" b="0" lang="ja-JP">
+              <a:rPr lang="ja-JP" sz="1900" b="0">
                 <a:latin typeface="+mn-lt"/>
                 <a:ea typeface="+mn-ea"/>
               </a:rPr>
@@ -5037,7 +4997,7 @@
               </a:spcAft>
             </a:pPr>
             <a:r>
-              <a:rPr sz="2200" b="0" lang="ja-JP">
+              <a:rPr lang="ja-JP" sz="2200" b="0">
                 <a:latin typeface="+mn-lt"/>
                 <a:ea typeface="+mn-ea"/>
               </a:rPr>
@@ -5051,7 +5011,7 @@
               </a:spcAft>
             </a:pPr>
             <a:r>
-              <a:rPr sz="2200" b="0" lang="ja-JP">
+              <a:rPr lang="ja-JP" sz="2200" b="0">
                 <a:latin typeface="+mn-lt"/>
                 <a:ea typeface="+mn-ea"/>
               </a:rPr>
@@ -5065,7 +5025,7 @@
               </a:spcAft>
             </a:pPr>
             <a:r>
-              <a:rPr sz="2200" b="0" lang="ja-JP">
+              <a:rPr lang="ja-JP" sz="2200" b="0">
                 <a:latin typeface="+mn-lt"/>
                 <a:ea typeface="+mn-ea"/>
               </a:rPr>
@@ -5079,7 +5039,7 @@
               </a:spcAft>
             </a:pPr>
             <a:r>
-              <a:rPr sz="2200" b="1" lang="ja-JP">
+              <a:rPr lang="ja-JP" sz="2200" b="1">
                 <a:latin typeface="+mn-lt"/>
                 <a:ea typeface="+mn-ea"/>
               </a:rPr>
@@ -5097,7 +5057,7 @@
 </file>
 
 <file path=ppt/slides/slide2.xml><?xml version="1.0" encoding="utf-8"?>
-<p:sld xmlns:a="http://schemas.openxmlformats.org/drawingml/2006/main" xmlns:p="http://schemas.openxmlformats.org/presentationml/2006/main" xmlns:r="http://schemas.openxmlformats.org/officeDocument/2006/relationships">
+<p:sld xmlns:a="http://schemas.openxmlformats.org/drawingml/2006/main" xmlns:r="http://schemas.openxmlformats.org/officeDocument/2006/relationships" xmlns:p="http://schemas.openxmlformats.org/presentationml/2006/main">
   <p:cSld>
     <p:spTree>
       <p:nvGrpSpPr>
@@ -5105,7 +5065,14 @@
         <p:cNvGrpSpPr/>
         <p:nvPr/>
       </p:nvGrpSpPr>
-      <p:grpSpPr/>
+      <p:grpSpPr>
+        <a:xfrm>
+          <a:off x="0" y="0"/>
+          <a:ext cx="0" cy="0"/>
+          <a:chOff x="0" y="0"/>
+          <a:chExt cx="0" cy="0"/>
+        </a:xfrm>
+      </p:grpSpPr>
       <p:sp>
         <p:nvSpPr>
           <p:cNvPr id="2" name="Title 1"/>
@@ -5122,11 +5089,11 @@
           <a:lstStyle/>
           <a:p>
             <a:r>
-              <a:rPr sz="3000" lang="ja-JP">
+              <a:rPr lang="ja-JP" sz="3000">
                 <a:latin typeface="+mj-lt"/>
                 <a:ea typeface="+mj-ea"/>
               </a:rPr>
-              <a:t>まず結論：わかったこと 3 つ</a:t>
+              <a:t>結論：わかったこと 3 つ</a:t>
             </a:r>
           </a:p>
         </p:txBody>
@@ -5159,7 +5126,7 @@
               </a:spcAft>
             </a:pPr>
             <a:r>
-              <a:rPr sz="1900" b="0" lang="ja-JP">
+              <a:rPr lang="ja-JP" sz="1900" b="0">
                 <a:latin typeface="+mn-lt"/>
                 <a:ea typeface="+mn-ea"/>
               </a:rPr>
@@ -5173,7 +5140,7 @@
               </a:spcAft>
             </a:pPr>
             <a:r>
-              <a:rPr sz="1900" b="1" lang="ja-JP">
+              <a:rPr lang="ja-JP" sz="1900" b="1">
                 <a:latin typeface="+mn-lt"/>
                 <a:ea typeface="+mn-ea"/>
               </a:rPr>
@@ -5187,7 +5154,7 @@
               </a:spcAft>
             </a:pPr>
             <a:r>
-              <a:rPr sz="1600" b="0" lang="ja-JP">
+              <a:rPr lang="ja-JP" sz="1600" b="0">
                 <a:latin typeface="+mn-lt"/>
                 <a:ea typeface="+mn-ea"/>
               </a:rPr>
@@ -5201,7 +5168,7 @@
               </a:spcAft>
             </a:pPr>
             <a:r>
-              <a:rPr sz="1600" b="0" lang="ja-JP">
+              <a:rPr lang="ja-JP" sz="1600" b="0">
                 <a:latin typeface="+mn-lt"/>
                 <a:ea typeface="+mn-ea"/>
               </a:rPr>
@@ -5215,7 +5182,7 @@
               </a:spcAft>
             </a:pPr>
             <a:r>
-              <a:rPr sz="1900" b="1" lang="ja-JP">
+              <a:rPr lang="ja-JP" sz="1900" b="1">
                 <a:latin typeface="+mn-lt"/>
                 <a:ea typeface="+mn-ea"/>
               </a:rPr>
@@ -5229,7 +5196,7 @@
               </a:spcAft>
             </a:pPr>
             <a:r>
-              <a:rPr sz="1600" b="0" lang="ja-JP">
+              <a:rPr lang="ja-JP" sz="1600" b="0">
                 <a:latin typeface="+mn-lt"/>
                 <a:ea typeface="+mn-ea"/>
               </a:rPr>
@@ -5243,7 +5210,7 @@
               </a:spcAft>
             </a:pPr>
             <a:r>
-              <a:rPr sz="1900" b="1" lang="ja-JP">
+              <a:rPr lang="ja-JP" sz="1900" b="1">
                 <a:latin typeface="+mn-lt"/>
                 <a:ea typeface="+mn-ea"/>
               </a:rPr>
@@ -5257,7 +5224,7 @@
               </a:spcAft>
             </a:pPr>
             <a:r>
-              <a:rPr sz="1600" b="0" lang="ja-JP">
+              <a:rPr lang="ja-JP" sz="1600" b="0">
                 <a:latin typeface="+mn-lt"/>
                 <a:ea typeface="+mn-ea"/>
               </a:rPr>
@@ -5275,7 +5242,7 @@
           <p:nvPr/>
         </p:nvPicPr>
         <p:blipFill>
-          <a:blip r:embed="rId2"/>
+          <a:blip r:embed="rId3"/>
           <a:stretch>
             <a:fillRect/>
           </a:stretch>
@@ -5299,7 +5266,7 @@
 </file>
 
 <file path=ppt/slides/slide3.xml><?xml version="1.0" encoding="utf-8"?>
-<p:sld xmlns:a="http://schemas.openxmlformats.org/drawingml/2006/main" xmlns:p="http://schemas.openxmlformats.org/presentationml/2006/main" xmlns:r="http://schemas.openxmlformats.org/officeDocument/2006/relationships">
+<p:sld xmlns:a="http://schemas.openxmlformats.org/drawingml/2006/main" xmlns:r="http://schemas.openxmlformats.org/officeDocument/2006/relationships" xmlns:p="http://schemas.openxmlformats.org/presentationml/2006/main">
   <p:cSld>
     <p:spTree>
       <p:nvGrpSpPr>
@@ -5307,7 +5274,14 @@
         <p:cNvGrpSpPr/>
         <p:nvPr/>
       </p:nvGrpSpPr>
-      <p:grpSpPr/>
+      <p:grpSpPr>
+        <a:xfrm>
+          <a:off x="0" y="0"/>
+          <a:ext cx="0" cy="0"/>
+          <a:chOff x="0" y="0"/>
+          <a:chExt cx="0" cy="0"/>
+        </a:xfrm>
+      </p:grpSpPr>
       <p:sp>
         <p:nvSpPr>
           <p:cNvPr id="2" name="Title 1"/>
@@ -5324,7 +5298,7 @@
           <a:lstStyle/>
           <a:p>
             <a:r>
-              <a:rPr sz="3000" lang="ja-JP">
+              <a:rPr lang="ja-JP" sz="3000">
                 <a:latin typeface="+mj-lt"/>
                 <a:ea typeface="+mj-ea"/>
               </a:rPr>
@@ -5361,7 +5335,7 @@
               </a:spcAft>
             </a:pPr>
             <a:r>
-              <a:rPr sz="1700" b="0" lang="ja-JP">
+              <a:rPr lang="ja-JP" sz="1700" b="0">
                 <a:latin typeface="+mn-lt"/>
                 <a:ea typeface="+mn-ea"/>
               </a:rPr>
@@ -5375,7 +5349,7 @@
               </a:spcAft>
             </a:pPr>
             <a:r>
-              <a:rPr sz="1700" b="1" lang="ja-JP">
+              <a:rPr lang="ja-JP" sz="1700" b="1">
                 <a:latin typeface="+mn-lt"/>
                 <a:ea typeface="+mn-ea"/>
               </a:rPr>
@@ -5389,7 +5363,7 @@
               </a:spcAft>
             </a:pPr>
             <a:r>
-              <a:rPr sz="1400" b="0" lang="ja-JP">
+              <a:rPr lang="ja-JP" sz="1400" b="0">
                 <a:latin typeface="+mn-lt"/>
                 <a:ea typeface="+mn-ea"/>
               </a:rPr>
@@ -5403,7 +5377,7 @@
               </a:spcAft>
             </a:pPr>
             <a:r>
-              <a:rPr sz="1700" b="0" lang="ja-JP">
+              <a:rPr lang="ja-JP" sz="1700" b="0">
                 <a:latin typeface="+mn-lt"/>
                 <a:ea typeface="+mn-ea"/>
               </a:rPr>
@@ -5417,7 +5391,7 @@
               </a:spcAft>
             </a:pPr>
             <a:r>
-              <a:rPr sz="1700" b="0" lang="ja-JP">
+              <a:rPr lang="ja-JP" sz="1700" b="0">
                 <a:latin typeface="+mn-lt"/>
                 <a:ea typeface="+mn-ea"/>
               </a:rPr>
@@ -5431,7 +5405,7 @@
               </a:spcAft>
             </a:pPr>
             <a:r>
-              <a:rPr sz="1700" b="0" lang="ja-JP">
+              <a:rPr lang="ja-JP" sz="1700" b="0">
                 <a:latin typeface="+mn-lt"/>
                 <a:ea typeface="+mn-ea"/>
               </a:rPr>
@@ -5449,7 +5423,7 @@
           <p:nvPr/>
         </p:nvPicPr>
         <p:blipFill>
-          <a:blip r:embed="rId2"/>
+          <a:blip r:embed="rId3"/>
           <a:stretch>
             <a:fillRect/>
           </a:stretch>
@@ -5473,7 +5447,7 @@
 </file>
 
 <file path=ppt/slides/slide4.xml><?xml version="1.0" encoding="utf-8"?>
-<p:sld xmlns:a="http://schemas.openxmlformats.org/drawingml/2006/main" xmlns:p="http://schemas.openxmlformats.org/presentationml/2006/main" xmlns:r="http://schemas.openxmlformats.org/officeDocument/2006/relationships">
+<p:sld xmlns:a="http://schemas.openxmlformats.org/drawingml/2006/main" xmlns:r="http://schemas.openxmlformats.org/officeDocument/2006/relationships" xmlns:p="http://schemas.openxmlformats.org/presentationml/2006/main">
   <p:cSld>
     <p:spTree>
       <p:nvGrpSpPr>
@@ -5481,7 +5455,14 @@
         <p:cNvGrpSpPr/>
         <p:nvPr/>
       </p:nvGrpSpPr>
-      <p:grpSpPr/>
+      <p:grpSpPr>
+        <a:xfrm>
+          <a:off x="0" y="0"/>
+          <a:ext cx="0" cy="0"/>
+          <a:chOff x="0" y="0"/>
+          <a:chExt cx="0" cy="0"/>
+        </a:xfrm>
+      </p:grpSpPr>
       <p:sp>
         <p:nvSpPr>
           <p:cNvPr id="2" name="Title 1"/>
@@ -5498,7 +5479,7 @@
           <a:lstStyle/>
           <a:p>
             <a:r>
-              <a:rPr sz="3000" lang="ja-JP">
+              <a:rPr lang="ja-JP" sz="3000">
                 <a:latin typeface="+mj-lt"/>
                 <a:ea typeface="+mj-ea"/>
               </a:rPr>
@@ -5535,7 +5516,7 @@
               </a:spcAft>
             </a:pPr>
             <a:r>
-              <a:rPr sz="1700" b="0" lang="ja-JP">
+              <a:rPr lang="ja-JP" sz="1700" b="0">
                 <a:latin typeface="+mn-lt"/>
                 <a:ea typeface="+mn-ea"/>
               </a:rPr>
@@ -5549,7 +5530,7 @@
               </a:spcAft>
             </a:pPr>
             <a:r>
-              <a:rPr sz="1400" b="0" lang="ja-JP">
+              <a:rPr lang="ja-JP" sz="1400" b="0">
                 <a:latin typeface="+mn-lt"/>
                 <a:ea typeface="+mn-ea"/>
               </a:rPr>
@@ -5563,7 +5544,7 @@
               </a:spcAft>
             </a:pPr>
             <a:r>
-              <a:rPr sz="1700" b="0" lang="ja-JP">
+              <a:rPr lang="ja-JP" sz="1700" b="0">
                 <a:latin typeface="+mn-lt"/>
                 <a:ea typeface="+mn-ea"/>
               </a:rPr>
@@ -5577,7 +5558,7 @@
               </a:spcAft>
             </a:pPr>
             <a:r>
-              <a:rPr sz="1400" b="0" lang="ja-JP">
+              <a:rPr lang="ja-JP" sz="1400" b="0">
                 <a:latin typeface="+mn-lt"/>
                 <a:ea typeface="+mn-ea"/>
               </a:rPr>
@@ -5591,7 +5572,7 @@
               </a:spcAft>
             </a:pPr>
             <a:r>
-              <a:rPr sz="1700" b="1" lang="ja-JP">
+              <a:rPr lang="ja-JP" sz="1700" b="1">
                 <a:latin typeface="+mn-lt"/>
                 <a:ea typeface="+mn-ea"/>
               </a:rPr>
@@ -5605,7 +5586,7 @@
               </a:spcAft>
             </a:pPr>
             <a:r>
-              <a:rPr sz="1400" b="0" lang="ja-JP">
+              <a:rPr lang="ja-JP" sz="1400" b="0">
                 <a:latin typeface="+mn-lt"/>
                 <a:ea typeface="+mn-ea"/>
               </a:rPr>
@@ -5619,7 +5600,7 @@
               </a:spcAft>
             </a:pPr>
             <a:r>
-              <a:rPr sz="1700" b="0" lang="ja-JP">
+              <a:rPr lang="ja-JP" sz="1700" b="0">
                 <a:latin typeface="+mn-lt"/>
                 <a:ea typeface="+mn-ea"/>
               </a:rPr>
@@ -5633,7 +5614,7 @@
               </a:spcAft>
             </a:pPr>
             <a:r>
-              <a:rPr sz="1700" b="1" lang="ja-JP">
+              <a:rPr lang="ja-JP" sz="1700" b="1">
                 <a:latin typeface="+mn-lt"/>
                 <a:ea typeface="+mn-ea"/>
               </a:rPr>
@@ -5651,7 +5632,7 @@
           <p:nvPr/>
         </p:nvPicPr>
         <p:blipFill>
-          <a:blip r:embed="rId2"/>
+          <a:blip r:embed="rId3"/>
           <a:stretch>
             <a:fillRect/>
           </a:stretch>
@@ -5675,7 +5656,7 @@
 </file>
 
 <file path=ppt/slides/slide5.xml><?xml version="1.0" encoding="utf-8"?>
-<p:sld xmlns:a="http://schemas.openxmlformats.org/drawingml/2006/main" xmlns:p="http://schemas.openxmlformats.org/presentationml/2006/main" xmlns:r="http://schemas.openxmlformats.org/officeDocument/2006/relationships">
+<p:sld xmlns:a="http://schemas.openxmlformats.org/drawingml/2006/main" xmlns:r="http://schemas.openxmlformats.org/officeDocument/2006/relationships" xmlns:p="http://schemas.openxmlformats.org/presentationml/2006/main">
   <p:cSld>
     <p:spTree>
       <p:nvGrpSpPr>
@@ -5683,7 +5664,14 @@
         <p:cNvGrpSpPr/>
         <p:nvPr/>
       </p:nvGrpSpPr>
-      <p:grpSpPr/>
+      <p:grpSpPr>
+        <a:xfrm>
+          <a:off x="0" y="0"/>
+          <a:ext cx="0" cy="0"/>
+          <a:chOff x="0" y="0"/>
+          <a:chExt cx="0" cy="0"/>
+        </a:xfrm>
+      </p:grpSpPr>
       <p:sp>
         <p:nvSpPr>
           <p:cNvPr id="2" name="Title 1"/>
@@ -5700,7 +5688,7 @@
           <a:lstStyle/>
           <a:p>
             <a:r>
-              <a:rPr sz="3000" lang="ja-JP">
+              <a:rPr lang="ja-JP" sz="3000">
                 <a:latin typeface="+mj-lt"/>
                 <a:ea typeface="+mj-ea"/>
               </a:rPr>
@@ -5737,7 +5725,7 @@
               </a:spcAft>
             </a:pPr>
             <a:r>
-              <a:rPr sz="1700" b="0" lang="ja-JP">
+              <a:rPr lang="ja-JP" sz="1700" b="0">
                 <a:latin typeface="+mn-lt"/>
                 <a:ea typeface="+mn-ea"/>
               </a:rPr>
@@ -5751,7 +5739,7 @@
               </a:spcAft>
             </a:pPr>
             <a:r>
-              <a:rPr sz="1700" b="1" lang="ja-JP">
+              <a:rPr lang="ja-JP" sz="1700" b="1">
                 <a:latin typeface="+mn-lt"/>
                 <a:ea typeface="+mn-ea"/>
               </a:rPr>
@@ -5765,7 +5753,7 @@
               </a:spcAft>
             </a:pPr>
             <a:r>
-              <a:rPr sz="1700" b="0" lang="ja-JP">
+              <a:rPr lang="ja-JP" sz="1700" b="0">
                 <a:latin typeface="+mn-lt"/>
                 <a:ea typeface="+mn-ea"/>
               </a:rPr>
@@ -5779,7 +5767,7 @@
               </a:spcAft>
             </a:pPr>
             <a:r>
-              <a:rPr sz="1700" b="1" lang="ja-JP">
+              <a:rPr lang="ja-JP" sz="1700" b="1">
                 <a:latin typeface="+mn-lt"/>
                 <a:ea typeface="+mn-ea"/>
               </a:rPr>
@@ -5797,7 +5785,7 @@
           <p:nvPr/>
         </p:nvPicPr>
         <p:blipFill>
-          <a:blip r:embed="rId2"/>
+          <a:blip r:embed="rId3"/>
           <a:stretch>
             <a:fillRect/>
           </a:stretch>
@@ -5821,7 +5809,7 @@
 </file>
 
 <file path=ppt/slides/slide6.xml><?xml version="1.0" encoding="utf-8"?>
-<p:sld xmlns:a="http://schemas.openxmlformats.org/drawingml/2006/main" xmlns:p="http://schemas.openxmlformats.org/presentationml/2006/main" xmlns:r="http://schemas.openxmlformats.org/officeDocument/2006/relationships">
+<p:sld xmlns:a="http://schemas.openxmlformats.org/drawingml/2006/main" xmlns:r="http://schemas.openxmlformats.org/officeDocument/2006/relationships" xmlns:p="http://schemas.openxmlformats.org/presentationml/2006/main">
   <p:cSld>
     <p:spTree>
       <p:nvGrpSpPr>
@@ -5829,7 +5817,14 @@
         <p:cNvGrpSpPr/>
         <p:nvPr/>
       </p:nvGrpSpPr>
-      <p:grpSpPr/>
+      <p:grpSpPr>
+        <a:xfrm>
+          <a:off x="0" y="0"/>
+          <a:ext cx="0" cy="0"/>
+          <a:chOff x="0" y="0"/>
+          <a:chExt cx="0" cy="0"/>
+        </a:xfrm>
+      </p:grpSpPr>
       <p:sp>
         <p:nvSpPr>
           <p:cNvPr id="2" name="Title 1"/>
@@ -5846,7 +5841,7 @@
           <a:lstStyle/>
           <a:p>
             <a:r>
-              <a:rPr sz="3000" lang="ja-JP">
+              <a:rPr lang="ja-JP" sz="3000">
                 <a:latin typeface="+mj-lt"/>
                 <a:ea typeface="+mj-ea"/>
               </a:rPr>
@@ -5883,7 +5878,7 @@
               </a:spcAft>
             </a:pPr>
             <a:r>
-              <a:rPr sz="1600" b="0" lang="ja-JP">
+              <a:rPr lang="ja-JP" sz="1600" b="0">
                 <a:latin typeface="+mn-lt"/>
                 <a:ea typeface="+mn-ea"/>
               </a:rPr>
@@ -5897,7 +5892,7 @@
               </a:spcAft>
             </a:pPr>
             <a:r>
-              <a:rPr sz="1600" b="1" lang="ja-JP">
+              <a:rPr lang="ja-JP" sz="1600" b="1">
                 <a:latin typeface="+mn-lt"/>
                 <a:ea typeface="+mn-ea"/>
               </a:rPr>
@@ -5911,7 +5906,7 @@
               </a:spcAft>
             </a:pPr>
             <a:r>
-              <a:rPr sz="1600" b="0" lang="ja-JP">
+              <a:rPr lang="ja-JP" sz="1600" b="0">
                 <a:latin typeface="+mn-lt"/>
                 <a:ea typeface="+mn-ea"/>
               </a:rPr>
@@ -5925,7 +5920,7 @@
               </a:spcAft>
             </a:pPr>
             <a:r>
-              <a:rPr sz="1600" b="0" lang="ja-JP">
+              <a:rPr lang="ja-JP" sz="1600" b="0">
                 <a:latin typeface="+mn-lt"/>
                 <a:ea typeface="+mn-ea"/>
               </a:rPr>
@@ -5939,7 +5934,7 @@
               </a:spcAft>
             </a:pPr>
             <a:r>
-              <a:rPr sz="1600" b="0" lang="ja-JP">
+              <a:rPr lang="ja-JP" sz="1600" b="0">
                 <a:latin typeface="+mn-lt"/>
                 <a:ea typeface="+mn-ea"/>
               </a:rPr>
@@ -5957,7 +5952,7 @@
           <p:nvPr/>
         </p:nvPicPr>
         <p:blipFill>
-          <a:blip r:embed="rId2"/>
+          <a:blip r:embed="rId3"/>
           <a:stretch>
             <a:fillRect/>
           </a:stretch>
@@ -5981,7 +5976,7 @@
 </file>
 
 <file path=ppt/slides/slide7.xml><?xml version="1.0" encoding="utf-8"?>
-<p:sld xmlns:a="http://schemas.openxmlformats.org/drawingml/2006/main" xmlns:p="http://schemas.openxmlformats.org/presentationml/2006/main" xmlns:r="http://schemas.openxmlformats.org/officeDocument/2006/relationships">
+<p:sld xmlns:a="http://schemas.openxmlformats.org/drawingml/2006/main" xmlns:r="http://schemas.openxmlformats.org/officeDocument/2006/relationships" xmlns:p="http://schemas.openxmlformats.org/presentationml/2006/main">
   <p:cSld>
     <p:spTree>
       <p:nvGrpSpPr>
@@ -5989,7 +5984,14 @@
         <p:cNvGrpSpPr/>
         <p:nvPr/>
       </p:nvGrpSpPr>
-      <p:grpSpPr/>
+      <p:grpSpPr>
+        <a:xfrm>
+          <a:off x="0" y="0"/>
+          <a:ext cx="0" cy="0"/>
+          <a:chOff x="0" y="0"/>
+          <a:chExt cx="0" cy="0"/>
+        </a:xfrm>
+      </p:grpSpPr>
       <p:sp>
         <p:nvSpPr>
           <p:cNvPr id="2" name="Title 1"/>
@@ -6006,7 +6008,7 @@
           <a:lstStyle/>
           <a:p>
             <a:r>
-              <a:rPr sz="3000" lang="ja-JP">
+              <a:rPr lang="ja-JP" sz="3000">
                 <a:latin typeface="+mj-lt"/>
                 <a:ea typeface="+mj-ea"/>
               </a:rPr>
@@ -6034,9 +6036,27 @@
                 <a:tableStyleId>{5C22544A-7EE6-4342-B048-85BDC9FD1C3A}</a:tableStyleId>
               </a:tblPr>
               <a:tblGrid>
-                <a:gridCol w="1554480"/>
-                <a:gridCol w="4846320"/>
-                <a:gridCol w="4846320"/>
+                <a:gridCol w="1554480">
+                  <a:extLst>
+                    <a:ext uri="{9D8B030D-6E8A-4147-A177-3AD203B41FA5}">
+                      <a16:colId xmlns:a16="http://schemas.microsoft.com/office/drawing/2014/main" val="20000"/>
+                    </a:ext>
+                  </a:extLst>
+                </a:gridCol>
+                <a:gridCol w="4846320">
+                  <a:extLst>
+                    <a:ext uri="{9D8B030D-6E8A-4147-A177-3AD203B41FA5}">
+                      <a16:colId xmlns:a16="http://schemas.microsoft.com/office/drawing/2014/main" val="20001"/>
+                    </a:ext>
+                  </a:extLst>
+                </a:gridCol>
+                <a:gridCol w="4846320">
+                  <a:extLst>
+                    <a:ext uri="{9D8B030D-6E8A-4147-A177-3AD203B41FA5}">
+                      <a16:colId xmlns:a16="http://schemas.microsoft.com/office/drawing/2014/main" val="20002"/>
+                    </a:ext>
+                  </a:extLst>
+                </a:gridCol>
               </a:tblGrid>
               <a:tr h="411480">
                 <a:tc>
@@ -6044,13 +6064,7 @@
                     <a:bodyPr/>
                     <a:lstStyle/>
                     <a:p>
-                      <a:r>
-                        <a:rPr sz="1500" b="1" lang="ja-JP">
-                          <a:latin typeface="+mn-lt"/>
-                          <a:ea typeface="+mn-ea"/>
-                        </a:rPr>
-                        <a:t/>
-                      </a:r>
+                      <a:endParaRPr/>
                     </a:p>
                   </a:txBody>
                   <a:tcPr/>
@@ -6061,7 +6075,7 @@
                     <a:lstStyle/>
                     <a:p>
                       <a:r>
-                        <a:rPr sz="1500" b="1" lang="ja-JP">
+                        <a:rPr lang="ja-JP" sz="1500" b="1">
                           <a:latin typeface="+mn-lt"/>
                           <a:ea typeface="+mn-ea"/>
                         </a:rPr>
@@ -6077,7 +6091,7 @@
                     <a:lstStyle/>
                     <a:p>
                       <a:r>
-                        <a:rPr sz="1500" b="1" lang="ja-JP">
+                        <a:rPr lang="ja-JP" sz="1500" b="1">
                           <a:latin typeface="+mn-lt"/>
                           <a:ea typeface="+mn-ea"/>
                         </a:rPr>
@@ -6087,6 +6101,11 @@
                   </a:txBody>
                   <a:tcPr/>
                 </a:tc>
+                <a:extLst>
+                  <a:ext uri="{0D108BD9-81ED-4DB2-BD59-A6C34878D82A}">
+                    <a16:rowId xmlns:a16="http://schemas.microsoft.com/office/drawing/2014/main" val="10000"/>
+                  </a:ext>
+                </a:extLst>
               </a:tr>
               <a:tr h="411480">
                 <a:tc>
@@ -6095,7 +6114,7 @@
                     <a:lstStyle/>
                     <a:p>
                       <a:r>
-                        <a:rPr sz="1500" b="1" lang="ja-JP">
+                        <a:rPr lang="ja-JP" sz="1500" b="1">
                           <a:latin typeface="+mn-lt"/>
                           <a:ea typeface="+mn-ea"/>
                         </a:rPr>
@@ -6111,7 +6130,7 @@
                     <a:lstStyle/>
                     <a:p>
                       <a:r>
-                        <a:rPr sz="1500" b="0" lang="ja-JP">
+                        <a:rPr lang="ja-JP" sz="1500" b="0">
                           <a:latin typeface="+mn-lt"/>
                           <a:ea typeface="+mn-ea"/>
                         </a:rPr>
@@ -6127,7 +6146,7 @@
                     <a:lstStyle/>
                     <a:p>
                       <a:r>
-                        <a:rPr sz="1500" b="0" lang="ja-JP">
+                        <a:rPr lang="ja-JP" sz="1500" b="0">
                           <a:latin typeface="+mn-lt"/>
                           <a:ea typeface="+mn-ea"/>
                         </a:rPr>
@@ -6137,6 +6156,11 @@
                   </a:txBody>
                   <a:tcPr/>
                 </a:tc>
+                <a:extLst>
+                  <a:ext uri="{0D108BD9-81ED-4DB2-BD59-A6C34878D82A}">
+                    <a16:rowId xmlns:a16="http://schemas.microsoft.com/office/drawing/2014/main" val="10001"/>
+                  </a:ext>
+                </a:extLst>
               </a:tr>
               <a:tr h="411480">
                 <a:tc>
@@ -6145,7 +6169,7 @@
                     <a:lstStyle/>
                     <a:p>
                       <a:r>
-                        <a:rPr sz="1500" b="1" lang="ja-JP">
+                        <a:rPr lang="ja-JP" sz="1500" b="1">
                           <a:latin typeface="+mn-lt"/>
                           <a:ea typeface="+mn-ea"/>
                         </a:rPr>
@@ -6161,7 +6185,7 @@
                     <a:lstStyle/>
                     <a:p>
                       <a:r>
-                        <a:rPr sz="1500" b="0" lang="ja-JP">
+                        <a:rPr lang="ja-JP" sz="1500" b="0">
                           <a:latin typeface="+mn-lt"/>
                           <a:ea typeface="+mn-ea"/>
                         </a:rPr>
@@ -6177,7 +6201,7 @@
                     <a:lstStyle/>
                     <a:p>
                       <a:r>
-                        <a:rPr sz="1500" b="0" lang="ja-JP">
+                        <a:rPr lang="ja-JP" sz="1500" b="0">
                           <a:latin typeface="+mn-lt"/>
                           <a:ea typeface="+mn-ea"/>
                         </a:rPr>
@@ -6187,6 +6211,11 @@
                   </a:txBody>
                   <a:tcPr/>
                 </a:tc>
+                <a:extLst>
+                  <a:ext uri="{0D108BD9-81ED-4DB2-BD59-A6C34878D82A}">
+                    <a16:rowId xmlns:a16="http://schemas.microsoft.com/office/drawing/2014/main" val="10002"/>
+                  </a:ext>
+                </a:extLst>
               </a:tr>
               <a:tr h="411480">
                 <a:tc>
@@ -6195,7 +6224,7 @@
                     <a:lstStyle/>
                     <a:p>
                       <a:r>
-                        <a:rPr sz="1500" b="1" lang="ja-JP">
+                        <a:rPr lang="ja-JP" sz="1500" b="1">
                           <a:latin typeface="+mn-lt"/>
                           <a:ea typeface="+mn-ea"/>
                         </a:rPr>
@@ -6211,7 +6240,7 @@
                     <a:lstStyle/>
                     <a:p>
                       <a:r>
-                        <a:rPr sz="1500" b="0" lang="ja-JP">
+                        <a:rPr lang="ja-JP" sz="1500" b="0">
                           <a:latin typeface="+mn-lt"/>
                           <a:ea typeface="+mn-ea"/>
                         </a:rPr>
@@ -6227,7 +6256,7 @@
                     <a:lstStyle/>
                     <a:p>
                       <a:r>
-                        <a:rPr sz="1500" b="0" lang="ja-JP">
+                        <a:rPr lang="ja-JP" sz="1500" b="0">
                           <a:latin typeface="+mn-lt"/>
                           <a:ea typeface="+mn-ea"/>
                         </a:rPr>
@@ -6237,6 +6266,11 @@
                   </a:txBody>
                   <a:tcPr/>
                 </a:tc>
+                <a:extLst>
+                  <a:ext uri="{0D108BD9-81ED-4DB2-BD59-A6C34878D82A}">
+                    <a16:rowId xmlns:a16="http://schemas.microsoft.com/office/drawing/2014/main" val="10003"/>
+                  </a:ext>
+                </a:extLst>
               </a:tr>
               <a:tr h="411480">
                 <a:tc>
@@ -6245,7 +6279,7 @@
                     <a:lstStyle/>
                     <a:p>
                       <a:r>
-                        <a:rPr sz="1500" b="1" lang="ja-JP">
+                        <a:rPr lang="ja-JP" sz="1500" b="1">
                           <a:latin typeface="+mn-lt"/>
                           <a:ea typeface="+mn-ea"/>
                         </a:rPr>
@@ -6261,7 +6295,7 @@
                     <a:lstStyle/>
                     <a:p>
                       <a:r>
-                        <a:rPr sz="1500" b="0" lang="ja-JP">
+                        <a:rPr lang="ja-JP" sz="1500" b="0">
                           <a:latin typeface="+mn-lt"/>
                           <a:ea typeface="+mn-ea"/>
                         </a:rPr>
@@ -6277,7 +6311,7 @@
                     <a:lstStyle/>
                     <a:p>
                       <a:r>
-                        <a:rPr sz="1500" b="0" lang="ja-JP">
+                        <a:rPr lang="ja-JP" sz="1500" b="0">
                           <a:latin typeface="+mn-lt"/>
                           <a:ea typeface="+mn-ea"/>
                         </a:rPr>
@@ -6287,6 +6321,11 @@
                   </a:txBody>
                   <a:tcPr/>
                 </a:tc>
+                <a:extLst>
+                  <a:ext uri="{0D108BD9-81ED-4DB2-BD59-A6C34878D82A}">
+                    <a16:rowId xmlns:a16="http://schemas.microsoft.com/office/drawing/2014/main" val="10004"/>
+                  </a:ext>
+                </a:extLst>
               </a:tr>
             </a:tbl>
           </a:graphicData>
@@ -6320,7 +6359,7 @@
               </a:spcAft>
             </a:pPr>
             <a:r>
-              <a:rPr sz="1700" b="1" lang="ja-JP">
+              <a:rPr lang="ja-JP" sz="1700" b="1">
                 <a:latin typeface="+mn-lt"/>
                 <a:ea typeface="+mn-ea"/>
               </a:rPr>
@@ -6334,7 +6373,7 @@
               </a:spcAft>
             </a:pPr>
             <a:r>
-              <a:rPr sz="1700" b="0" lang="ja-JP">
+              <a:rPr lang="ja-JP" sz="1700" b="0">
                 <a:latin typeface="+mn-lt"/>
                 <a:ea typeface="+mn-ea"/>
               </a:rPr>
@@ -6348,7 +6387,7 @@
               </a:spcAft>
             </a:pPr>
             <a:r>
-              <a:rPr sz="1700" b="0" lang="ja-JP">
+              <a:rPr lang="ja-JP" sz="1700" b="0">
                 <a:latin typeface="+mn-lt"/>
                 <a:ea typeface="+mn-ea"/>
               </a:rPr>
@@ -6366,7 +6405,7 @@
 </file>
 
 <file path=ppt/slides/slide8.xml><?xml version="1.0" encoding="utf-8"?>
-<p:sld xmlns:a="http://schemas.openxmlformats.org/drawingml/2006/main" xmlns:p="http://schemas.openxmlformats.org/presentationml/2006/main" xmlns:r="http://schemas.openxmlformats.org/officeDocument/2006/relationships">
+<p:sld xmlns:a="http://schemas.openxmlformats.org/drawingml/2006/main" xmlns:r="http://schemas.openxmlformats.org/officeDocument/2006/relationships" xmlns:p="http://schemas.openxmlformats.org/presentationml/2006/main">
   <p:cSld>
     <p:spTree>
       <p:nvGrpSpPr>
@@ -6374,7 +6413,14 @@
         <p:cNvGrpSpPr/>
         <p:nvPr/>
       </p:nvGrpSpPr>
-      <p:grpSpPr/>
+      <p:grpSpPr>
+        <a:xfrm>
+          <a:off x="0" y="0"/>
+          <a:ext cx="0" cy="0"/>
+          <a:chOff x="0" y="0"/>
+          <a:chExt cx="0" cy="0"/>
+        </a:xfrm>
+      </p:grpSpPr>
       <p:sp>
         <p:nvSpPr>
           <p:cNvPr id="2" name="Title 1"/>
@@ -6391,7 +6437,7 @@
           <a:lstStyle/>
           <a:p>
             <a:r>
-              <a:rPr sz="3000" lang="ja-JP">
+              <a:rPr lang="ja-JP" sz="3000">
                 <a:latin typeface="+mj-lt"/>
                 <a:ea typeface="+mj-ea"/>
               </a:rPr>
@@ -6438,12 +6484,12 @@
           </a:fontRef>
         </p:style>
         <p:txBody>
-          <a:bodyPr rtlCol="0" anchor="ctr" wrap="square"/>
+          <a:bodyPr wrap="square" rtlCol="0" anchor="ctr"/>
           <a:lstStyle/>
           <a:p>
             <a:pPr algn="ctr"/>
             <a:r>
-              <a:rPr sz="2000" b="1" lang="ja-JP">
+              <a:rPr lang="ja-JP" sz="2000" b="1">
                 <a:solidFill>
                   <a:srgbClr val="101010"/>
                 </a:solidFill>
@@ -6493,12 +6539,12 @@
           </a:fontRef>
         </p:style>
         <p:txBody>
-          <a:bodyPr rtlCol="0" anchor="ctr" wrap="square"/>
+          <a:bodyPr wrap="square" rtlCol="0" anchor="ctr"/>
           <a:lstStyle/>
           <a:p>
             <a:pPr algn="ctr"/>
             <a:r>
-              <a:rPr sz="2000" b="1" lang="ja-JP">
+              <a:rPr lang="ja-JP" sz="2000" b="1">
                 <a:solidFill>
                   <a:srgbClr val="101010"/>
                 </a:solidFill>
@@ -6550,6 +6596,7 @@
           <a:lstStyle/>
           <a:p>
             <a:pPr algn="ctr"/>
+            <a:endParaRPr/>
           </a:p>
         </p:txBody>
       </p:sp>
@@ -6581,7 +6628,7 @@
               </a:spcAft>
             </a:pPr>
             <a:r>
-              <a:rPr sz="1800" b="0" lang="ja-JP">
+              <a:rPr lang="ja-JP" sz="1800" b="0">
                 <a:latin typeface="+mn-lt"/>
                 <a:ea typeface="+mn-ea"/>
               </a:rPr>
@@ -6595,7 +6642,7 @@
               </a:spcAft>
             </a:pPr>
             <a:r>
-              <a:rPr sz="1800" b="0" lang="ja-JP">
+              <a:rPr lang="ja-JP" sz="1800" b="0">
                 <a:latin typeface="+mn-lt"/>
                 <a:ea typeface="+mn-ea"/>
               </a:rPr>
@@ -6609,7 +6656,7 @@
               </a:spcAft>
             </a:pPr>
             <a:r>
-              <a:rPr sz="1800" b="1" lang="ja-JP">
+              <a:rPr lang="ja-JP" sz="1800" b="1">
                 <a:latin typeface="+mn-lt"/>
                 <a:ea typeface="+mn-ea"/>
               </a:rPr>
@@ -6623,7 +6670,7 @@
               </a:spcAft>
             </a:pPr>
             <a:r>
-              <a:rPr sz="1500" b="0" lang="ja-JP">
+              <a:rPr lang="ja-JP" sz="1500" b="0">
                 <a:latin typeface="+mn-lt"/>
                 <a:ea typeface="+mn-ea"/>
               </a:rPr>
@@ -6637,7 +6684,7 @@
               </a:spcAft>
             </a:pPr>
             <a:r>
-              <a:rPr sz="1800" b="1" lang="ja-JP">
+              <a:rPr lang="ja-JP" sz="1800" b="1">
                 <a:latin typeface="+mn-lt"/>
                 <a:ea typeface="+mn-ea"/>
               </a:rPr>
@@ -6655,7 +6702,7 @@
 </file>
 
 <file path=ppt/slides/slide9.xml><?xml version="1.0" encoding="utf-8"?>
-<p:sld xmlns:a="http://schemas.openxmlformats.org/drawingml/2006/main" xmlns:p="http://schemas.openxmlformats.org/presentationml/2006/main" xmlns:r="http://schemas.openxmlformats.org/officeDocument/2006/relationships">
+<p:sld xmlns:a="http://schemas.openxmlformats.org/drawingml/2006/main" xmlns:r="http://schemas.openxmlformats.org/officeDocument/2006/relationships" xmlns:p="http://schemas.openxmlformats.org/presentationml/2006/main">
   <p:cSld>
     <p:spTree>
       <p:nvGrpSpPr>
@@ -6663,7 +6710,14 @@
         <p:cNvGrpSpPr/>
         <p:nvPr/>
       </p:nvGrpSpPr>
-      <p:grpSpPr/>
+      <p:grpSpPr>
+        <a:xfrm>
+          <a:off x="0" y="0"/>
+          <a:ext cx="0" cy="0"/>
+          <a:chOff x="0" y="0"/>
+          <a:chExt cx="0" cy="0"/>
+        </a:xfrm>
+      </p:grpSpPr>
       <p:sp>
         <p:nvSpPr>
           <p:cNvPr id="2" name="Title 1"/>
@@ -6680,7 +6734,7 @@
           <a:lstStyle/>
           <a:p>
             <a:r>
-              <a:rPr sz="3000" lang="ja-JP">
+              <a:rPr lang="ja-JP" sz="3000">
                 <a:latin typeface="+mj-lt"/>
                 <a:ea typeface="+mj-ea"/>
               </a:rPr>
@@ -6717,7 +6771,7 @@
               </a:spcAft>
             </a:pPr>
             <a:r>
-              <a:rPr sz="1800" b="0" lang="ja-JP">
+              <a:rPr lang="ja-JP" sz="1800" b="0">
                 <a:latin typeface="+mn-lt"/>
                 <a:ea typeface="+mn-ea"/>
               </a:rPr>
@@ -6731,7 +6785,7 @@
               </a:spcAft>
             </a:pPr>
             <a:r>
-              <a:rPr sz="1800" b="1" lang="ja-JP">
+              <a:rPr lang="ja-JP" sz="1800" b="1">
                 <a:latin typeface="+mn-lt"/>
                 <a:ea typeface="+mn-ea"/>
               </a:rPr>
@@ -6745,7 +6799,7 @@
               </a:spcAft>
             </a:pPr>
             <a:r>
-              <a:rPr sz="1800" b="0" lang="ja-JP">
+              <a:rPr lang="ja-JP" sz="1800" b="0">
                 <a:latin typeface="+mn-lt"/>
                 <a:ea typeface="+mn-ea"/>
               </a:rPr>
@@ -6759,7 +6813,7 @@
               </a:spcAft>
             </a:pPr>
             <a:r>
-              <a:rPr sz="1800" b="1" lang="ja-JP">
+              <a:rPr lang="ja-JP" sz="1800" b="1">
                 <a:latin typeface="+mn-lt"/>
                 <a:ea typeface="+mn-ea"/>
               </a:rPr>
@@ -6777,7 +6831,7 @@
           <p:nvPr/>
         </p:nvPicPr>
         <p:blipFill>
-          <a:blip r:embed="rId2"/>
+          <a:blip r:embed="rId3"/>
           <a:stretch>
             <a:fillRect/>
           </a:stretch>

</xml_diff>

<commit_message>
slides: 本人の編集版を更新 (10-06 14:50)
</commit_message>
<xml_diff>
--- a/slides/2026-10-09_研究報告_10枚版.pptx
+++ b/slides/2026-10-09_研究報告_10枚版.pptx
@@ -5,19 +5,19 @@
     <p:sldMasterId id="2147483648" r:id="rId1"/>
   </p:sldMasterIdLst>
   <p:notesMasterIdLst>
-    <p:notesMasterId r:id="rId12"/>
+    <p:notesMasterId r:id="rId53"/>
   </p:notesMasterIdLst>
   <p:sldIdLst>
-    <p:sldId id="256" r:id="rId2"/>
-    <p:sldId id="257" r:id="rId3"/>
-    <p:sldId id="258" r:id="rId4"/>
-    <p:sldId id="259" r:id="rId5"/>
-    <p:sldId id="260" r:id="rId6"/>
-    <p:sldId id="261" r:id="rId7"/>
-    <p:sldId id="262" r:id="rId8"/>
-    <p:sldId id="263" r:id="rId9"/>
-    <p:sldId id="264" r:id="rId10"/>
-    <p:sldId id="265" r:id="rId11"/>
+    <p:sldId id="256" r:id="rId9"/>
+    <p:sldId id="257" r:id="rId10"/>
+    <p:sldId id="258" r:id="rId11"/>
+    <p:sldId id="259" r:id="rId12"/>
+    <p:sldId id="260" r:id="rId13"/>
+    <p:sldId id="261" r:id="rId14"/>
+    <p:sldId id="262" r:id="rId15"/>
+    <p:sldId id="263" r:id="rId16"/>
+    <p:sldId id="264" r:id="rId17"/>
+    <p:sldId id="265" r:id="rId18"/>
   </p:sldIdLst>
   <p:sldSz cx="12192000" cy="6858000"/>
   <p:notesSz cx="6858000" cy="9144000"/>
@@ -135,29 +135,29 @@
 </p:presentation>
 </file>
 
+<file path=ppt/revisionInfo.xml><?xml version="1.0" encoding="utf-8"?>
+<p1510:revInfo xmlns:a="http://schemas.openxmlformats.org/drawingml/2006/main" xmlns:r="http://schemas.openxmlformats.org/officeDocument/2006/relationships" xmlns:p1510="http://schemas.microsoft.com/office/powerpoint/2015/10/main">
+  <p1510:revLst>
+    <p1510:client id="{00028602-DADF-4A12-9718-18B16E5CE366}" v="1" dt="2026-10-05T03:38:29.240"/>
+  </p1510:revLst>
+</p1510:revInfo>
+</file>
+
 <file path=ppt/changesInfos/changesInfo1.xml><?xml version="1.0" encoding="utf-8"?>
 <pc:chgInfo xmlns:a="http://schemas.openxmlformats.org/drawingml/2006/main" xmlns:r="http://schemas.openxmlformats.org/officeDocument/2006/relationships" xmlns:ac="http://schemas.microsoft.com/office/drawing/2013/main/command" xmlns:pc="http://schemas.microsoft.com/office/powerpoint/2013/main/command">
   <pc:docChgLst>
     <pc:chgData name="202304239" userId="ab1adf7a-b8eb-4038-b404-de23e20d8a3a" providerId="ADAL" clId="{6C0E59ED-D716-49AF-B2FA-B94E7B8E5A8C}"/>
     <pc:docChg chg="undo custSel addSld delSld modSld sldOrd">
-      <pc:chgData name="202304239" userId="ab1adf7a-b8eb-4038-b404-de23e20d8a3a" providerId="ADAL" clId="{6C0E59ED-D716-49AF-B2FA-B94E7B8E5A8C}" dt="2026-10-06T05:48:43.412" v="866" actId="20577"/>
+      <pc:chgData name="202304239" userId="ab1adf7a-b8eb-4038-b404-de23e20d8a3a" providerId="ADAL" clId="{6C0E59ED-D716-49AF-B2FA-B94E7B8E5A8C}" dt="2026-10-05T05:57:59.931" v="864" actId="20577"/>
       <pc:docMkLst>
         <pc:docMk/>
       </pc:docMkLst>
       <pc:sldChg chg="modSp mod">
-        <pc:chgData name="202304239" userId="ab1adf7a-b8eb-4038-b404-de23e20d8a3a" providerId="ADAL" clId="{6C0E59ED-D716-49AF-B2FA-B94E7B8E5A8C}" dt="2026-10-06T05:48:43.412" v="866" actId="20577"/>
+        <pc:chgData name="202304239" userId="ab1adf7a-b8eb-4038-b404-de23e20d8a3a" providerId="ADAL" clId="{6C0E59ED-D716-49AF-B2FA-B94E7B8E5A8C}" dt="2026-10-02T01:41:32.636" v="29" actId="20577"/>
         <pc:sldMkLst>
           <pc:docMk/>
           <pc:sldMk cId="0" sldId="257"/>
         </pc:sldMkLst>
-        <pc:spChg chg="mod">
-          <ac:chgData name="202304239" userId="ab1adf7a-b8eb-4038-b404-de23e20d8a3a" providerId="ADAL" clId="{6C0E59ED-D716-49AF-B2FA-B94E7B8E5A8C}" dt="2026-10-06T05:48:43.412" v="866" actId="20577"/>
-          <ac:spMkLst>
-            <pc:docMk/>
-            <pc:sldMk cId="0" sldId="257"/>
-            <ac:spMk id="2" creationId="{00000000-0000-0000-0000-000000000000}"/>
-          </ac:spMkLst>
-        </pc:spChg>
         <pc:spChg chg="mod">
           <ac:chgData name="202304239" userId="ab1adf7a-b8eb-4038-b404-de23e20d8a3a" providerId="ADAL" clId="{6C0E59ED-D716-49AF-B2FA-B94E7B8E5A8C}" dt="2026-10-02T01:41:32.636" v="29" actId="20577"/>
           <ac:spMkLst>
@@ -173,6 +173,14 @@
           <pc:docMk/>
           <pc:sldMk cId="0" sldId="258"/>
         </pc:sldMkLst>
+        <pc:spChg chg="mod">
+          <ac:chgData name="202304239" userId="ab1adf7a-b8eb-4038-b404-de23e20d8a3a" providerId="ADAL" clId="{6C0E59ED-D716-49AF-B2FA-B94E7B8E5A8C}" dt="2026-10-02T01:15:41.310" v="14" actId="1076"/>
+          <ac:spMkLst>
+            <pc:docMk/>
+            <pc:sldMk cId="0" sldId="258"/>
+            <ac:spMk id="7" creationId="{0C0F810D-B137-252F-B137-69AD8335E4B7}"/>
+          </ac:spMkLst>
+        </pc:spChg>
       </pc:sldChg>
       <pc:sldChg chg="modSp mod">
         <pc:chgData name="202304239" userId="ab1adf7a-b8eb-4038-b404-de23e20d8a3a" providerId="ADAL" clId="{6C0E59ED-D716-49AF-B2FA-B94E7B8E5A8C}" dt="2026-10-05T03:38:03.028" v="92" actId="20577"/>
@@ -361,6 +369,37 @@
             <ac:spMk id="2" creationId="{00000000-0000-0000-0000-000000000000}"/>
           </ac:spMkLst>
         </pc:spChg>
+        <pc:picChg chg="add mod">
+          <ac:chgData name="202304239" userId="ab1adf7a-b8eb-4038-b404-de23e20d8a3a" providerId="ADAL" clId="{6C0E59ED-D716-49AF-B2FA-B94E7B8E5A8C}" dt="2026-10-03T04:13:39.011" v="59" actId="27614"/>
+          <ac:picMkLst>
+            <pc:docMk/>
+            <pc:sldMk cId="0" sldId="295"/>
+            <ac:picMk id="5" creationId="{960CE5B3-4BC1-0B00-D670-CAC2F1397BD5}"/>
+          </ac:picMkLst>
+        </pc:picChg>
+      </pc:sldChg>
+      <pc:sldChg chg="addSp delSp modSp mod">
+        <pc:chgData name="202304239" userId="ab1adf7a-b8eb-4038-b404-de23e20d8a3a" providerId="ADAL" clId="{6C0E59ED-D716-49AF-B2FA-B94E7B8E5A8C}" dt="2026-10-03T04:16:37.708" v="74" actId="14100"/>
+        <pc:sldMkLst>
+          <pc:docMk/>
+          <pc:sldMk cId="0" sldId="296"/>
+        </pc:sldMkLst>
+        <pc:spChg chg="mod">
+          <ac:chgData name="202304239" userId="ab1adf7a-b8eb-4038-b404-de23e20d8a3a" providerId="ADAL" clId="{6C0E59ED-D716-49AF-B2FA-B94E7B8E5A8C}" dt="2026-10-03T04:16:37.708" v="74" actId="14100"/>
+          <ac:spMkLst>
+            <pc:docMk/>
+            <pc:sldMk cId="0" sldId="296"/>
+            <ac:spMk id="3" creationId="{00000000-0000-0000-0000-000000000000}"/>
+          </ac:spMkLst>
+        </pc:spChg>
+        <pc:picChg chg="add mod">
+          <ac:chgData name="202304239" userId="ab1adf7a-b8eb-4038-b404-de23e20d8a3a" providerId="ADAL" clId="{6C0E59ED-D716-49AF-B2FA-B94E7B8E5A8C}" dt="2026-10-03T04:16:30.783" v="72" actId="1076"/>
+          <ac:picMkLst>
+            <pc:docMk/>
+            <pc:sldMk cId="0" sldId="296"/>
+            <ac:picMk id="7" creationId="{DBE7D927-8B33-8CDB-1BC3-DBD46AE4DF3A}"/>
+          </ac:picMkLst>
+        </pc:picChg>
       </pc:sldChg>
       <pc:sldChg chg="addSp modSp mod">
         <pc:chgData name="202304239" userId="ab1adf7a-b8eb-4038-b404-de23e20d8a3a" providerId="ADAL" clId="{6C0E59ED-D716-49AF-B2FA-B94E7B8E5A8C}" dt="2026-10-05T05:09:57.079" v="571" actId="1076"/>
@@ -391,6 +430,21 @@
             <ac:spMk id="8" creationId="{F85CD606-E3CE-F314-B3EE-F3D7028115CB}"/>
           </ac:spMkLst>
         </pc:spChg>
+        <pc:picChg chg="add mod">
+          <ac:chgData name="202304239" userId="ab1adf7a-b8eb-4038-b404-de23e20d8a3a" providerId="ADAL" clId="{6C0E59ED-D716-49AF-B2FA-B94E7B8E5A8C}" dt="2026-10-03T06:10:08.014" v="80" actId="27614"/>
+          <ac:picMkLst>
+            <pc:docMk/>
+            <pc:sldMk cId="0" sldId="299"/>
+            <ac:picMk id="5" creationId="{4380DBC0-9AA7-8727-D6C3-C05AE0BF39C9}"/>
+          </ac:picMkLst>
+        </pc:picChg>
+      </pc:sldChg>
+      <pc:sldChg chg="addSp delSp modSp mod">
+        <pc:chgData name="202304239" userId="ab1adf7a-b8eb-4038-b404-de23e20d8a3a" providerId="ADAL" clId="{6C0E59ED-D716-49AF-B2FA-B94E7B8E5A8C}" dt="2026-10-03T06:10:09.262" v="81" actId="478"/>
+        <pc:sldMkLst>
+          <pc:docMk/>
+          <pc:sldMk cId="0" sldId="300"/>
+        </pc:sldMkLst>
       </pc:sldChg>
       <pc:sldChg chg="addSp modSp mod">
         <pc:chgData name="202304239" userId="ab1adf7a-b8eb-4038-b404-de23e20d8a3a" providerId="ADAL" clId="{6C0E59ED-D716-49AF-B2FA-B94E7B8E5A8C}" dt="2026-10-05T03:47:04.200" v="139" actId="1076"/>
@@ -655,7 +709,7 @@
           <a:p>
             <a:fld id="{B414FD46-9C41-4E77-8212-EE695A2FE528}" type="datetimeFigureOut">
               <a:rPr lang="en-US" smtClean="0"/>
-              <a:t>10/6/2026</a:t>
+              <a:t>10/5/2026</a:t>
             </a:fld>
             <a:endParaRPr lang="en-US"/>
           </a:p>
@@ -923,7 +977,7 @@
 </file>
 
 <file path=ppt/notesSlides/notesSlide1.xml><?xml version="1.0" encoding="utf-8"?>
-<p:notes xmlns:a="http://schemas.openxmlformats.org/drawingml/2006/main" xmlns:r="http://schemas.openxmlformats.org/officeDocument/2006/relationships" xmlns:p="http://schemas.openxmlformats.org/presentationml/2006/main">
+<p:notes xmlns:a="http://schemas.openxmlformats.org/drawingml/2006/main" xmlns:p="http://schemas.openxmlformats.org/presentationml/2006/main" xmlns:r="http://schemas.openxmlformats.org/officeDocument/2006/relationships">
   <p:cSld>
     <p:spTree>
       <p:nvGrpSpPr>
@@ -943,7 +997,7 @@
         <p:nvSpPr>
           <p:cNvPr id="2" name="Slide Image Placeholder 1"/>
           <p:cNvSpPr>
-            <a:spLocks noGrp="1" noRot="1" noChangeAspect="1"/>
+            <a:spLocks noGrp="1"/>
           </p:cNvSpPr>
           <p:nvPr>
             <p:ph type="sldImg" idx="2"/>
@@ -958,7 +1012,7 @@
             <a:spLocks noGrp="1"/>
           </p:cNvSpPr>
           <p:nvPr>
-            <p:ph type="body" sz="quarter" idx="3"/>
+            <p:ph type="body" idx="3" sz="quarter"/>
           </p:nvPr>
         </p:nvSpPr>
         <p:spPr/>
@@ -979,7 +1033,7 @@
             <a:spLocks noGrp="1"/>
           </p:cNvSpPr>
           <p:nvPr>
-            <p:ph type="sldNum" sz="quarter" idx="5"/>
+            <p:ph type="sldNum" idx="5" sz="quarter"/>
           </p:nvPr>
         </p:nvSpPr>
         <p:spPr/>
@@ -993,7 +1047,7 @@
 </file>
 
 <file path=ppt/notesSlides/notesSlide10.xml><?xml version="1.0" encoding="utf-8"?>
-<p:notes xmlns:a="http://schemas.openxmlformats.org/drawingml/2006/main" xmlns:r="http://schemas.openxmlformats.org/officeDocument/2006/relationships" xmlns:p="http://schemas.openxmlformats.org/presentationml/2006/main">
+<p:notes xmlns:a="http://schemas.openxmlformats.org/drawingml/2006/main" xmlns:p="http://schemas.openxmlformats.org/presentationml/2006/main" xmlns:r="http://schemas.openxmlformats.org/officeDocument/2006/relationships">
   <p:cSld>
     <p:spTree>
       <p:nvGrpSpPr>
@@ -1013,7 +1067,7 @@
         <p:nvSpPr>
           <p:cNvPr id="2" name="Slide Image Placeholder 1"/>
           <p:cNvSpPr>
-            <a:spLocks noGrp="1" noRot="1" noChangeAspect="1"/>
+            <a:spLocks noGrp="1"/>
           </p:cNvSpPr>
           <p:nvPr>
             <p:ph type="sldImg" idx="2"/>
@@ -1028,7 +1082,7 @@
             <a:spLocks noGrp="1"/>
           </p:cNvSpPr>
           <p:nvPr>
-            <p:ph type="body" sz="quarter" idx="3"/>
+            <p:ph type="body" idx="3" sz="quarter"/>
           </p:nvPr>
         </p:nvSpPr>
         <p:spPr/>
@@ -1049,7 +1103,7 @@
             <a:spLocks noGrp="1"/>
           </p:cNvSpPr>
           <p:nvPr>
-            <p:ph type="sldNum" sz="quarter" idx="5"/>
+            <p:ph type="sldNum" idx="5" sz="quarter"/>
           </p:nvPr>
         </p:nvSpPr>
         <p:spPr/>
@@ -1063,7 +1117,7 @@
 </file>
 
 <file path=ppt/notesSlides/notesSlide2.xml><?xml version="1.0" encoding="utf-8"?>
-<p:notes xmlns:a="http://schemas.openxmlformats.org/drawingml/2006/main" xmlns:r="http://schemas.openxmlformats.org/officeDocument/2006/relationships" xmlns:p="http://schemas.openxmlformats.org/presentationml/2006/main">
+<p:notes xmlns:a="http://schemas.openxmlformats.org/drawingml/2006/main" xmlns:p="http://schemas.openxmlformats.org/presentationml/2006/main" xmlns:r="http://schemas.openxmlformats.org/officeDocument/2006/relationships">
   <p:cSld>
     <p:spTree>
       <p:nvGrpSpPr>
@@ -1083,7 +1137,7 @@
         <p:nvSpPr>
           <p:cNvPr id="2" name="Slide Image Placeholder 1"/>
           <p:cNvSpPr>
-            <a:spLocks noGrp="1" noRot="1" noChangeAspect="1"/>
+            <a:spLocks noGrp="1"/>
           </p:cNvSpPr>
           <p:nvPr>
             <p:ph type="sldImg" idx="2"/>
@@ -1098,7 +1152,7 @@
             <a:spLocks noGrp="1"/>
           </p:cNvSpPr>
           <p:nvPr>
-            <p:ph type="body" sz="quarter" idx="3"/>
+            <p:ph type="body" idx="3" sz="quarter"/>
           </p:nvPr>
         </p:nvSpPr>
         <p:spPr/>
@@ -1110,11 +1164,6 @@
               <a:t>図: 青＝本研究 (名目)、赤＝Totani Fig. 9 (NFW-ρ²)、緑＝何も無い空のクセ 1.2〜1.3 で割った値 (14〜15σ)。露出マップを公式の方法で作り直した結果 (results/mcmc_allbins_gasICS_v20t_irf)。Totani との比は 1.23 倍。</a:t>
             </a:r>
           </a:p>
-          <a:p>
-            <a:r>
-              <a:t>② の根拠: ICS の型紙をバブルの長方形 (|l|&lt;22°, 10°&lt;|b|&lt;55°) の内側と外側に分け、別々の強さを許すと、ハローなしでも内側が外側の 2.1 倍になり、ハローの有意度は 17.6σ → 5.7σ に下がる (ハローが良くした点数の 93% を説明; results/ics_inner_boost_irf)。だから『型紙のずれ』と『ハロー』はまだ区別できない。</a:t>
-            </a:r>
-          </a:p>
         </p:txBody>
       </p:sp>
       <p:sp>
@@ -1124,7 +1173,7 @@
             <a:spLocks noGrp="1"/>
           </p:cNvSpPr>
           <p:nvPr>
-            <p:ph type="sldNum" sz="quarter" idx="5"/>
+            <p:ph type="sldNum" idx="5" sz="quarter"/>
           </p:nvPr>
         </p:nvSpPr>
         <p:spPr/>
@@ -1138,7 +1187,7 @@
 </file>
 
 <file path=ppt/notesSlides/notesSlide3.xml><?xml version="1.0" encoding="utf-8"?>
-<p:notes xmlns:a="http://schemas.openxmlformats.org/drawingml/2006/main" xmlns:r="http://schemas.openxmlformats.org/officeDocument/2006/relationships" xmlns:p="http://schemas.openxmlformats.org/presentationml/2006/main">
+<p:notes xmlns:a="http://schemas.openxmlformats.org/drawingml/2006/main" xmlns:p="http://schemas.openxmlformats.org/presentationml/2006/main" xmlns:r="http://schemas.openxmlformats.org/officeDocument/2006/relationships">
   <p:cSld>
     <p:spTree>
       <p:nvGrpSpPr>
@@ -1158,7 +1207,7 @@
         <p:nvSpPr>
           <p:cNvPr id="2" name="Slide Image Placeholder 1"/>
           <p:cNvSpPr>
-            <a:spLocks noGrp="1" noRot="1" noChangeAspect="1"/>
+            <a:spLocks noGrp="1"/>
           </p:cNvSpPr>
           <p:nvPr>
             <p:ph type="sldImg" idx="2"/>
@@ -1173,7 +1222,7 @@
             <a:spLocks noGrp="1"/>
           </p:cNvSpPr>
           <p:nvPr>
-            <p:ph type="body" sz="quarter" idx="3"/>
+            <p:ph type="body" idx="3" sz="quarter"/>
           </p:nvPr>
         </p:nvSpPr>
         <p:spPr/>
@@ -1182,7 +1231,7 @@
           <a:lstStyle/>
           <a:p>
             <a:r>
-              <a:t>何も無い空 23 か所 × ビン 2〜10 (207 個): 平均 +0.08、ばらつき 1.19。平均が 0 からずれていない (＝引く量は無い) のに、幅が広い (＝割る量がある)。定義: 較正後の σ ＝ 名目の σ ÷ 1.2〜1.3。同じことを『名目 5 × 1.2〜1.3 ≈ 6〜6.5σ 以上を本当の 5σ とみなす』と言い換えられる。限界: 23 か所 (207 個) では 3σ くらいまでの分布しか見えない。17σ のような大きい値でも同じ倍率かは仮定。追加 (10/5 夜): 別の乱数で 23 か所の組を 3 つ作り直し、計 92 か所。20.8 GeV のばらつき 1.235 (天体単位ブートストラップ 68%: 1.15〜1.32)、ビン 2〜10 で 1.14。組ごと: 元 1.26、追加 1.32 / 1.20 / 1.16。新しい組は元の組と中心が 7° 程度しか離れない所が多く (空の広さの限界)、独立な 92 か所ではない。だから幅は少し狭く見えている。較正後の 20.8 GeV: 17.6 ÷ 1.235 = 14.2σ (13.3〜15.3σ)。results/control_spread_all_sets/summary.json標準の方法: McDaniel ほか (2024, arXiv:2311.04982) とその更新 (2026, arXiv:2605.25586) は、高緯度の何も無い方向 6,500 か所を解析し、その結果の分布で『信号が無いときの分布』を決めて有意度を出す。理由は『名目の計算は背景モデルのずれや見えない天体を考えていないので、信号が無い場合の分布として不十分』。</a:t>
+              <a:t>何も無い空 23 か所 × ビン 2〜10 (207 個): 平均 +0.08、ばらつき 1.19。平均が 0 からずれていない (＝引く量は無い) のに、幅が広い (＝割る量がある)。定義: 較正後の σ ＝ 名目の σ ÷ 1.2〜1.3。同じことを『名目 5 × 1.2〜1.3 ≈ 6〜6.5σ 以上を本当の 5σ とみなす』と言い換えられる。限界: 23 か所 (207 個) では 3σ くらいまでの分布しか見えない。17σ のような大きい値でも同じ倍率かは仮定。標準の方法: McDaniel ほか (2024, arXiv:2311.04982) とその更新 (2026, arXiv:2605.25586) は、高緯度の何も無い方向 6,500 か所を解析し、その結果の分布で『信号が無いときの分布』を決めて有意度を出す。理由は『名目の計算は背景モデルのずれや見えない天体を考えていないので、信号が無い場合の分布として不十分』。</a:t>
             </a:r>
           </a:p>
         </p:txBody>
@@ -1194,7 +1243,7 @@
             <a:spLocks noGrp="1"/>
           </p:cNvSpPr>
           <p:nvPr>
-            <p:ph type="sldNum" sz="quarter" idx="5"/>
+            <p:ph type="sldNum" idx="5" sz="quarter"/>
           </p:nvPr>
         </p:nvSpPr>
         <p:spPr/>
@@ -1208,7 +1257,7 @@
 </file>
 
 <file path=ppt/notesSlides/notesSlide4.xml><?xml version="1.0" encoding="utf-8"?>
-<p:notes xmlns:a="http://schemas.openxmlformats.org/drawingml/2006/main" xmlns:r="http://schemas.openxmlformats.org/officeDocument/2006/relationships" xmlns:p="http://schemas.openxmlformats.org/presentationml/2006/main">
+<p:notes xmlns:a="http://schemas.openxmlformats.org/drawingml/2006/main" xmlns:p="http://schemas.openxmlformats.org/presentationml/2006/main" xmlns:r="http://schemas.openxmlformats.org/officeDocument/2006/relationships">
   <p:cSld>
     <p:spTree>
       <p:nvGrpSpPr>
@@ -1228,7 +1277,7 @@
         <p:nvSpPr>
           <p:cNvPr id="2" name="Slide Image Placeholder 1"/>
           <p:cNvSpPr>
-            <a:spLocks noGrp="1" noRot="1" noChangeAspect="1"/>
+            <a:spLocks noGrp="1"/>
           </p:cNvSpPr>
           <p:nvPr>
             <p:ph type="sldImg" idx="2"/>
@@ -1243,7 +1292,7 @@
             <a:spLocks noGrp="1"/>
           </p:cNvSpPr>
           <p:nvPr>
-            <p:ph type="body" sz="quarter" idx="3"/>
+            <p:ph type="body" idx="3" sz="quarter"/>
           </p:nvPr>
         </p:nvSpPr>
         <p:spPr/>
@@ -1264,7 +1313,7 @@
             <a:spLocks noGrp="1"/>
           </p:cNvSpPr>
           <p:nvPr>
-            <p:ph type="sldNum" sz="quarter" idx="5"/>
+            <p:ph type="sldNum" idx="5" sz="quarter"/>
           </p:nvPr>
         </p:nvSpPr>
         <p:spPr/>
@@ -1278,7 +1327,7 @@
 </file>
 
 <file path=ppt/notesSlides/notesSlide5.xml><?xml version="1.0" encoding="utf-8"?>
-<p:notes xmlns:a="http://schemas.openxmlformats.org/drawingml/2006/main" xmlns:r="http://schemas.openxmlformats.org/officeDocument/2006/relationships" xmlns:p="http://schemas.openxmlformats.org/presentationml/2006/main">
+<p:notes xmlns:a="http://schemas.openxmlformats.org/drawingml/2006/main" xmlns:p="http://schemas.openxmlformats.org/presentationml/2006/main" xmlns:r="http://schemas.openxmlformats.org/officeDocument/2006/relationships">
   <p:cSld>
     <p:spTree>
       <p:nvGrpSpPr>
@@ -1298,7 +1347,7 @@
         <p:nvSpPr>
           <p:cNvPr id="2" name="Slide Image Placeholder 1"/>
           <p:cNvSpPr>
-            <a:spLocks noGrp="1" noRot="1" noChangeAspect="1"/>
+            <a:spLocks noGrp="1"/>
           </p:cNvSpPr>
           <p:nvPr>
             <p:ph type="sldImg" idx="2"/>
@@ -1313,7 +1362,7 @@
             <a:spLocks noGrp="1"/>
           </p:cNvSpPr>
           <p:nvPr>
-            <p:ph type="body" sz="quarter" idx="3"/>
+            <p:ph type="body" idx="3" sz="quarter"/>
           </p:nvPr>
         </p:nvSpPr>
         <p:spPr/>
@@ -1322,7 +1371,7 @@
           <a:lstStyle/>
           <a:p>
             <a:r>
-              <a:t>results/targets_v20_totani_fixneg_irf の control_*_spectrum.json の f_other (ハローありの最良値) と f_halo。20.8 GeV: ガス中央値 1.12、点源 0.99、ハロー (光子換算) 中央値 −0.85、範囲 −6.4〜+11.7、負が 52%。全 299 件 (23 か所 × 13 ビン) で、ガス・ICS・点源が下限 0 に張り付いた件数は 0。等方だけ、光子が 2〜13 個しかない最高 2 ビン (300 GeV 以上) で 5 件が 0 に張り付いた。ガスは 20.8 GeV でも 4 か所が 0.02〜0.06 と小さい (高緯度でガスが薄い所)。ICS は 20.8 GeV で 0.2〜5、全ビンでは最大 28、ガスは最大 17 (どちらも光子が数個〜数十個のビン)。これは背景どうしの形が似ていて分け方が決まらないため。それでも何も無い空の σ の分布は平均 +0.08 で、ハローの判定に片寄りは出ていない。ハローの係数が負になれるのは、あるか分からないものを探すので偏りを作らないため (Totani §2.3)。予測の光子数が負になる組は選ばない規則にしている。</a:t>
+              <a:t>results/targets_v20_totani_fixneg_irf の control_*_spectrum.json の f_other (ハローありの最良値) と f_halo。20.8 GeV: ガス中央値 1.12、点源 0.99、ハロー (光子換算) 中央値 −0.85、範囲 −6.4〜+11.7、負が 52%。ビン 2〜10 で ガス・ICS・点源が下限 0 に張り付いた件数は 0。ハローの係数が負になれるのは、あるか分からないものを探すので偏りを作らないため (Totani §2.3)。予測の光子数が負になる組は選ばない規則にしている。</a:t>
             </a:r>
           </a:p>
         </p:txBody>
@@ -1334,7 +1383,7 @@
             <a:spLocks noGrp="1"/>
           </p:cNvSpPr>
           <p:nvPr>
-            <p:ph type="sldNum" sz="quarter" idx="5"/>
+            <p:ph type="sldNum" idx="5" sz="quarter"/>
           </p:nvPr>
         </p:nvSpPr>
         <p:spPr/>
@@ -1348,7 +1397,7 @@
 </file>
 
 <file path=ppt/notesSlides/notesSlide6.xml><?xml version="1.0" encoding="utf-8"?>
-<p:notes xmlns:a="http://schemas.openxmlformats.org/drawingml/2006/main" xmlns:r="http://schemas.openxmlformats.org/officeDocument/2006/relationships" xmlns:p="http://schemas.openxmlformats.org/presentationml/2006/main">
+<p:notes xmlns:a="http://schemas.openxmlformats.org/drawingml/2006/main" xmlns:p="http://schemas.openxmlformats.org/presentationml/2006/main" xmlns:r="http://schemas.openxmlformats.org/officeDocument/2006/relationships">
   <p:cSld>
     <p:spTree>
       <p:nvGrpSpPr>
@@ -1368,7 +1417,7 @@
         <p:nvSpPr>
           <p:cNvPr id="2" name="Slide Image Placeholder 1"/>
           <p:cNvSpPr>
-            <a:spLocks noGrp="1" noRot="1" noChangeAspect="1"/>
+            <a:spLocks noGrp="1"/>
           </p:cNvSpPr>
           <p:nvPr>
             <p:ph type="sldImg" idx="2"/>
@@ -1383,7 +1432,7 @@
             <a:spLocks noGrp="1"/>
           </p:cNvSpPr>
           <p:nvPr>
-            <p:ph type="body" sz="quarter" idx="3"/>
+            <p:ph type="body" idx="3" sz="quarter"/>
           </p:nvPr>
         </p:nvSpPr>
         <p:spPr/>
@@ -1404,7 +1453,7 @@
             <a:spLocks noGrp="1"/>
           </p:cNvSpPr>
           <p:nvPr>
-            <p:ph type="sldNum" sz="quarter" idx="5"/>
+            <p:ph type="sldNum" idx="5" sz="quarter"/>
           </p:nvPr>
         </p:nvSpPr>
         <p:spPr/>
@@ -1418,7 +1467,7 @@
 </file>
 
 <file path=ppt/notesSlides/notesSlide7.xml><?xml version="1.0" encoding="utf-8"?>
-<p:notes xmlns:a="http://schemas.openxmlformats.org/drawingml/2006/main" xmlns:r="http://schemas.openxmlformats.org/officeDocument/2006/relationships" xmlns:p="http://schemas.openxmlformats.org/presentationml/2006/main">
+<p:notes xmlns:a="http://schemas.openxmlformats.org/drawingml/2006/main" xmlns:p="http://schemas.openxmlformats.org/presentationml/2006/main" xmlns:r="http://schemas.openxmlformats.org/officeDocument/2006/relationships">
   <p:cSld>
     <p:spTree>
       <p:nvGrpSpPr>
@@ -1438,7 +1487,7 @@
         <p:nvSpPr>
           <p:cNvPr id="2" name="Slide Image Placeholder 1"/>
           <p:cNvSpPr>
-            <a:spLocks noGrp="1" noRot="1" noChangeAspect="1"/>
+            <a:spLocks noGrp="1"/>
           </p:cNvSpPr>
           <p:nvPr>
             <p:ph type="sldImg" idx="2"/>
@@ -1453,7 +1502,7 @@
             <a:spLocks noGrp="1"/>
           </p:cNvSpPr>
           <p:nvPr>
-            <p:ph type="body" sz="quarter" idx="3"/>
+            <p:ph type="body" idx="3" sz="quarter"/>
           </p:nvPr>
         </p:nvSpPr>
         <p:spPr/>
@@ -1474,7 +1523,7 @@
             <a:spLocks noGrp="1"/>
           </p:cNvSpPr>
           <p:nvPr>
-            <p:ph type="sldNum" sz="quarter" idx="5"/>
+            <p:ph type="sldNum" idx="5" sz="quarter"/>
           </p:nvPr>
         </p:nvSpPr>
         <p:spPr/>
@@ -1488,7 +1537,7 @@
 </file>
 
 <file path=ppt/notesSlides/notesSlide8.xml><?xml version="1.0" encoding="utf-8"?>
-<p:notes xmlns:a="http://schemas.openxmlformats.org/drawingml/2006/main" xmlns:r="http://schemas.openxmlformats.org/officeDocument/2006/relationships" xmlns:p="http://schemas.openxmlformats.org/presentationml/2006/main">
+<p:notes xmlns:a="http://schemas.openxmlformats.org/drawingml/2006/main" xmlns:p="http://schemas.openxmlformats.org/presentationml/2006/main" xmlns:r="http://schemas.openxmlformats.org/officeDocument/2006/relationships">
   <p:cSld>
     <p:spTree>
       <p:nvGrpSpPr>
@@ -1508,7 +1557,7 @@
         <p:nvSpPr>
           <p:cNvPr id="2" name="Slide Image Placeholder 1"/>
           <p:cNvSpPr>
-            <a:spLocks noGrp="1" noRot="1" noChangeAspect="1"/>
+            <a:spLocks noGrp="1"/>
           </p:cNvSpPr>
           <p:nvPr>
             <p:ph type="sldImg" idx="2"/>
@@ -1523,7 +1572,7 @@
             <a:spLocks noGrp="1"/>
           </p:cNvSpPr>
           <p:nvPr>
-            <p:ph type="body" sz="quarter" idx="3"/>
+            <p:ph type="body" idx="3" sz="quarter"/>
           </p:nvPr>
         </p:nvSpPr>
         <p:spPr/>
@@ -1544,7 +1593,7 @@
             <a:spLocks noGrp="1"/>
           </p:cNvSpPr>
           <p:nvPr>
-            <p:ph type="sldNum" sz="quarter" idx="5"/>
+            <p:ph type="sldNum" idx="5" sz="quarter"/>
           </p:nvPr>
         </p:nvSpPr>
         <p:spPr/>
@@ -1558,7 +1607,7 @@
 </file>
 
 <file path=ppt/notesSlides/notesSlide9.xml><?xml version="1.0" encoding="utf-8"?>
-<p:notes xmlns:a="http://schemas.openxmlformats.org/drawingml/2006/main" xmlns:r="http://schemas.openxmlformats.org/officeDocument/2006/relationships" xmlns:p="http://schemas.openxmlformats.org/presentationml/2006/main">
+<p:notes xmlns:a="http://schemas.openxmlformats.org/drawingml/2006/main" xmlns:p="http://schemas.openxmlformats.org/presentationml/2006/main" xmlns:r="http://schemas.openxmlformats.org/officeDocument/2006/relationships">
   <p:cSld>
     <p:spTree>
       <p:nvGrpSpPr>
@@ -1578,7 +1627,7 @@
         <p:nvSpPr>
           <p:cNvPr id="2" name="Slide Image Placeholder 1"/>
           <p:cNvSpPr>
-            <a:spLocks noGrp="1" noRot="1" noChangeAspect="1"/>
+            <a:spLocks noGrp="1"/>
           </p:cNvSpPr>
           <p:nvPr>
             <p:ph type="sldImg" idx="2"/>
@@ -1593,7 +1642,7 @@
             <a:spLocks noGrp="1"/>
           </p:cNvSpPr>
           <p:nvPr>
-            <p:ph type="body" sz="quarter" idx="3"/>
+            <p:ph type="body" idx="3" sz="quarter"/>
           </p:nvPr>
         </p:nvSpPr>
         <p:spPr/>
@@ -1614,7 +1663,7 @@
             <a:spLocks noGrp="1"/>
           </p:cNvSpPr>
           <p:nvPr>
-            <p:ph type="sldNum" sz="quarter" idx="5"/>
+            <p:ph type="sldNum" idx="5" sz="quarter"/>
           </p:nvPr>
         </p:nvSpPr>
         <p:spPr/>
@@ -1774,7 +1823,7 @@
           <a:p>
             <a:fld id="{030FFF5C-2D96-4D39-AE5C-E4AC30C80AB5}" type="datetimeFigureOut">
               <a:rPr lang="en-US" smtClean="0"/>
-              <a:t>10/6/2026</a:t>
+              <a:t>10/5/2026</a:t>
             </a:fld>
             <a:endParaRPr lang="en-US"/>
           </a:p>
@@ -1972,7 +2021,7 @@
           <a:p>
             <a:fld id="{030FFF5C-2D96-4D39-AE5C-E4AC30C80AB5}" type="datetimeFigureOut">
               <a:rPr lang="en-US" smtClean="0"/>
-              <a:t>10/6/2026</a:t>
+              <a:t>10/5/2026</a:t>
             </a:fld>
             <a:endParaRPr lang="en-US"/>
           </a:p>
@@ -2180,7 +2229,7 @@
           <a:p>
             <a:fld id="{030FFF5C-2D96-4D39-AE5C-E4AC30C80AB5}" type="datetimeFigureOut">
               <a:rPr lang="en-US" smtClean="0"/>
-              <a:t>10/6/2026</a:t>
+              <a:t>10/5/2026</a:t>
             </a:fld>
             <a:endParaRPr lang="en-US"/>
           </a:p>
@@ -2378,7 +2427,7 @@
           <a:p>
             <a:fld id="{030FFF5C-2D96-4D39-AE5C-E4AC30C80AB5}" type="datetimeFigureOut">
               <a:rPr lang="en-US" smtClean="0"/>
-              <a:t>10/6/2026</a:t>
+              <a:t>10/5/2026</a:t>
             </a:fld>
             <a:endParaRPr lang="en-US"/>
           </a:p>
@@ -2653,7 +2702,7 @@
           <a:p>
             <a:fld id="{030FFF5C-2D96-4D39-AE5C-E4AC30C80AB5}" type="datetimeFigureOut">
               <a:rPr lang="en-US" smtClean="0"/>
-              <a:t>10/6/2026</a:t>
+              <a:t>10/5/2026</a:t>
             </a:fld>
             <a:endParaRPr lang="en-US"/>
           </a:p>
@@ -2918,7 +2967,7 @@
           <a:p>
             <a:fld id="{030FFF5C-2D96-4D39-AE5C-E4AC30C80AB5}" type="datetimeFigureOut">
               <a:rPr lang="en-US" smtClean="0"/>
-              <a:t>10/6/2026</a:t>
+              <a:t>10/5/2026</a:t>
             </a:fld>
             <a:endParaRPr lang="en-US"/>
           </a:p>
@@ -3330,7 +3379,7 @@
           <a:p>
             <a:fld id="{030FFF5C-2D96-4D39-AE5C-E4AC30C80AB5}" type="datetimeFigureOut">
               <a:rPr lang="en-US" smtClean="0"/>
-              <a:t>10/6/2026</a:t>
+              <a:t>10/5/2026</a:t>
             </a:fld>
             <a:endParaRPr lang="en-US"/>
           </a:p>
@@ -3471,7 +3520,7 @@
           <a:p>
             <a:fld id="{030FFF5C-2D96-4D39-AE5C-E4AC30C80AB5}" type="datetimeFigureOut">
               <a:rPr lang="en-US" smtClean="0"/>
-              <a:t>10/6/2026</a:t>
+              <a:t>10/5/2026</a:t>
             </a:fld>
             <a:endParaRPr lang="en-US"/>
           </a:p>
@@ -3584,7 +3633,7 @@
           <a:p>
             <a:fld id="{030FFF5C-2D96-4D39-AE5C-E4AC30C80AB5}" type="datetimeFigureOut">
               <a:rPr lang="en-US" smtClean="0"/>
-              <a:t>10/6/2026</a:t>
+              <a:t>10/5/2026</a:t>
             </a:fld>
             <a:endParaRPr lang="en-US"/>
           </a:p>
@@ -3895,7 +3944,7 @@
           <a:p>
             <a:fld id="{030FFF5C-2D96-4D39-AE5C-E4AC30C80AB5}" type="datetimeFigureOut">
               <a:rPr lang="en-US" smtClean="0"/>
-              <a:t>10/6/2026</a:t>
+              <a:t>10/5/2026</a:t>
             </a:fld>
             <a:endParaRPr lang="en-US"/>
           </a:p>
@@ -4183,7 +4232,7 @@
           <a:p>
             <a:fld id="{030FFF5C-2D96-4D39-AE5C-E4AC30C80AB5}" type="datetimeFigureOut">
               <a:rPr lang="en-US" smtClean="0"/>
-              <a:t>10/6/2026</a:t>
+              <a:t>10/5/2026</a:t>
             </a:fld>
             <a:endParaRPr lang="en-US"/>
           </a:p>
@@ -4424,7 +4473,7 @@
           <a:p>
             <a:fld id="{030FFF5C-2D96-4D39-AE5C-E4AC30C80AB5}" type="datetimeFigureOut">
               <a:rPr lang="en-US" smtClean="0"/>
-              <a:t>10/6/2026</a:t>
+              <a:t>10/5/2026</a:t>
             </a:fld>
             <a:endParaRPr lang="en-US"/>
           </a:p>
@@ -4825,7 +4874,7 @@
 </file>
 
 <file path=ppt/slides/slide1.xml><?xml version="1.0" encoding="utf-8"?>
-<p:sld xmlns:a="http://schemas.openxmlformats.org/drawingml/2006/main" xmlns:r="http://schemas.openxmlformats.org/officeDocument/2006/relationships" xmlns:p="http://schemas.openxmlformats.org/presentationml/2006/main">
+<p:sld xmlns:a="http://schemas.openxmlformats.org/drawingml/2006/main" xmlns:p="http://schemas.openxmlformats.org/presentationml/2006/main" xmlns:r="http://schemas.openxmlformats.org/officeDocument/2006/relationships">
   <p:cSld>
     <p:spTree>
       <p:nvGrpSpPr>
@@ -4833,14 +4882,7 @@
         <p:cNvGrpSpPr/>
         <p:nvPr/>
       </p:nvGrpSpPr>
-      <p:grpSpPr>
-        <a:xfrm>
-          <a:off x="0" y="0"/>
-          <a:ext cx="0" cy="0"/>
-          <a:chOff x="0" y="0"/>
-          <a:chExt cx="0" cy="0"/>
-        </a:xfrm>
-      </p:grpSpPr>
+      <p:grpSpPr/>
       <p:sp>
         <p:nvSpPr>
           <p:cNvPr id="2" name="Title 1"/>
@@ -4900,7 +4942,7 @@
 </file>
 
 <file path=ppt/slides/slide10.xml><?xml version="1.0" encoding="utf-8"?>
-<p:sld xmlns:a="http://schemas.openxmlformats.org/drawingml/2006/main" xmlns:r="http://schemas.openxmlformats.org/officeDocument/2006/relationships" xmlns:p="http://schemas.openxmlformats.org/presentationml/2006/main">
+<p:sld xmlns:a="http://schemas.openxmlformats.org/drawingml/2006/main" xmlns:p="http://schemas.openxmlformats.org/presentationml/2006/main" xmlns:r="http://schemas.openxmlformats.org/officeDocument/2006/relationships">
   <p:cSld>
     <p:spTree>
       <p:nvGrpSpPr>
@@ -4908,14 +4950,7 @@
         <p:cNvGrpSpPr/>
         <p:nvPr/>
       </p:nvGrpSpPr>
-      <p:grpSpPr>
-        <a:xfrm>
-          <a:off x="0" y="0"/>
-          <a:ext cx="0" cy="0"/>
-          <a:chOff x="0" y="0"/>
-          <a:chExt cx="0" cy="0"/>
-        </a:xfrm>
-      </p:grpSpPr>
+      <p:grpSpPr/>
       <p:sp>
         <p:nvSpPr>
           <p:cNvPr id="2" name="Title 1"/>
@@ -4932,7 +4967,7 @@
           <a:lstStyle/>
           <a:p>
             <a:r>
-              <a:rPr lang="ja-JP" sz="3000">
+              <a:rPr sz="3000" lang="ja-JP">
                 <a:latin typeface="+mj-lt"/>
                 <a:ea typeface="+mj-ea"/>
               </a:rPr>
@@ -4949,7 +4984,7 @@
         </p:nvSpPr>
         <p:spPr>
           <a:xfrm>
-            <a:off x="548640" y="1463040"/>
+            <a:off x="548640" y="1280160"/>
             <a:ext cx="11155680" cy="4572000"/>
           </a:xfrm>
           <a:prstGeom prst="rect">
@@ -4963,13 +4998,13 @@
           </a:bodyPr>
           <a:lstStyle/>
           <a:p>
-            <a:pPr marL="274320" indent="-274320">
+            <a:pPr>
               <a:spcAft>
                 <a:spcPts val="500"/>
               </a:spcAft>
             </a:pPr>
             <a:r>
-              <a:rPr lang="ja-JP" sz="2200" b="1">
+              <a:rPr sz="1900" b="1" lang="ja-JP">
                 <a:latin typeface="+mn-lt"/>
                 <a:ea typeface="+mn-ea"/>
               </a:rPr>
@@ -4977,41 +5012,41 @@
             </a:r>
           </a:p>
           <a:p>
-            <a:pPr marL="548640" indent="0">
+            <a:pPr>
               <a:spcAft>
                 <a:spcPts val="500"/>
               </a:spcAft>
             </a:pPr>
             <a:r>
-              <a:rPr lang="ja-JP" sz="1900" b="0">
+              <a:rPr sz="1600" b="0" lang="ja-JP">
                 <a:latin typeface="+mn-lt"/>
                 <a:ea typeface="+mn-ea"/>
               </a:rPr>
-              <a:t>シミュレーションの誤差を統計に入れる方法（データ同化）で扱いたい</a:t>
-            </a:r>
-          </a:p>
-          <a:p>
-            <a:pPr marL="274320" indent="-274320">
+              <a:t>　　シミュレーションの誤差を統計に入れる方法（データ同化）で扱いたい</a:t>
+            </a:r>
+          </a:p>
+          <a:p>
+            <a:pPr>
               <a:spcAft>
                 <a:spcPts val="500"/>
               </a:spcAft>
             </a:pPr>
             <a:r>
-              <a:rPr lang="ja-JP" sz="2200" b="0">
+              <a:rPr sz="1900" b="0" lang="ja-JP">
                 <a:latin typeface="+mn-lt"/>
                 <a:ea typeface="+mn-ea"/>
               </a:rPr>
-              <a:t>・何も無い空は 92 か所で 1.24 倍を確認。でも 17σ のような大きい値で同じ倍率かは、まだ仮定</a:t>
-            </a:r>
-          </a:p>
-          <a:p>
-            <a:pPr marL="274320" indent="-274320">
+              <a:t>・何も無い空を 23 → 数百か所に増やす（標準は 6,500 か所）</a:t>
+            </a:r>
+          </a:p>
+          <a:p>
+            <a:pPr>
               <a:spcAft>
                 <a:spcPts val="500"/>
               </a:spcAft>
             </a:pPr>
             <a:r>
-              <a:rPr lang="ja-JP" sz="2200" b="0">
+              <a:rPr sz="1900" b="0" lang="ja-JP">
                 <a:latin typeface="+mn-lt"/>
                 <a:ea typeface="+mn-ea"/>
               </a:rPr>
@@ -5019,27 +5054,27 @@
             </a:r>
           </a:p>
           <a:p>
-            <a:pPr marL="274320" indent="-274320">
+            <a:pPr>
               <a:spcAft>
                 <a:spcPts val="500"/>
               </a:spcAft>
             </a:pPr>
             <a:r>
-              <a:rPr lang="ja-JP" sz="2200" b="0">
+              <a:rPr sz="1900" b="0" lang="ja-JP">
                 <a:latin typeface="+mn-lt"/>
                 <a:ea typeface="+mn-ea"/>
               </a:rPr>
-              <a:t>・ICS の型紙の形のずれ（中心付近 2 倍）は、まだ否定できていない</a:t>
-            </a:r>
-          </a:p>
-          <a:p>
-            <a:pPr marL="274320" indent="-274320">
+              <a:t>・ICS の「空での形」のずれは、まだ否定できていない</a:t>
+            </a:r>
+          </a:p>
+          <a:p>
+            <a:pPr>
               <a:spcAft>
                 <a:spcPts val="500"/>
               </a:spcAft>
             </a:pPr>
             <a:r>
-              <a:rPr lang="ja-JP" sz="2200" b="1">
+              <a:rPr sz="1900" b="1" lang="ja-JP">
                 <a:latin typeface="+mn-lt"/>
                 <a:ea typeface="+mn-ea"/>
               </a:rPr>
@@ -5057,7 +5092,7 @@
 </file>
 
 <file path=ppt/slides/slide2.xml><?xml version="1.0" encoding="utf-8"?>
-<p:sld xmlns:a="http://schemas.openxmlformats.org/drawingml/2006/main" xmlns:r="http://schemas.openxmlformats.org/officeDocument/2006/relationships" xmlns:p="http://schemas.openxmlformats.org/presentationml/2006/main">
+<p:sld xmlns:a="http://schemas.openxmlformats.org/drawingml/2006/main" xmlns:p="http://schemas.openxmlformats.org/presentationml/2006/main" xmlns:r="http://schemas.openxmlformats.org/officeDocument/2006/relationships">
   <p:cSld>
     <p:spTree>
       <p:nvGrpSpPr>
@@ -5065,14 +5100,7 @@
         <p:cNvGrpSpPr/>
         <p:nvPr/>
       </p:nvGrpSpPr>
-      <p:grpSpPr>
-        <a:xfrm>
-          <a:off x="0" y="0"/>
-          <a:ext cx="0" cy="0"/>
-          <a:chOff x="0" y="0"/>
-          <a:chExt cx="0" cy="0"/>
-        </a:xfrm>
-      </p:grpSpPr>
+      <p:grpSpPr/>
       <p:sp>
         <p:nvSpPr>
           <p:cNvPr id="2" name="Title 1"/>
@@ -5089,11 +5117,11 @@
           <a:lstStyle/>
           <a:p>
             <a:r>
-              <a:rPr lang="ja-JP" sz="3000">
+              <a:rPr sz="3000" lang="ja-JP">
                 <a:latin typeface="+mj-lt"/>
                 <a:ea typeface="+mj-ea"/>
               </a:rPr>
-              <a:t>結論：わかったこと 3 つ</a:t>
+              <a:t>まず結論：わかったこと 3 つ</a:t>
             </a:r>
           </a:p>
         </p:txBody>
@@ -5106,7 +5134,7 @@
         </p:nvSpPr>
         <p:spPr>
           <a:xfrm>
-            <a:off x="548640" y="1463040"/>
+            <a:off x="548640" y="1280160"/>
             <a:ext cx="6035040" cy="4754880"/>
           </a:xfrm>
           <a:prstGeom prst="rect">
@@ -5120,13 +5148,13 @@
           </a:bodyPr>
           <a:lstStyle/>
           <a:p>
-            <a:pPr marL="274320" indent="-274320">
+            <a:pPr>
               <a:spcAft>
                 <a:spcPts val="500"/>
               </a:spcAft>
             </a:pPr>
             <a:r>
-              <a:rPr lang="ja-JP" sz="1900" b="0">
+              <a:rPr sz="1900" b="0" lang="ja-JP">
                 <a:latin typeface="+mn-lt"/>
                 <a:ea typeface="+mn-ea"/>
               </a:rPr>
@@ -5134,13 +5162,13 @@
             </a:r>
           </a:p>
           <a:p>
-            <a:pPr marL="274320" indent="-274320">
+            <a:pPr>
               <a:spcAft>
                 <a:spcPts val="500"/>
               </a:spcAft>
             </a:pPr>
             <a:r>
-              <a:rPr lang="ja-JP" sz="1900" b="1">
+              <a:rPr sz="1900" b="1" lang="ja-JP">
                 <a:latin typeface="+mn-lt"/>
                 <a:ea typeface="+mn-ea"/>
               </a:rPr>
@@ -5148,69 +5176,69 @@
             </a:r>
           </a:p>
           <a:p>
-            <a:pPr marL="548640" indent="0">
+            <a:pPr>
               <a:spcAft>
                 <a:spcPts val="500"/>
               </a:spcAft>
             </a:pPr>
             <a:r>
-              <a:rPr lang="ja-JP" sz="1600" b="0">
+              <a:rPr sz="1600" b="0" lang="ja-JP">
                 <a:latin typeface="+mn-lt"/>
                 <a:ea typeface="+mn-ea"/>
               </a:rPr>
-              <a:t>20.8 GeV で 17.6σ（Totani の同じ形は 14.3σ）</a:t>
-            </a:r>
-          </a:p>
-          <a:p>
-            <a:pPr marL="548640" indent="0">
+              <a:t>　　20.8 GeV で 17.6σ（Totani の同じ形は 14.3σ）</a:t>
+            </a:r>
+          </a:p>
+          <a:p>
+            <a:pPr>
               <a:spcAft>
                 <a:spcPts val="500"/>
               </a:spcAft>
             </a:pPr>
             <a:r>
-              <a:rPr lang="ja-JP" sz="1600" b="0">
+              <a:rPr sz="1600" b="0" lang="ja-JP">
                 <a:latin typeface="+mn-lt"/>
                 <a:ea typeface="+mn-ea"/>
               </a:rPr>
-              <a:t>山の位置・形・一番合うハローの形が一致</a:t>
-            </a:r>
-          </a:p>
-          <a:p>
-            <a:pPr marL="274320" indent="-274320">
+              <a:t>　　山の位置・形・一番合うハローの形が一致</a:t>
+            </a:r>
+          </a:p>
+          <a:p>
+            <a:pPr>
               <a:spcAft>
                 <a:spcPts val="500"/>
               </a:spcAft>
             </a:pPr>
             <a:r>
-              <a:rPr lang="ja-JP" sz="1900" b="1">
+              <a:rPr sz="1900" b="1" lang="ja-JP">
                 <a:latin typeface="+mn-lt"/>
                 <a:ea typeface="+mn-ea"/>
               </a:rPr>
-              <a:t>・② でも、暗黒物質とはまだ決められない</a:t>
-            </a:r>
-          </a:p>
-          <a:p>
-            <a:pPr marL="548640" indent="0">
+              <a:t>・② 背景（ICS・バブル）の計算の間違いでは説明できない</a:t>
+            </a:r>
+          </a:p>
+          <a:p>
+            <a:pPr>
               <a:spcAft>
                 <a:spcPts val="500"/>
               </a:spcAft>
             </a:pPr>
             <a:r>
-              <a:rPr lang="ja-JP" sz="1600" b="0">
+              <a:rPr sz="1600" b="0" lang="ja-JP">
                 <a:latin typeface="+mn-lt"/>
                 <a:ea typeface="+mn-ea"/>
               </a:rPr>
-              <a:t>背景の光（ICS）の型紙が中心付近で 2 倍ずれていても、ほぼ同じ結果になる</a:t>
-            </a:r>
-          </a:p>
-          <a:p>
-            <a:pPr marL="274320" indent="-274320">
+              <a:t>　　ただし、暗黒物質の証拠とまでは言えない</a:t>
+            </a:r>
+          </a:p>
+          <a:p>
+            <a:pPr>
               <a:spcAft>
                 <a:spcPts val="500"/>
               </a:spcAft>
             </a:pPr>
             <a:r>
-              <a:rPr lang="ja-JP" sz="1900" b="1">
+              <a:rPr sz="1900" b="1" lang="ja-JP">
                 <a:latin typeface="+mn-lt"/>
                 <a:ea typeface="+mn-ea"/>
               </a:rPr>
@@ -5218,17 +5246,17 @@
             </a:r>
           </a:p>
           <a:p>
-            <a:pPr marL="548640" indent="0">
+            <a:pPr>
               <a:spcAft>
                 <a:spcPts val="500"/>
               </a:spcAft>
             </a:pPr>
             <a:r>
-              <a:rPr lang="ja-JP" sz="1600" b="0">
+              <a:rPr sz="1600" b="0" lang="ja-JP">
                 <a:latin typeface="+mn-lt"/>
                 <a:ea typeface="+mn-ea"/>
               </a:rPr>
-              <a:t>でも「無い」とも言えない（判定できない）</a:t>
+              <a:t>　　でも「無い」とも言えない（判定できない）</a:t>
             </a:r>
           </a:p>
         </p:txBody>
@@ -5242,7 +5270,7 @@
           <p:nvPr/>
         </p:nvPicPr>
         <p:blipFill>
-          <a:blip r:embed="rId3"/>
+          <a:blip r:embed="rId2"/>
           <a:stretch>
             <a:fillRect/>
           </a:stretch>
@@ -5266,7 +5294,7 @@
 </file>
 
 <file path=ppt/slides/slide3.xml><?xml version="1.0" encoding="utf-8"?>
-<p:sld xmlns:a="http://schemas.openxmlformats.org/drawingml/2006/main" xmlns:r="http://schemas.openxmlformats.org/officeDocument/2006/relationships" xmlns:p="http://schemas.openxmlformats.org/presentationml/2006/main">
+<p:sld xmlns:a="http://schemas.openxmlformats.org/drawingml/2006/main" xmlns:p="http://schemas.openxmlformats.org/presentationml/2006/main" xmlns:r="http://schemas.openxmlformats.org/officeDocument/2006/relationships">
   <p:cSld>
     <p:spTree>
       <p:nvGrpSpPr>
@@ -5274,14 +5302,7 @@
         <p:cNvGrpSpPr/>
         <p:nvPr/>
       </p:nvGrpSpPr>
-      <p:grpSpPr>
-        <a:xfrm>
-          <a:off x="0" y="0"/>
-          <a:ext cx="0" cy="0"/>
-          <a:chOff x="0" y="0"/>
-          <a:chExt cx="0" cy="0"/>
-        </a:xfrm>
-      </p:grpSpPr>
+      <p:grpSpPr/>
       <p:sp>
         <p:nvSpPr>
           <p:cNvPr id="2" name="Title 1"/>
@@ -5298,11 +5319,11 @@
           <a:lstStyle/>
           <a:p>
             <a:r>
-              <a:rPr lang="ja-JP" sz="3000">
+              <a:rPr sz="3000" lang="ja-JP">
                 <a:latin typeface="+mj-lt"/>
                 <a:ea typeface="+mj-ea"/>
               </a:rPr>
-              <a:t>疑問①：1.2〜1.3 は「引く」？「割る」？</a:t>
+              <a:t>先週の疑問①：1.2〜1.3 は「引く」？「割る」？</a:t>
             </a:r>
           </a:p>
         </p:txBody>
@@ -5315,7 +5336,7 @@
         </p:nvSpPr>
         <p:spPr>
           <a:xfrm>
-            <a:off x="548640" y="1463040"/>
+            <a:off x="548640" y="1280160"/>
             <a:ext cx="5852160" cy="4937760"/>
           </a:xfrm>
           <a:prstGeom prst="rect">
@@ -5329,13 +5350,13 @@
           </a:bodyPr>
           <a:lstStyle/>
           <a:p>
-            <a:pPr marL="274320" indent="-274320">
+            <a:pPr>
               <a:spcAft>
                 <a:spcPts val="500"/>
               </a:spcAft>
             </a:pPr>
             <a:r>
-              <a:rPr lang="ja-JP" sz="1700" b="0">
+              <a:rPr sz="1700" b="0" lang="ja-JP">
                 <a:latin typeface="+mn-lt"/>
                 <a:ea typeface="+mn-ea"/>
               </a:rPr>
@@ -5343,13 +5364,13 @@
             </a:r>
           </a:p>
           <a:p>
-            <a:pPr marL="274320" indent="-274320">
+            <a:pPr>
               <a:spcAft>
                 <a:spcPts val="500"/>
               </a:spcAft>
             </a:pPr>
             <a:r>
-              <a:rPr lang="ja-JP" sz="1700" b="1">
+              <a:rPr sz="1700" b="1" lang="ja-JP">
                 <a:latin typeface="+mn-lt"/>
                 <a:ea typeface="+mn-ea"/>
               </a:rPr>
@@ -5357,27 +5378,27 @@
             </a:r>
           </a:p>
           <a:p>
-            <a:pPr marL="548640" indent="0">
+            <a:pPr>
               <a:spcAft>
                 <a:spcPts val="500"/>
               </a:spcAft>
             </a:pPr>
             <a:r>
-              <a:rPr lang="ja-JP" sz="1400" b="0">
+              <a:rPr sz="1400" b="0" lang="ja-JP">
                 <a:latin typeface="+mn-lt"/>
                 <a:ea typeface="+mn-ea"/>
               </a:rPr>
-              <a:t>たとえ：目盛りが 1.2 倍に伸びた定規。引き算では直らず、1.2 で割ると直る</a:t>
-            </a:r>
-          </a:p>
-          <a:p>
-            <a:pPr marL="274320" indent="-274320">
+              <a:t>　　たとえ：目盛りが 1.2 倍に伸びた定規。引き算では直らず、1.2 で割ると直る</a:t>
+            </a:r>
+          </a:p>
+          <a:p>
+            <a:pPr>
               <a:spcAft>
                 <a:spcPts val="500"/>
               </a:spcAft>
             </a:pPr>
             <a:r>
-              <a:rPr lang="ja-JP" sz="1700" b="0">
+              <a:rPr sz="1700" b="0" lang="ja-JP">
                 <a:latin typeface="+mn-lt"/>
                 <a:ea typeface="+mn-ea"/>
               </a:rPr>
@@ -5385,13 +5406,13 @@
             </a:r>
           </a:p>
           <a:p>
-            <a:pPr marL="274320" indent="-274320">
+            <a:pPr>
               <a:spcAft>
                 <a:spcPts val="500"/>
               </a:spcAft>
             </a:pPr>
             <a:r>
-              <a:rPr lang="ja-JP" sz="1700" b="0">
+              <a:rPr sz="1700" b="0" lang="ja-JP">
                 <a:latin typeface="+mn-lt"/>
                 <a:ea typeface="+mn-ea"/>
               </a:rPr>
@@ -5399,13 +5420,13 @@
             </a:r>
           </a:p>
           <a:p>
-            <a:pPr marL="274320" indent="-274320">
+            <a:pPr>
               <a:spcAft>
                 <a:spcPts val="500"/>
               </a:spcAft>
             </a:pPr>
             <a:r>
-              <a:rPr lang="ja-JP" sz="1700" b="0">
+              <a:rPr sz="1700" b="0" lang="ja-JP">
                 <a:latin typeface="+mn-lt"/>
                 <a:ea typeface="+mn-ea"/>
               </a:rPr>
@@ -5423,7 +5444,7 @@
           <p:nvPr/>
         </p:nvPicPr>
         <p:blipFill>
-          <a:blip r:embed="rId3"/>
+          <a:blip r:embed="rId2"/>
           <a:stretch>
             <a:fillRect/>
           </a:stretch>
@@ -5447,7 +5468,7 @@
 </file>
 
 <file path=ppt/slides/slide4.xml><?xml version="1.0" encoding="utf-8"?>
-<p:sld xmlns:a="http://schemas.openxmlformats.org/drawingml/2006/main" xmlns:r="http://schemas.openxmlformats.org/officeDocument/2006/relationships" xmlns:p="http://schemas.openxmlformats.org/presentationml/2006/main">
+<p:sld xmlns:a="http://schemas.openxmlformats.org/drawingml/2006/main" xmlns:p="http://schemas.openxmlformats.org/presentationml/2006/main" xmlns:r="http://schemas.openxmlformats.org/officeDocument/2006/relationships">
   <p:cSld>
     <p:spTree>
       <p:nvGrpSpPr>
@@ -5455,14 +5476,7 @@
         <p:cNvGrpSpPr/>
         <p:nvPr/>
       </p:nvGrpSpPr>
-      <p:grpSpPr>
-        <a:xfrm>
-          <a:off x="0" y="0"/>
-          <a:ext cx="0" cy="0"/>
-          <a:chOff x="0" y="0"/>
-          <a:chExt cx="0" cy="0"/>
-        </a:xfrm>
-      </p:grpSpPr>
+      <p:grpSpPr/>
       <p:sp>
         <p:nvSpPr>
           <p:cNvPr id="2" name="Title 1"/>
@@ -5479,11 +5493,11 @@
           <a:lstStyle/>
           <a:p>
             <a:r>
-              <a:rPr lang="ja-JP" sz="3000">
+              <a:rPr sz="3000" lang="ja-JP">
                 <a:latin typeface="+mj-lt"/>
                 <a:ea typeface="+mj-ea"/>
               </a:rPr>
-              <a:t>疑問②：何も無い空はどこから？　0 ではだめ？</a:t>
+              <a:t>先週の疑問②：何も無い空はどこから？パラメータ 0 ではだめ？</a:t>
             </a:r>
           </a:p>
         </p:txBody>
@@ -5496,7 +5510,7 @@
         </p:nvSpPr>
         <p:spPr>
           <a:xfrm>
-            <a:off x="548640" y="1463040"/>
+            <a:off x="548640" y="1280160"/>
             <a:ext cx="5852160" cy="4937760"/>
           </a:xfrm>
           <a:prstGeom prst="rect">
@@ -5510,13 +5524,13 @@
           </a:bodyPr>
           <a:lstStyle/>
           <a:p>
-            <a:pPr marL="274320" indent="-274320">
+            <a:pPr>
               <a:spcAft>
                 <a:spcPts val="500"/>
               </a:spcAft>
             </a:pPr>
             <a:r>
-              <a:rPr lang="ja-JP" sz="1700" b="0">
+              <a:rPr sz="1700" b="0" lang="ja-JP">
                 <a:latin typeface="+mn-lt"/>
                 <a:ea typeface="+mn-ea"/>
               </a:rPr>
@@ -5524,27 +5538,27 @@
             </a:r>
           </a:p>
           <a:p>
-            <a:pPr marL="548640" indent="0">
+            <a:pPr>
               <a:spcAft>
                 <a:spcPts val="500"/>
               </a:spcAft>
             </a:pPr>
             <a:r>
-              <a:rPr lang="ja-JP" sz="1400" b="0">
+              <a:rPr sz="1400" b="0" lang="ja-JP">
                 <a:latin typeface="+mn-lt"/>
                 <a:ea typeface="+mn-ea"/>
               </a:rPr>
-              <a:t>「何も無い」＝探している天体が無い。背景の光（ガス・ICS・遠い銀河）はどこにでもある → だから係数を合わせる</a:t>
-            </a:r>
-          </a:p>
-          <a:p>
-            <a:pPr marL="274320" indent="-274320">
+              <a:t>　　「何も無い」＝探している天体が無い。背景の光（ガス・ICS・遠い銀河）はどこにでもある → だから係数を合わせる</a:t>
+            </a:r>
+          </a:p>
+          <a:p>
+            <a:pPr>
               <a:spcAft>
                 <a:spcPts val="500"/>
               </a:spcAft>
             </a:pPr>
             <a:r>
-              <a:rPr lang="ja-JP" sz="1700" b="0">
+              <a:rPr sz="1700" b="0" lang="ja-JP">
                 <a:latin typeface="+mn-lt"/>
                 <a:ea typeface="+mn-ea"/>
               </a:rPr>
@@ -5552,27 +5566,27 @@
             </a:r>
           </a:p>
           <a:p>
-            <a:pPr marL="548640" indent="0">
+            <a:pPr>
               <a:spcAft>
                 <a:spcPts val="500"/>
               </a:spcAft>
             </a:pPr>
             <a:r>
-              <a:rPr lang="ja-JP" sz="1400" b="0">
+              <a:rPr sz="1400" b="0" lang="ja-JP">
                 <a:latin typeface="+mn-lt"/>
                 <a:ea typeface="+mn-ea"/>
               </a:rPr>
-              <a:t>→ 計算のやり方そのものは正しい</a:t>
-            </a:r>
-          </a:p>
-          <a:p>
-            <a:pPr marL="274320" indent="-274320">
+              <a:t>　　→ 計算のやり方そのものは正しい</a:t>
+            </a:r>
+          </a:p>
+          <a:p>
+            <a:pPr>
               <a:spcAft>
                 <a:spcPts val="500"/>
               </a:spcAft>
             </a:pPr>
             <a:r>
-              <a:rPr lang="ja-JP" sz="1700" b="1">
+              <a:rPr sz="1700" b="1" lang="ja-JP">
                 <a:latin typeface="+mn-lt"/>
                 <a:ea typeface="+mn-ea"/>
               </a:rPr>
@@ -5580,45 +5594,31 @@
             </a:r>
           </a:p>
           <a:p>
-            <a:pPr marL="548640" indent="0">
+            <a:pPr>
               <a:spcAft>
                 <a:spcPts val="500"/>
               </a:spcAft>
             </a:pPr>
             <a:r>
-              <a:rPr lang="ja-JP" sz="1400" b="0">
+              <a:rPr sz="1400" b="0" lang="ja-JP">
                 <a:latin typeface="+mn-lt"/>
                 <a:ea typeface="+mn-ea"/>
               </a:rPr>
-              <a:t>型紙のずれ・まだ見つかっていない暗い天体</a:t>
-            </a:r>
-          </a:p>
-          <a:p>
-            <a:pPr marL="274320" indent="-274320">
+              <a:t>　　型紙のずれ・まだ見つかっていない暗い天体</a:t>
+            </a:r>
+          </a:p>
+          <a:p>
+            <a:pPr>
               <a:spcAft>
                 <a:spcPts val="500"/>
               </a:spcAft>
             </a:pPr>
             <a:r>
-              <a:rPr lang="ja-JP" sz="1700" b="0">
+              <a:rPr sz="1700" b="0" lang="ja-JP">
                 <a:latin typeface="+mn-lt"/>
                 <a:ea typeface="+mn-ea"/>
               </a:rPr>
               <a:t>・本物の空を使うのは、それを測るため（Fermi チームの標準と同じ）</a:t>
-            </a:r>
-          </a:p>
-          <a:p>
-            <a:pPr marL="274320" indent="-274320">
-              <a:spcAft>
-                <a:spcPts val="500"/>
-              </a:spcAft>
-            </a:pPr>
-            <a:r>
-              <a:rPr lang="ja-JP" sz="1700" b="1">
-                <a:latin typeface="+mn-lt"/>
-                <a:ea typeface="+mn-ea"/>
-              </a:rPr>
-              <a:t>・置き方を変えて 92 か所に増やしても、20.8 GeV で 1.24 倍（1.15〜1.32）→ 変わらない</a:t>
             </a:r>
           </a:p>
         </p:txBody>
@@ -5632,7 +5632,7 @@
           <p:nvPr/>
         </p:nvPicPr>
         <p:blipFill>
-          <a:blip r:embed="rId3"/>
+          <a:blip r:embed="rId2"/>
           <a:stretch>
             <a:fillRect/>
           </a:stretch>
@@ -5656,7 +5656,7 @@
 </file>
 
 <file path=ppt/slides/slide5.xml><?xml version="1.0" encoding="utf-8"?>
-<p:sld xmlns:a="http://schemas.openxmlformats.org/drawingml/2006/main" xmlns:r="http://schemas.openxmlformats.org/officeDocument/2006/relationships" xmlns:p="http://schemas.openxmlformats.org/presentationml/2006/main">
+<p:sld xmlns:a="http://schemas.openxmlformats.org/drawingml/2006/main" xmlns:p="http://schemas.openxmlformats.org/presentationml/2006/main" xmlns:r="http://schemas.openxmlformats.org/officeDocument/2006/relationships">
   <p:cSld>
     <p:spTree>
       <p:nvGrpSpPr>
@@ -5664,14 +5664,7 @@
         <p:cNvGrpSpPr/>
         <p:nvPr/>
       </p:nvGrpSpPr>
-      <p:grpSpPr>
-        <a:xfrm>
-          <a:off x="0" y="0"/>
-          <a:ext cx="0" cy="0"/>
-          <a:chOff x="0" y="0"/>
-          <a:chExt cx="0" cy="0"/>
-        </a:xfrm>
-      </p:grpSpPr>
+      <p:grpSpPr/>
       <p:sp>
         <p:nvSpPr>
           <p:cNvPr id="2" name="Title 1"/>
@@ -5688,11 +5681,11 @@
           <a:lstStyle/>
           <a:p>
             <a:r>
-              <a:rPr lang="ja-JP" sz="3000">
+              <a:rPr sz="3000" lang="ja-JP">
                 <a:latin typeface="+mj-lt"/>
                 <a:ea typeface="+mj-ea"/>
               </a:rPr>
-              <a:t>疑問③：何も無い空で、係数は変になっていない？</a:t>
+              <a:t>先週の疑問③：何も無い空で、係数は変になっていない？</a:t>
             </a:r>
           </a:p>
         </p:txBody>
@@ -5705,7 +5698,7 @@
         </p:nvSpPr>
         <p:spPr>
           <a:xfrm>
-            <a:off x="548640" y="1463040"/>
+            <a:off x="548640" y="1234440"/>
             <a:ext cx="11155680" cy="2103120"/>
           </a:xfrm>
           <a:prstGeom prst="rect">
@@ -5719,59 +5712,59 @@
           </a:bodyPr>
           <a:lstStyle/>
           <a:p>
-            <a:pPr marL="274320" indent="-274320">
+            <a:pPr>
               <a:spcAft>
                 <a:spcPts val="500"/>
               </a:spcAft>
             </a:pPr>
             <a:r>
-              <a:rPr lang="ja-JP" sz="1700" b="0">
+              <a:rPr sz="1700" b="0" lang="ja-JP">
                 <a:latin typeface="+mn-lt"/>
                 <a:ea typeface="+mn-ea"/>
               </a:rPr>
-              <a:t>・20.8 GeV で、ガス：真ん中 1.1、点源：真ん中 1.0（予想どおりなら 1）</a:t>
-            </a:r>
-          </a:p>
-          <a:p>
-            <a:pPr marL="274320" indent="-274320">
+              <a:t>・ガス：真ん中 1.1、点源：真ん中 1.0（どちらも予想どおりなら 1）</a:t>
+            </a:r>
+          </a:p>
+          <a:p>
+            <a:pPr>
               <a:spcAft>
                 <a:spcPts val="500"/>
               </a:spcAft>
             </a:pPr>
             <a:r>
-              <a:rPr lang="ja-JP" sz="1700" b="1">
+              <a:rPr sz="1700" b="0" lang="ja-JP">
                 <a:latin typeface="+mn-lt"/>
                 <a:ea typeface="+mn-ea"/>
               </a:rPr>
-              <a:t>・ハロー：0 のまわりでプラス・マイナスがほぼ半々 → 片寄りなし</a:t>
-            </a:r>
-          </a:p>
-          <a:p>
-            <a:pPr marL="274320" indent="-274320">
+              <a:t>・ハロー：0 のまわりでプラス・マイナスがほぼ半々（光子 −6〜+12 個分）→ 片寄りなし</a:t>
+            </a:r>
+          </a:p>
+          <a:p>
+            <a:pPr>
               <a:spcAft>
                 <a:spcPts val="500"/>
               </a:spcAft>
             </a:pPr>
             <a:r>
-              <a:rPr lang="ja-JP" sz="1700" b="0">
+              <a:rPr sz="1700" b="1" lang="ja-JP">
                 <a:latin typeface="+mn-lt"/>
                 <a:ea typeface="+mn-ea"/>
               </a:rPr>
-              <a:t>・ガス・ICS・等方は、狭い空では形が似ていて分け方が決まらない → 1 つずつは大きく振れる（光子が数個しかない高いエネルギーでは特に）</a:t>
-            </a:r>
-          </a:p>
-          <a:p>
-            <a:pPr marL="274320" indent="-274320">
+              <a:t>・0 に張り付いたり、とんでもない値になったものは無い（23 か所 × 13 ビン ＝ 299 件すべて確認）</a:t>
+            </a:r>
+          </a:p>
+          <a:p>
+            <a:pPr>
               <a:spcAft>
                 <a:spcPts val="500"/>
               </a:spcAft>
             </a:pPr>
             <a:r>
-              <a:rPr lang="ja-JP" sz="1700" b="1">
+              <a:rPr sz="1700" b="0" lang="ja-JP">
                 <a:latin typeface="+mn-lt"/>
                 <a:ea typeface="+mn-ea"/>
               </a:rPr>
-              <a:t>・それでも何も無い空の σ は真ん中 0（疑問①の図）→ 振れても、ハローの答えは片寄らない</a:t>
+              <a:t>・ICS だけ 0.2〜5 と幅が広い：狭い範囲では等方とほぼ同じ形で、分け方が決まらないため（ハローには効かない）</a:t>
             </a:r>
           </a:p>
         </p:txBody>
@@ -5785,15 +5778,15 @@
           <p:nvPr/>
         </p:nvPicPr>
         <p:blipFill>
-          <a:blip r:embed="rId3"/>
+          <a:blip r:embed="rId2"/>
           <a:stretch>
             <a:fillRect/>
           </a:stretch>
         </p:blipFill>
         <p:spPr>
           <a:xfrm>
-            <a:off x="1463040" y="3611880"/>
-            <a:ext cx="9334500" cy="3200400"/>
+            <a:off x="1097280" y="3429000"/>
+            <a:ext cx="9875520" cy="3385893"/>
           </a:xfrm>
           <a:prstGeom prst="rect">
             <a:avLst/>
@@ -5809,7 +5802,7 @@
 </file>
 
 <file path=ppt/slides/slide6.xml><?xml version="1.0" encoding="utf-8"?>
-<p:sld xmlns:a="http://schemas.openxmlformats.org/drawingml/2006/main" xmlns:r="http://schemas.openxmlformats.org/officeDocument/2006/relationships" xmlns:p="http://schemas.openxmlformats.org/presentationml/2006/main">
+<p:sld xmlns:a="http://schemas.openxmlformats.org/drawingml/2006/main" xmlns:p="http://schemas.openxmlformats.org/presentationml/2006/main" xmlns:r="http://schemas.openxmlformats.org/officeDocument/2006/relationships">
   <p:cSld>
     <p:spTree>
       <p:nvGrpSpPr>
@@ -5817,14 +5810,7 @@
         <p:cNvGrpSpPr/>
         <p:nvPr/>
       </p:nvGrpSpPr>
-      <p:grpSpPr>
-        <a:xfrm>
-          <a:off x="0" y="0"/>
-          <a:ext cx="0" cy="0"/>
-          <a:chOff x="0" y="0"/>
-          <a:chExt cx="0" cy="0"/>
-        </a:xfrm>
-      </p:grpSpPr>
+      <p:grpSpPr/>
       <p:sp>
         <p:nvSpPr>
           <p:cNvPr id="2" name="Title 1"/>
@@ -5841,11 +5827,11 @@
           <a:lstStyle/>
           <a:p>
             <a:r>
-              <a:rPr lang="ja-JP" sz="3000">
+              <a:rPr sz="3000" lang="ja-JP">
                 <a:latin typeface="+mj-lt"/>
                 <a:ea typeface="+mj-ea"/>
               </a:rPr>
-              <a:t>疑問④：ICS とハローは本当に似ている？</a:t>
+              <a:t>先週の疑問④：ICS とハローは本当に似ている？ガスの方が似てない？</a:t>
             </a:r>
           </a:p>
         </p:txBody>
@@ -5858,7 +5844,7 @@
         </p:nvSpPr>
         <p:spPr>
           <a:xfrm>
-            <a:off x="548640" y="1463040"/>
+            <a:off x="548640" y="1234440"/>
             <a:ext cx="11155680" cy="2286000"/>
           </a:xfrm>
           <a:prstGeom prst="rect">
@@ -5872,13 +5858,13 @@
           </a:bodyPr>
           <a:lstStyle/>
           <a:p>
-            <a:pPr marL="274320" indent="-274320">
+            <a:pPr>
               <a:spcAft>
                 <a:spcPts val="500"/>
               </a:spcAft>
             </a:pPr>
             <a:r>
-              <a:rPr lang="ja-JP" sz="1600" b="0">
+              <a:rPr sz="1600" b="0" lang="ja-JP">
                 <a:latin typeface="+mn-lt"/>
                 <a:ea typeface="+mn-ea"/>
               </a:rPr>
@@ -5886,13 +5872,13 @@
             </a:r>
           </a:p>
           <a:p>
-            <a:pPr marL="274320" indent="-274320">
+            <a:pPr>
               <a:spcAft>
                 <a:spcPts val="500"/>
               </a:spcAft>
             </a:pPr>
             <a:r>
-              <a:rPr lang="ja-JP" sz="1600" b="1">
+              <a:rPr sz="1600" b="1" lang="ja-JP">
                 <a:latin typeface="+mn-lt"/>
                 <a:ea typeface="+mn-ea"/>
               </a:rPr>
@@ -5900,13 +5886,13 @@
             </a:r>
           </a:p>
           <a:p>
-            <a:pPr marL="274320" indent="-274320">
+            <a:pPr>
               <a:spcAft>
                 <a:spcPts val="500"/>
               </a:spcAft>
             </a:pPr>
             <a:r>
-              <a:rPr lang="ja-JP" sz="1600" b="0">
+              <a:rPr sz="1600" b="0" lang="ja-JP">
                 <a:latin typeface="+mn-lt"/>
                 <a:ea typeface="+mn-ea"/>
               </a:rPr>
@@ -5914,31 +5900,17 @@
             </a:r>
           </a:p>
           <a:p>
-            <a:pPr marL="274320" indent="-274320">
+            <a:pPr>
               <a:spcAft>
                 <a:spcPts val="500"/>
               </a:spcAft>
             </a:pPr>
             <a:r>
-              <a:rPr lang="ja-JP" sz="1600" b="0">
+              <a:rPr sz="1600" b="0" lang="ja-JP">
                 <a:latin typeface="+mn-lt"/>
                 <a:ea typeface="+mn-ea"/>
               </a:rPr>
-              <a:t>・横方向は違う（ICS は横に広い）→ 型紙どおりなら区別でき、ハローは 17.6σ。ただし ICS が中心で 2 倍ずれていれば 5.7σ に下がる</a:t>
-            </a:r>
-          </a:p>
-          <a:p>
-            <a:pPr marL="274320" indent="-274320">
-              <a:spcAft>
-                <a:spcPts val="500"/>
-              </a:spcAft>
-            </a:pPr>
-            <a:r>
-              <a:rPr lang="ja-JP" sz="1600" b="0">
-                <a:latin typeface="+mn-lt"/>
-                <a:ea typeface="+mn-ea"/>
-              </a:rPr>
-              <a:t>・バブルはハローに似ていない（0.53）→ 先週のご指摘どおり</a:t>
+              <a:t>・横方向は違う（ICS は横に広い）→ 完全には区別できなくならず、ハローは 17.6σ で残る。バブルは似ていない（0.53）</a:t>
             </a:r>
           </a:p>
         </p:txBody>
@@ -5952,15 +5924,15 @@
           <p:nvPr/>
         </p:nvPicPr>
         <p:blipFill>
-          <a:blip r:embed="rId3"/>
+          <a:blip r:embed="rId2"/>
           <a:stretch>
             <a:fillRect/>
           </a:stretch>
         </p:blipFill>
         <p:spPr>
           <a:xfrm>
-            <a:off x="1828800" y="3703320"/>
-            <a:ext cx="8041005" cy="3063240"/>
+            <a:off x="1280160" y="3520440"/>
+            <a:ext cx="9509760" cy="3622766"/>
           </a:xfrm>
           <a:prstGeom prst="rect">
             <a:avLst/>
@@ -5976,7 +5948,7 @@
 </file>
 
 <file path=ppt/slides/slide7.xml><?xml version="1.0" encoding="utf-8"?>
-<p:sld xmlns:a="http://schemas.openxmlformats.org/drawingml/2006/main" xmlns:r="http://schemas.openxmlformats.org/officeDocument/2006/relationships" xmlns:p="http://schemas.openxmlformats.org/presentationml/2006/main">
+<p:sld xmlns:a="http://schemas.openxmlformats.org/drawingml/2006/main" xmlns:p="http://schemas.openxmlformats.org/presentationml/2006/main" xmlns:r="http://schemas.openxmlformats.org/officeDocument/2006/relationships">
   <p:cSld>
     <p:spTree>
       <p:nvGrpSpPr>
@@ -5984,14 +5956,7 @@
         <p:cNvGrpSpPr/>
         <p:nvPr/>
       </p:nvGrpSpPr>
-      <p:grpSpPr>
-        <a:xfrm>
-          <a:off x="0" y="0"/>
-          <a:ext cx="0" cy="0"/>
-          <a:chOff x="0" y="0"/>
-          <a:chExt cx="0" cy="0"/>
-        </a:xfrm>
-      </p:grpSpPr>
+      <p:grpSpPr/>
       <p:sp>
         <p:nvSpPr>
           <p:cNvPr id="2" name="Title 1"/>
@@ -6008,11 +5973,11 @@
           <a:lstStyle/>
           <a:p>
             <a:r>
-              <a:rPr lang="ja-JP" sz="3000">
+              <a:rPr sz="3000" lang="ja-JP">
                 <a:latin typeface="+mj-lt"/>
                 <a:ea typeface="+mj-ea"/>
               </a:rPr>
-              <a:t>疑問⑤：矮小銀河にこのやり方を使っていい？</a:t>
+              <a:t>矮小銀河：このやり方で当てはめていいのか（標準の方法と比べる）</a:t>
             </a:r>
           </a:p>
         </p:txBody>
@@ -6026,7 +5991,7 @@
           <p:nvPr/>
         </p:nvGraphicFramePr>
         <p:xfrm>
-          <a:off x="457200" y="1463040"/>
+          <a:off x="457200" y="1280160"/>
           <a:ext cx="11247120" cy="2057400"/>
         </p:xfrm>
         <a:graphic>
@@ -6036,27 +6001,9 @@
                 <a:tableStyleId>{5C22544A-7EE6-4342-B048-85BDC9FD1C3A}</a:tableStyleId>
               </a:tblPr>
               <a:tblGrid>
-                <a:gridCol w="1554480">
-                  <a:extLst>
-                    <a:ext uri="{9D8B030D-6E8A-4147-A177-3AD203B41FA5}">
-                      <a16:colId xmlns:a16="http://schemas.microsoft.com/office/drawing/2014/main" val="20000"/>
-                    </a:ext>
-                  </a:extLst>
-                </a:gridCol>
-                <a:gridCol w="4846320">
-                  <a:extLst>
-                    <a:ext uri="{9D8B030D-6E8A-4147-A177-3AD203B41FA5}">
-                      <a16:colId xmlns:a16="http://schemas.microsoft.com/office/drawing/2014/main" val="20001"/>
-                    </a:ext>
-                  </a:extLst>
-                </a:gridCol>
-                <a:gridCol w="4846320">
-                  <a:extLst>
-                    <a:ext uri="{9D8B030D-6E8A-4147-A177-3AD203B41FA5}">
-                      <a16:colId xmlns:a16="http://schemas.microsoft.com/office/drawing/2014/main" val="20002"/>
-                    </a:ext>
-                  </a:extLst>
-                </a:gridCol>
+                <a:gridCol w="1554480"/>
+                <a:gridCol w="4846320"/>
+                <a:gridCol w="4846320"/>
               </a:tblGrid>
               <a:tr h="411480">
                 <a:tc>
@@ -6064,7 +6011,13 @@
                     <a:bodyPr/>
                     <a:lstStyle/>
                     <a:p>
-                      <a:endParaRPr/>
+                      <a:r>
+                        <a:rPr sz="1500" b="1" lang="ja-JP">
+                          <a:latin typeface="+mn-lt"/>
+                          <a:ea typeface="+mn-ea"/>
+                        </a:rPr>
+                        <a:t/>
+                      </a:r>
                     </a:p>
                   </a:txBody>
                   <a:tcPr/>
@@ -6075,7 +6028,7 @@
                     <a:lstStyle/>
                     <a:p>
                       <a:r>
-                        <a:rPr lang="ja-JP" sz="1500" b="1">
+                        <a:rPr sz="1500" b="1" lang="ja-JP">
                           <a:latin typeface="+mn-lt"/>
                           <a:ea typeface="+mn-ea"/>
                         </a:rPr>
@@ -6091,7 +6044,7 @@
                     <a:lstStyle/>
                     <a:p>
                       <a:r>
-                        <a:rPr lang="ja-JP" sz="1500" b="1">
+                        <a:rPr sz="1500" b="1" lang="ja-JP">
                           <a:latin typeface="+mn-lt"/>
                           <a:ea typeface="+mn-ea"/>
                         </a:rPr>
@@ -6101,11 +6054,6 @@
                   </a:txBody>
                   <a:tcPr/>
                 </a:tc>
-                <a:extLst>
-                  <a:ext uri="{0D108BD9-81ED-4DB2-BD59-A6C34878D82A}">
-                    <a16:rowId xmlns:a16="http://schemas.microsoft.com/office/drawing/2014/main" val="10000"/>
-                  </a:ext>
-                </a:extLst>
               </a:tr>
               <a:tr h="411480">
                 <a:tc>
@@ -6114,7 +6062,7 @@
                     <a:lstStyle/>
                     <a:p>
                       <a:r>
-                        <a:rPr lang="ja-JP" sz="1500" b="1">
+                        <a:rPr sz="1500" b="1" lang="ja-JP">
                           <a:latin typeface="+mn-lt"/>
                           <a:ea typeface="+mn-ea"/>
                         </a:rPr>
@@ -6130,7 +6078,7 @@
                     <a:lstStyle/>
                     <a:p>
                       <a:r>
-                        <a:rPr lang="ja-JP" sz="1500" b="0">
+                        <a:rPr sz="1500" b="0" lang="ja-JP">
                           <a:latin typeface="+mn-lt"/>
                           <a:ea typeface="+mn-ea"/>
                         </a:rPr>
@@ -6146,7 +6094,7 @@
                     <a:lstStyle/>
                     <a:p>
                       <a:r>
-                        <a:rPr lang="ja-JP" sz="1500" b="0">
+                        <a:rPr sz="1500" b="0" lang="ja-JP">
                           <a:latin typeface="+mn-lt"/>
                           <a:ea typeface="+mn-ea"/>
                         </a:rPr>
@@ -6156,11 +6104,6 @@
                   </a:txBody>
                   <a:tcPr/>
                 </a:tc>
-                <a:extLst>
-                  <a:ext uri="{0D108BD9-81ED-4DB2-BD59-A6C34878D82A}">
-                    <a16:rowId xmlns:a16="http://schemas.microsoft.com/office/drawing/2014/main" val="10001"/>
-                  </a:ext>
-                </a:extLst>
               </a:tr>
               <a:tr h="411480">
                 <a:tc>
@@ -6169,7 +6112,7 @@
                     <a:lstStyle/>
                     <a:p>
                       <a:r>
-                        <a:rPr lang="ja-JP" sz="1500" b="1">
+                        <a:rPr sz="1500" b="1" lang="ja-JP">
                           <a:latin typeface="+mn-lt"/>
                           <a:ea typeface="+mn-ea"/>
                         </a:rPr>
@@ -6185,7 +6128,7 @@
                     <a:lstStyle/>
                     <a:p>
                       <a:r>
-                        <a:rPr lang="ja-JP" sz="1500" b="0">
+                        <a:rPr sz="1500" b="0" lang="ja-JP">
                           <a:latin typeface="+mn-lt"/>
                           <a:ea typeface="+mn-ea"/>
                         </a:rPr>
@@ -6201,7 +6144,7 @@
                     <a:lstStyle/>
                     <a:p>
                       <a:r>
-                        <a:rPr lang="ja-JP" sz="1500" b="0">
+                        <a:rPr sz="1500" b="0" lang="ja-JP">
                           <a:latin typeface="+mn-lt"/>
                           <a:ea typeface="+mn-ea"/>
                         </a:rPr>
@@ -6211,11 +6154,6 @@
                   </a:txBody>
                   <a:tcPr/>
                 </a:tc>
-                <a:extLst>
-                  <a:ext uri="{0D108BD9-81ED-4DB2-BD59-A6C34878D82A}">
-                    <a16:rowId xmlns:a16="http://schemas.microsoft.com/office/drawing/2014/main" val="10002"/>
-                  </a:ext>
-                </a:extLst>
               </a:tr>
               <a:tr h="411480">
                 <a:tc>
@@ -6224,7 +6162,7 @@
                     <a:lstStyle/>
                     <a:p>
                       <a:r>
-                        <a:rPr lang="ja-JP" sz="1500" b="1">
+                        <a:rPr sz="1500" b="1" lang="ja-JP">
                           <a:latin typeface="+mn-lt"/>
                           <a:ea typeface="+mn-ea"/>
                         </a:rPr>
@@ -6240,7 +6178,7 @@
                     <a:lstStyle/>
                     <a:p>
                       <a:r>
-                        <a:rPr lang="ja-JP" sz="1500" b="0">
+                        <a:rPr sz="1500" b="0" lang="ja-JP">
                           <a:latin typeface="+mn-lt"/>
                           <a:ea typeface="+mn-ea"/>
                         </a:rPr>
@@ -6256,7 +6194,7 @@
                     <a:lstStyle/>
                     <a:p>
                       <a:r>
-                        <a:rPr lang="ja-JP" sz="1500" b="0">
+                        <a:rPr sz="1500" b="0" lang="ja-JP">
                           <a:latin typeface="+mn-lt"/>
                           <a:ea typeface="+mn-ea"/>
                         </a:rPr>
@@ -6266,11 +6204,6 @@
                   </a:txBody>
                   <a:tcPr/>
                 </a:tc>
-                <a:extLst>
-                  <a:ext uri="{0D108BD9-81ED-4DB2-BD59-A6C34878D82A}">
-                    <a16:rowId xmlns:a16="http://schemas.microsoft.com/office/drawing/2014/main" val="10003"/>
-                  </a:ext>
-                </a:extLst>
               </a:tr>
               <a:tr h="411480">
                 <a:tc>
@@ -6279,7 +6212,7 @@
                     <a:lstStyle/>
                     <a:p>
                       <a:r>
-                        <a:rPr lang="ja-JP" sz="1500" b="1">
+                        <a:rPr sz="1500" b="1" lang="ja-JP">
                           <a:latin typeface="+mn-lt"/>
                           <a:ea typeface="+mn-ea"/>
                         </a:rPr>
@@ -6295,7 +6228,7 @@
                     <a:lstStyle/>
                     <a:p>
                       <a:r>
-                        <a:rPr lang="ja-JP" sz="1500" b="0">
+                        <a:rPr sz="1500" b="0" lang="ja-JP">
                           <a:latin typeface="+mn-lt"/>
                           <a:ea typeface="+mn-ea"/>
                         </a:rPr>
@@ -6311,7 +6244,7 @@
                     <a:lstStyle/>
                     <a:p>
                       <a:r>
-                        <a:rPr lang="ja-JP" sz="1500" b="0">
+                        <a:rPr sz="1500" b="0" lang="ja-JP">
                           <a:latin typeface="+mn-lt"/>
                           <a:ea typeface="+mn-ea"/>
                         </a:rPr>
@@ -6321,11 +6254,6 @@
                   </a:txBody>
                   <a:tcPr/>
                 </a:tc>
-                <a:extLst>
-                  <a:ext uri="{0D108BD9-81ED-4DB2-BD59-A6C34878D82A}">
-                    <a16:rowId xmlns:a16="http://schemas.microsoft.com/office/drawing/2014/main" val="10004"/>
-                  </a:ext>
-                </a:extLst>
               </a:tr>
             </a:tbl>
           </a:graphicData>
@@ -6339,7 +6267,7 @@
         </p:nvSpPr>
         <p:spPr>
           <a:xfrm>
-            <a:off x="548640" y="4023360"/>
+            <a:off x="548640" y="3840480"/>
             <a:ext cx="11155680" cy="2194560"/>
           </a:xfrm>
           <a:prstGeom prst="rect">
@@ -6353,13 +6281,13 @@
           </a:bodyPr>
           <a:lstStyle/>
           <a:p>
-            <a:pPr marL="274320" indent="-274320">
+            <a:pPr>
               <a:spcAft>
                 <a:spcPts val="500"/>
               </a:spcAft>
             </a:pPr>
             <a:r>
-              <a:rPr lang="ja-JP" sz="1700" b="1">
+              <a:rPr sz="1700" b="1" lang="ja-JP">
                 <a:latin typeface="+mn-lt"/>
                 <a:ea typeface="+mn-ea"/>
               </a:rPr>
@@ -6367,13 +6295,13 @@
             </a:r>
           </a:p>
           <a:p>
-            <a:pPr marL="274320" indent="-274320">
+            <a:pPr>
               <a:spcAft>
                 <a:spcPts val="500"/>
               </a:spcAft>
             </a:pPr>
             <a:r>
-              <a:rPr lang="ja-JP" sz="1700" b="0">
+              <a:rPr sz="1700" b="0" lang="ja-JP">
                 <a:latin typeface="+mn-lt"/>
                 <a:ea typeface="+mn-ea"/>
               </a:rPr>
@@ -6381,13 +6309,13 @@
             </a:r>
           </a:p>
           <a:p>
-            <a:pPr marL="274320" indent="-274320">
+            <a:pPr>
               <a:spcAft>
                 <a:spcPts val="500"/>
               </a:spcAft>
             </a:pPr>
             <a:r>
-              <a:rPr lang="ja-JP" sz="1700" b="0">
+              <a:rPr sz="1700" b="0" lang="ja-JP">
                 <a:latin typeface="+mn-lt"/>
                 <a:ea typeface="+mn-ea"/>
               </a:rPr>
@@ -6405,7 +6333,7 @@
 </file>
 
 <file path=ppt/slides/slide8.xml><?xml version="1.0" encoding="utf-8"?>
-<p:sld xmlns:a="http://schemas.openxmlformats.org/drawingml/2006/main" xmlns:r="http://schemas.openxmlformats.org/officeDocument/2006/relationships" xmlns:p="http://schemas.openxmlformats.org/presentationml/2006/main">
+<p:sld xmlns:a="http://schemas.openxmlformats.org/drawingml/2006/main" xmlns:p="http://schemas.openxmlformats.org/presentationml/2006/main" xmlns:r="http://schemas.openxmlformats.org/officeDocument/2006/relationships">
   <p:cSld>
     <p:spTree>
       <p:nvGrpSpPr>
@@ -6413,14 +6341,7 @@
         <p:cNvGrpSpPr/>
         <p:nvPr/>
       </p:nvGrpSpPr>
-      <p:grpSpPr>
-        <a:xfrm>
-          <a:off x="0" y="0"/>
-          <a:ext cx="0" cy="0"/>
-          <a:chOff x="0" y="0"/>
-          <a:chExt cx="0" cy="0"/>
-        </a:xfrm>
-      </p:grpSpPr>
+      <p:grpSpPr/>
       <p:sp>
         <p:nvSpPr>
           <p:cNvPr id="2" name="Title 1"/>
@@ -6437,7 +6358,7 @@
           <a:lstStyle/>
           <a:p>
             <a:r>
-              <a:rPr lang="ja-JP" sz="3000">
+              <a:rPr sz="3000" lang="ja-JP">
                 <a:latin typeface="+mj-lt"/>
                 <a:ea typeface="+mj-ea"/>
               </a:rPr>
@@ -6454,7 +6375,7 @@
         </p:nvSpPr>
         <p:spPr>
           <a:xfrm>
-            <a:off x="731520" y="1554480"/>
+            <a:off x="731520" y="1371600"/>
             <a:ext cx="3840480" cy="1280160"/>
           </a:xfrm>
           <a:prstGeom prst="roundRect">
@@ -6484,12 +6405,12 @@
           </a:fontRef>
         </p:style>
         <p:txBody>
-          <a:bodyPr wrap="square" rtlCol="0" anchor="ctr"/>
+          <a:bodyPr rtlCol="0" anchor="ctr" wrap="square"/>
           <a:lstStyle/>
           <a:p>
             <a:pPr algn="ctr"/>
             <a:r>
-              <a:rPr lang="ja-JP" sz="2000" b="1">
+              <a:rPr sz="2000" b="1" lang="ja-JP">
                 <a:solidFill>
                   <a:srgbClr val="101010"/>
                 </a:solidFill>
@@ -6509,7 +6430,7 @@
         </p:nvSpPr>
         <p:spPr>
           <a:xfrm>
-            <a:off x="7589520" y="1554480"/>
+            <a:off x="7589520" y="1371600"/>
             <a:ext cx="3840480" cy="1280160"/>
           </a:xfrm>
           <a:prstGeom prst="roundRect">
@@ -6539,12 +6460,12 @@
           </a:fontRef>
         </p:style>
         <p:txBody>
-          <a:bodyPr wrap="square" rtlCol="0" anchor="ctr"/>
+          <a:bodyPr rtlCol="0" anchor="ctr" wrap="square"/>
           <a:lstStyle/>
           <a:p>
             <a:pPr algn="ctr"/>
             <a:r>
-              <a:rPr lang="ja-JP" sz="2000" b="1">
+              <a:rPr sz="2000" b="1" lang="ja-JP">
                 <a:solidFill>
                   <a:srgbClr val="101010"/>
                 </a:solidFill>
@@ -6564,7 +6485,7 @@
         </p:nvSpPr>
         <p:spPr>
           <a:xfrm>
-            <a:off x="4754880" y="1920240"/>
+            <a:off x="4754880" y="1737360"/>
             <a:ext cx="2651760" cy="548640"/>
           </a:xfrm>
           <a:prstGeom prst="leftRightArrow">
@@ -6596,7 +6517,6 @@
           <a:lstStyle/>
           <a:p>
             <a:pPr algn="ctr"/>
-            <a:endParaRPr/>
           </a:p>
         </p:txBody>
       </p:sp>
@@ -6608,8 +6528,8 @@
         </p:nvSpPr>
         <p:spPr>
           <a:xfrm>
-            <a:off x="548640" y="3108960"/>
-            <a:ext cx="11155680" cy="3474720"/>
+            <a:off x="548640" y="2926080"/>
+            <a:ext cx="11155680" cy="3200400"/>
           </a:xfrm>
           <a:prstGeom prst="rect">
             <a:avLst/>
@@ -6622,13 +6542,13 @@
           </a:bodyPr>
           <a:lstStyle/>
           <a:p>
-            <a:pPr marL="274320" indent="-274320">
+            <a:pPr>
               <a:spcAft>
                 <a:spcPts val="500"/>
               </a:spcAft>
             </a:pPr>
             <a:r>
-              <a:rPr lang="ja-JP" sz="1800" b="0">
+              <a:rPr sz="1800" b="0" lang="ja-JP">
                 <a:latin typeface="+mn-lt"/>
                 <a:ea typeface="+mn-ea"/>
               </a:rPr>
@@ -6636,13 +6556,13 @@
             </a:r>
           </a:p>
           <a:p>
-            <a:pPr marL="274320" indent="-274320">
+            <a:pPr>
               <a:spcAft>
                 <a:spcPts val="500"/>
               </a:spcAft>
             </a:pPr>
             <a:r>
-              <a:rPr lang="ja-JP" sz="1800" b="0">
+              <a:rPr sz="1800" b="0" lang="ja-JP">
                 <a:latin typeface="+mn-lt"/>
                 <a:ea typeface="+mn-ea"/>
               </a:rPr>
@@ -6650,13 +6570,13 @@
             </a:r>
           </a:p>
           <a:p>
-            <a:pPr marL="274320" indent="-274320">
+            <a:pPr>
               <a:spcAft>
                 <a:spcPts val="500"/>
               </a:spcAft>
             </a:pPr>
             <a:r>
-              <a:rPr lang="ja-JP" sz="1800" b="1">
+              <a:rPr sz="1800" b="1" lang="ja-JP">
                 <a:latin typeface="+mn-lt"/>
                 <a:ea typeface="+mn-ea"/>
               </a:rPr>
@@ -6664,27 +6584,13 @@
             </a:r>
           </a:p>
           <a:p>
-            <a:pPr marL="548640" indent="0">
+            <a:pPr>
               <a:spcAft>
                 <a:spcPts val="500"/>
               </a:spcAft>
             </a:pPr>
             <a:r>
-              <a:rPr lang="ja-JP" sz="1500" b="0">
-                <a:latin typeface="+mn-lt"/>
-                <a:ea typeface="+mn-ea"/>
-              </a:rPr>
-              <a:t>たとえ：宝の地図の「ここに 10 個」が 3 個の間違いかもしれない。掘って 0 個でも、宝が無いとは言い切れない</a:t>
-            </a:r>
-          </a:p>
-          <a:p>
-            <a:pPr marL="274320" indent="-274320">
-              <a:spcAft>
-                <a:spcPts val="500"/>
-              </a:spcAft>
-            </a:pPr>
-            <a:r>
-              <a:rPr lang="ja-JP" sz="1800" b="1">
+              <a:rPr sz="1800" b="1" lang="ja-JP">
                 <a:latin typeface="+mn-lt"/>
                 <a:ea typeface="+mn-ea"/>
               </a:rPr>
@@ -6702,7 +6608,7 @@
 </file>
 
 <file path=ppt/slides/slide9.xml><?xml version="1.0" encoding="utf-8"?>
-<p:sld xmlns:a="http://schemas.openxmlformats.org/drawingml/2006/main" xmlns:r="http://schemas.openxmlformats.org/officeDocument/2006/relationships" xmlns:p="http://schemas.openxmlformats.org/presentationml/2006/main">
+<p:sld xmlns:a="http://schemas.openxmlformats.org/drawingml/2006/main" xmlns:p="http://schemas.openxmlformats.org/presentationml/2006/main" xmlns:r="http://schemas.openxmlformats.org/officeDocument/2006/relationships">
   <p:cSld>
     <p:spTree>
       <p:nvGrpSpPr>
@@ -6710,14 +6616,7 @@
         <p:cNvGrpSpPr/>
         <p:nvPr/>
       </p:nvGrpSpPr>
-      <p:grpSpPr>
-        <a:xfrm>
-          <a:off x="0" y="0"/>
-          <a:ext cx="0" cy="0"/>
-          <a:chOff x="0" y="0"/>
-          <a:chExt cx="0" cy="0"/>
-        </a:xfrm>
-      </p:grpSpPr>
+      <p:grpSpPr/>
       <p:sp>
         <p:nvSpPr>
           <p:cNvPr id="2" name="Title 1"/>
@@ -6734,7 +6633,7 @@
           <a:lstStyle/>
           <a:p>
             <a:r>
-              <a:rPr lang="ja-JP" sz="3000">
+              <a:rPr sz="3000" lang="ja-JP">
                 <a:latin typeface="+mj-lt"/>
                 <a:ea typeface="+mj-ea"/>
               </a:rPr>
@@ -6751,7 +6650,7 @@
         </p:nvSpPr>
         <p:spPr>
           <a:xfrm>
-            <a:off x="548640" y="1463040"/>
+            <a:off x="548640" y="1280160"/>
             <a:ext cx="11155680" cy="2377440"/>
           </a:xfrm>
           <a:prstGeom prst="rect">
@@ -6765,13 +6664,13 @@
           </a:bodyPr>
           <a:lstStyle/>
           <a:p>
-            <a:pPr marL="274320" indent="-274320">
+            <a:pPr>
               <a:spcAft>
                 <a:spcPts val="500"/>
               </a:spcAft>
             </a:pPr>
             <a:r>
-              <a:rPr lang="ja-JP" sz="1800" b="0">
+              <a:rPr sz="1800" b="0" lang="ja-JP">
                 <a:latin typeface="+mn-lt"/>
                 <a:ea typeface="+mn-ea"/>
               </a:rPr>
@@ -6779,13 +6678,13 @@
             </a:r>
           </a:p>
           <a:p>
-            <a:pPr marL="274320" indent="-274320">
+            <a:pPr>
               <a:spcAft>
                 <a:spcPts val="500"/>
               </a:spcAft>
             </a:pPr>
             <a:r>
-              <a:rPr lang="ja-JP" sz="1800" b="1">
+              <a:rPr sz="1800" b="1" lang="ja-JP">
                 <a:latin typeface="+mn-lt"/>
                 <a:ea typeface="+mn-ea"/>
               </a:rPr>
@@ -6793,13 +6692,13 @@
             </a:r>
           </a:p>
           <a:p>
-            <a:pPr marL="274320" indent="-274320">
+            <a:pPr>
               <a:spcAft>
                 <a:spcPts val="500"/>
               </a:spcAft>
             </a:pPr>
             <a:r>
-              <a:rPr lang="ja-JP" sz="1800" b="0">
+              <a:rPr sz="1800" b="0" lang="ja-JP">
                 <a:latin typeface="+mn-lt"/>
                 <a:ea typeface="+mn-ea"/>
               </a:rPr>
@@ -6807,13 +6706,13 @@
             </a:r>
           </a:p>
           <a:p>
-            <a:pPr marL="274320" indent="-274320">
+            <a:pPr>
               <a:spcAft>
                 <a:spcPts val="500"/>
               </a:spcAft>
             </a:pPr>
             <a:r>
-              <a:rPr lang="ja-JP" sz="1800" b="1">
+              <a:rPr sz="1800" b="1" lang="ja-JP">
                 <a:latin typeface="+mn-lt"/>
                 <a:ea typeface="+mn-ea"/>
               </a:rPr>
@@ -6831,7 +6730,7 @@
           <p:nvPr/>
         </p:nvPicPr>
         <p:blipFill>
-          <a:blip r:embed="rId3"/>
+          <a:blip r:embed="rId2"/>
           <a:stretch>
             <a:fillRect/>
           </a:stretch>

</xml_diff>

<commit_message>
slides: 本人の編集版を更新 (10-06 14:53)
</commit_message>
<xml_diff>
--- a/slides/2026-10-09_研究報告_10枚版.pptx
+++ b/slides/2026-10-09_研究報告_10枚版.pptx
@@ -140,12 +140,12 @@
   <pc:docChgLst>
     <pc:chgData name="202304239" userId="ab1adf7a-b8eb-4038-b404-de23e20d8a3a" providerId="ADAL" clId="{6C0E59ED-D716-49AF-B2FA-B94E7B8E5A8C}"/>
     <pc:docChg chg="undo custSel addSld delSld modSld sldOrd">
-      <pc:chgData name="202304239" userId="ab1adf7a-b8eb-4038-b404-de23e20d8a3a" providerId="ADAL" clId="{6C0E59ED-D716-49AF-B2FA-B94E7B8E5A8C}" dt="2026-10-06T05:50:18.636" v="866" actId="20577"/>
+      <pc:chgData name="202304239" userId="ab1adf7a-b8eb-4038-b404-de23e20d8a3a" providerId="ADAL" clId="{6C0E59ED-D716-49AF-B2FA-B94E7B8E5A8C}" dt="2026-10-06T05:53:19.203" v="936" actId="20577"/>
       <pc:docMkLst>
         <pc:docMk/>
       </pc:docMkLst>
       <pc:sldChg chg="modSp mod">
-        <pc:chgData name="202304239" userId="ab1adf7a-b8eb-4038-b404-de23e20d8a3a" providerId="ADAL" clId="{6C0E59ED-D716-49AF-B2FA-B94E7B8E5A8C}" dt="2026-10-06T05:50:18.636" v="866" actId="20577"/>
+        <pc:chgData name="202304239" userId="ab1adf7a-b8eb-4038-b404-de23e20d8a3a" providerId="ADAL" clId="{6C0E59ED-D716-49AF-B2FA-B94E7B8E5A8C}" dt="2026-10-06T05:53:19.203" v="936" actId="20577"/>
         <pc:sldMkLst>
           <pc:docMk/>
           <pc:sldMk cId="0" sldId="257"/>
@@ -159,7 +159,7 @@
           </ac:spMkLst>
         </pc:spChg>
         <pc:spChg chg="mod">
-          <ac:chgData name="202304239" userId="ab1adf7a-b8eb-4038-b404-de23e20d8a3a" providerId="ADAL" clId="{6C0E59ED-D716-49AF-B2FA-B94E7B8E5A8C}" dt="2026-10-02T01:41:32.636" v="29" actId="20577"/>
+          <ac:chgData name="202304239" userId="ab1adf7a-b8eb-4038-b404-de23e20d8a3a" providerId="ADAL" clId="{6C0E59ED-D716-49AF-B2FA-B94E7B8E5A8C}" dt="2026-10-06T05:53:19.203" v="936" actId="20577"/>
           <ac:spMkLst>
             <pc:docMk/>
             <pc:sldMk cId="0" sldId="257"/>
@@ -5102,7 +5102,7 @@
         <p:spPr>
           <a:xfrm>
             <a:off x="548640" y="1280160"/>
-            <a:ext cx="6035040" cy="4754880"/>
+            <a:ext cx="6035040" cy="2695610"/>
           </a:xfrm>
           <a:prstGeom prst="rect">
             <a:avLst/>
@@ -5125,8 +5125,19 @@
                 <a:latin typeface="+mn-lt"/>
                 <a:ea typeface="+mn-ea"/>
               </a:rPr>
-              <a:t>・やったこと：Totani さんの「20 GeV のハロー状の光」を、同じデータ・同じ方法で計算し直した</a:t>
-            </a:r>
+              <a:t>・</a:t>
+            </a:r>
+            <a:r>
+              <a:rPr lang="ja-JP" altLang="en-US" sz="1900" b="0">
+                <a:latin typeface="+mn-lt"/>
+                <a:ea typeface="+mn-ea"/>
+              </a:rPr>
+              <a:t>前回の疑問点の解決</a:t>
+            </a:r>
+            <a:endParaRPr lang="en-US" altLang="ja-JP" sz="1900" b="0">
+              <a:latin typeface="+mn-lt"/>
+              <a:ea typeface="+mn-ea"/>
+            </a:endParaRPr>
           </a:p>
           <a:p>
             <a:pPr>
@@ -5139,7 +5150,7 @@
                 <a:latin typeface="+mn-lt"/>
                 <a:ea typeface="+mn-ea"/>
               </a:rPr>
-              <a:t>・① 同じ光が見えた</a:t>
+              <a:t>・① </a:t>
             </a:r>
           </a:p>
           <a:p>
@@ -5181,7 +5192,7 @@
                 <a:latin typeface="+mn-lt"/>
                 <a:ea typeface="+mn-ea"/>
               </a:rPr>
-              <a:t>・② 背景（ICS・バブル）の計算の間違いでは説明できない</a:t>
+              <a:t>・②</a:t>
             </a:r>
           </a:p>
           <a:p>

</xml_diff>

<commit_message>
slides: 本人の編集版を更新 (10-06 14:54)
</commit_message>
<xml_diff>
--- a/slides/2026-10-09_研究報告_10枚版.pptx
+++ b/slides/2026-10-09_研究報告_10枚版.pptx
@@ -140,12 +140,12 @@
   <pc:docChgLst>
     <pc:chgData name="202304239" userId="ab1adf7a-b8eb-4038-b404-de23e20d8a3a" providerId="ADAL" clId="{6C0E59ED-D716-49AF-B2FA-B94E7B8E5A8C}"/>
     <pc:docChg chg="undo custSel addSld delSld modSld sldOrd">
-      <pc:chgData name="202304239" userId="ab1adf7a-b8eb-4038-b404-de23e20d8a3a" providerId="ADAL" clId="{6C0E59ED-D716-49AF-B2FA-B94E7B8E5A8C}" dt="2026-10-06T05:53:19.203" v="936" actId="20577"/>
+      <pc:chgData name="202304239" userId="ab1adf7a-b8eb-4038-b404-de23e20d8a3a" providerId="ADAL" clId="{6C0E59ED-D716-49AF-B2FA-B94E7B8E5A8C}" dt="2026-10-06T05:53:51.536" v="982" actId="20577"/>
       <pc:docMkLst>
         <pc:docMk/>
       </pc:docMkLst>
       <pc:sldChg chg="modSp mod">
-        <pc:chgData name="202304239" userId="ab1adf7a-b8eb-4038-b404-de23e20d8a3a" providerId="ADAL" clId="{6C0E59ED-D716-49AF-B2FA-B94E7B8E5A8C}" dt="2026-10-06T05:53:19.203" v="936" actId="20577"/>
+        <pc:chgData name="202304239" userId="ab1adf7a-b8eb-4038-b404-de23e20d8a3a" providerId="ADAL" clId="{6C0E59ED-D716-49AF-B2FA-B94E7B8E5A8C}" dt="2026-10-06T05:53:51.536" v="982" actId="20577"/>
         <pc:sldMkLst>
           <pc:docMk/>
           <pc:sldMk cId="0" sldId="257"/>
@@ -159,7 +159,7 @@
           </ac:spMkLst>
         </pc:spChg>
         <pc:spChg chg="mod">
-          <ac:chgData name="202304239" userId="ab1adf7a-b8eb-4038-b404-de23e20d8a3a" providerId="ADAL" clId="{6C0E59ED-D716-49AF-B2FA-B94E7B8E5A8C}" dt="2026-10-06T05:53:19.203" v="936" actId="20577"/>
+          <ac:chgData name="202304239" userId="ab1adf7a-b8eb-4038-b404-de23e20d8a3a" providerId="ADAL" clId="{6C0E59ED-D716-49AF-B2FA-B94E7B8E5A8C}" dt="2026-10-06T05:53:51.536" v="982" actId="20577"/>
           <ac:spMkLst>
             <pc:docMk/>
             <pc:sldMk cId="0" sldId="257"/>
@@ -5121,11 +5121,8 @@
               </a:spcAft>
             </a:pPr>
             <a:r>
-              <a:rPr lang="ja-JP" sz="1900" b="0">
-                <a:latin typeface="+mn-lt"/>
-                <a:ea typeface="+mn-ea"/>
-              </a:rPr>
-              <a:t>・</a:t>
+              <a:rPr lang="ja-JP" altLang="en-US" sz="1900"/>
+              <a:t>①</a:t>
             </a:r>
             <a:r>
               <a:rPr lang="ja-JP" altLang="en-US" sz="1900" b="0">
@@ -5150,7 +5147,7 @@
                 <a:latin typeface="+mn-lt"/>
                 <a:ea typeface="+mn-ea"/>
               </a:rPr>
-              <a:t>・① </a:t>
+              <a:t>・ </a:t>
             </a:r>
           </a:p>
           <a:p>
@@ -5188,12 +5185,20 @@
               </a:spcAft>
             </a:pPr>
             <a:r>
-              <a:rPr lang="ja-JP" sz="1900" b="1">
+              <a:rPr lang="ja-JP" altLang="en-US" sz="1900" b="1"/>
+              <a:t>②</a:t>
+            </a:r>
+            <a:r>
+              <a:rPr lang="ja-JP" altLang="en-US" sz="1900" b="1">
                 <a:latin typeface="+mn-lt"/>
                 <a:ea typeface="+mn-ea"/>
               </a:rPr>
-              <a:t>・②</a:t>
-            </a:r>
+              <a:t>論文拡張</a:t>
+            </a:r>
+            <a:endParaRPr lang="ja-JP" sz="1900" b="1">
+              <a:latin typeface="+mn-lt"/>
+              <a:ea typeface="+mn-ea"/>
+            </a:endParaRPr>
           </a:p>
           <a:p>
             <a:pPr>
@@ -5206,7 +5211,7 @@
                 <a:latin typeface="+mn-lt"/>
                 <a:ea typeface="+mn-ea"/>
               </a:rPr>
-              <a:t>　　ただし、暗黒物質の証拠とまでは言えない</a:t>
+              <a:t>　　</a:t>
             </a:r>
           </a:p>
           <a:p>
@@ -5220,7 +5225,7 @@
                 <a:latin typeface="+mn-lt"/>
                 <a:ea typeface="+mn-ea"/>
               </a:rPr>
-              <a:t>・③ 矮小銀河では見えない</a:t>
+              <a:t>・</a:t>
             </a:r>
           </a:p>
           <a:p>

</xml_diff>

<commit_message>
slides: 本人の編集版を更新 (10-06 14:55)
</commit_message>
<xml_diff>
--- a/slides/2026-10-09_研究報告_10枚版.pptx
+++ b/slides/2026-10-09_研究報告_10枚版.pptx
@@ -135,17 +135,25 @@
 </p:presentation>
 </file>
 
+<file path=ppt/revisionInfo.xml><?xml version="1.0" encoding="utf-8"?>
+<p1510:revInfo xmlns:a="http://schemas.openxmlformats.org/drawingml/2006/main" xmlns:r="http://schemas.openxmlformats.org/officeDocument/2006/relationships" xmlns:p1510="http://schemas.microsoft.com/office/powerpoint/2015/10/main">
+  <p1510:revLst>
+    <p1510:client id="{4956FDFF-018F-490D-9719-867BBBF6B84B}" v="1" dt="2026-10-06T05:54:37.335"/>
+  </p1510:revLst>
+</p1510:revInfo>
+</file>
+
 <file path=ppt/changesInfos/changesInfo1.xml><?xml version="1.0" encoding="utf-8"?>
 <pc:chgInfo xmlns:a="http://schemas.openxmlformats.org/drawingml/2006/main" xmlns:r="http://schemas.openxmlformats.org/officeDocument/2006/relationships" xmlns:ac="http://schemas.microsoft.com/office/drawing/2013/main/command" xmlns:pc="http://schemas.microsoft.com/office/powerpoint/2013/main/command">
   <pc:docChgLst>
     <pc:chgData name="202304239" userId="ab1adf7a-b8eb-4038-b404-de23e20d8a3a" providerId="ADAL" clId="{6C0E59ED-D716-49AF-B2FA-B94E7B8E5A8C}"/>
     <pc:docChg chg="undo custSel addSld delSld modSld sldOrd">
-      <pc:chgData name="202304239" userId="ab1adf7a-b8eb-4038-b404-de23e20d8a3a" providerId="ADAL" clId="{6C0E59ED-D716-49AF-B2FA-B94E7B8E5A8C}" dt="2026-10-06T05:53:57.692" v="986" actId="20577"/>
+      <pc:chgData name="202304239" userId="ab1adf7a-b8eb-4038-b404-de23e20d8a3a" providerId="ADAL" clId="{6C0E59ED-D716-49AF-B2FA-B94E7B8E5A8C}" dt="2026-10-06T05:55:01.285" v="994" actId="20577"/>
       <pc:docMkLst>
         <pc:docMk/>
       </pc:docMkLst>
       <pc:sldChg chg="modSp mod">
-        <pc:chgData name="202304239" userId="ab1adf7a-b8eb-4038-b404-de23e20d8a3a" providerId="ADAL" clId="{6C0E59ED-D716-49AF-B2FA-B94E7B8E5A8C}" dt="2026-10-06T05:53:57.692" v="986" actId="20577"/>
+        <pc:chgData name="202304239" userId="ab1adf7a-b8eb-4038-b404-de23e20d8a3a" providerId="ADAL" clId="{6C0E59ED-D716-49AF-B2FA-B94E7B8E5A8C}" dt="2026-10-06T05:55:01.285" v="994" actId="20577"/>
         <pc:sldMkLst>
           <pc:docMk/>
           <pc:sldMk cId="0" sldId="257"/>
@@ -159,7 +167,7 @@
           </ac:spMkLst>
         </pc:spChg>
         <pc:spChg chg="mod">
-          <ac:chgData name="202304239" userId="ab1adf7a-b8eb-4038-b404-de23e20d8a3a" providerId="ADAL" clId="{6C0E59ED-D716-49AF-B2FA-B94E7B8E5A8C}" dt="2026-10-06T05:53:57.692" v="986" actId="20577"/>
+          <ac:chgData name="202304239" userId="ab1adf7a-b8eb-4038-b404-de23e20d8a3a" providerId="ADAL" clId="{6C0E59ED-D716-49AF-B2FA-B94E7B8E5A8C}" dt="2026-10-06T05:55:01.285" v="994" actId="20577"/>
           <ac:spMkLst>
             <pc:docMk/>
             <pc:sldMk cId="0" sldId="257"/>
@@ -5102,7 +5110,7 @@
         <p:spPr>
           <a:xfrm>
             <a:off x="548640" y="1280160"/>
-            <a:ext cx="6035040" cy="1718419"/>
+            <a:ext cx="6035040" cy="3934410"/>
           </a:xfrm>
           <a:prstGeom prst="rect">
             <a:avLst/>
@@ -5137,18 +5145,63 @@
             </a:endParaRPr>
           </a:p>
           <a:p>
+            <a:pPr lvl="0"/>
+            <a:r>
+              <a:rPr lang="en-US" b="1"/>
+              <a:t>① 1.2〜1.3 は「引く」？「割る」？</a:t>
+            </a:r>
+            <a:endParaRPr lang="en-US"/>
+          </a:p>
+          <a:p>
+            <a:pPr lvl="0"/>
+            <a:r>
+              <a:rPr lang="en-US" b="1"/>
+              <a:t>② 何も無い空の分布はどこから来たのか</a:t>
+            </a:r>
+            <a:endParaRPr lang="en-US"/>
+          </a:p>
+          <a:p>
+            <a:pPr lvl="0"/>
+            <a:r>
+              <a:rPr lang="en-US" b="1"/>
+              <a:t>③ 何も無い空での係数</a:t>
+            </a:r>
+            <a:endParaRPr lang="en-US"/>
+          </a:p>
+          <a:p>
+            <a:pPr lvl="0"/>
+            <a:r>
+              <a:rPr lang="en-US" b="1"/>
+              <a:t>④ ICS とハローは本当に縮退しているのか</a:t>
+            </a:r>
+            <a:endParaRPr lang="en-US"/>
+          </a:p>
+          <a:p>
+            <a:pPr lvl="0"/>
+            <a:r>
+              <a:rPr lang="en-US" b="1"/>
+              <a:t>⑤ 矮小銀河の標準的な方法は何か</a:t>
+            </a:r>
+            <a:endParaRPr lang="en-US"/>
+          </a:p>
+          <a:p>
+            <a:br>
+              <a:rPr lang="en-US"/>
+            </a:br>
+            <a:endParaRPr lang="en-US"/>
+          </a:p>
+          <a:p>
+            <a:r>
+              <a:rPr lang="en-US"/>
+              <a:t>この2つに抜けや違いがあれば教えて</a:t>
+            </a:r>
+          </a:p>
+          <a:p>
             <a:pPr>
               <a:spcAft>
                 <a:spcPts val="500"/>
               </a:spcAft>
             </a:pPr>
-            <a:r>
-              <a:rPr lang="ja-JP" sz="1900" b="1">
-                <a:latin typeface="+mn-lt"/>
-                <a:ea typeface="+mn-ea"/>
-              </a:rPr>
-              <a:t>・ </a:t>
-            </a:r>
             <a:r>
               <a:rPr lang="ja-JP" altLang="en-US" sz="1900" b="1"/>
               <a:t>②</a:t>

</xml_diff>

<commit_message>
slides: 本人の編集版を更新 (10-06 14:57)
</commit_message>
<xml_diff>
--- a/slides/2026-10-09_研究報告_10枚版.pptx
+++ b/slides/2026-10-09_研究報告_10枚版.pptx
@@ -148,18 +148,18 @@
   <pc:docChgLst>
     <pc:chgData name="202304239" userId="ab1adf7a-b8eb-4038-b404-de23e20d8a3a" providerId="ADAL" clId="{6C0E59ED-D716-49AF-B2FA-B94E7B8E5A8C}"/>
     <pc:docChg chg="undo custSel addSld delSld modSld sldOrd">
-      <pc:chgData name="202304239" userId="ab1adf7a-b8eb-4038-b404-de23e20d8a3a" providerId="ADAL" clId="{6C0E59ED-D716-49AF-B2FA-B94E7B8E5A8C}" dt="2026-10-06T05:55:25.907" v="1003" actId="14100"/>
+      <pc:chgData name="202304239" userId="ab1adf7a-b8eb-4038-b404-de23e20d8a3a" providerId="ADAL" clId="{6C0E59ED-D716-49AF-B2FA-B94E7B8E5A8C}" dt="2026-10-06T05:57:15.073" v="1032" actId="20577"/>
       <pc:docMkLst>
         <pc:docMk/>
       </pc:docMkLst>
       <pc:sldChg chg="addSp delSp modSp mod">
-        <pc:chgData name="202304239" userId="ab1adf7a-b8eb-4038-b404-de23e20d8a3a" providerId="ADAL" clId="{6C0E59ED-D716-49AF-B2FA-B94E7B8E5A8C}" dt="2026-10-06T05:55:25.907" v="1003" actId="14100"/>
+        <pc:chgData name="202304239" userId="ab1adf7a-b8eb-4038-b404-de23e20d8a3a" providerId="ADAL" clId="{6C0E59ED-D716-49AF-B2FA-B94E7B8E5A8C}" dt="2026-10-06T05:57:15.073" v="1032" actId="20577"/>
         <pc:sldMkLst>
           <pc:docMk/>
           <pc:sldMk cId="0" sldId="257"/>
         </pc:sldMkLst>
         <pc:spChg chg="mod">
-          <ac:chgData name="202304239" userId="ab1adf7a-b8eb-4038-b404-de23e20d8a3a" providerId="ADAL" clId="{6C0E59ED-D716-49AF-B2FA-B94E7B8E5A8C}" dt="2026-10-06T05:50:18.636" v="866" actId="20577"/>
+          <ac:chgData name="202304239" userId="ab1adf7a-b8eb-4038-b404-de23e20d8a3a" providerId="ADAL" clId="{6C0E59ED-D716-49AF-B2FA-B94E7B8E5A8C}" dt="2026-10-06T05:57:15.073" v="1032" actId="20577"/>
           <ac:spMkLst>
             <pc:docMk/>
             <pc:sldMk cId="0" sldId="257"/>
@@ -5100,12 +5100,23 @@
           <a:lstStyle/>
           <a:p>
             <a:r>
-              <a:rPr lang="ja-JP" sz="3000">
+              <a:rPr lang="ja-JP" altLang="en-US" sz="3000">
                 <a:latin typeface="+mj-lt"/>
                 <a:ea typeface="+mj-ea"/>
               </a:rPr>
-              <a:t>結論：わかったこと 3 つ</a:t>
-            </a:r>
+              <a:t>やってきた子</a:t>
+            </a:r>
+            <a:r>
+              <a:rPr lang="en-US" altLang="ja-JP" sz="3000">
+                <a:latin typeface="+mj-lt"/>
+                <a:ea typeface="+mj-ea"/>
+              </a:rPr>
+              <a:t>t</a:t>
+            </a:r>
+            <a:endParaRPr lang="ja-JP" sz="3000">
+              <a:latin typeface="+mj-lt"/>
+              <a:ea typeface="+mj-ea"/>
+            </a:endParaRPr>
           </a:p>
         </p:txBody>
       </p:sp>

</xml_diff>

<commit_message>
slides: 本人の編集版を更新 (10-06 14:58)
</commit_message>
<xml_diff>
--- a/slides/2026-10-09_研究報告_10枚版.pptx
+++ b/slides/2026-10-09_研究報告_10枚版.pptx
@@ -148,12 +148,12 @@
   <pc:docChgLst>
     <pc:chgData name="202304239" userId="ab1adf7a-b8eb-4038-b404-de23e20d8a3a" providerId="ADAL" clId="{6C0E59ED-D716-49AF-B2FA-B94E7B8E5A8C}"/>
     <pc:docChg chg="undo custSel addSld delSld modSld sldOrd">
-      <pc:chgData name="202304239" userId="ab1adf7a-b8eb-4038-b404-de23e20d8a3a" providerId="ADAL" clId="{6C0E59ED-D716-49AF-B2FA-B94E7B8E5A8C}" dt="2026-10-06T05:57:41.783" v="1055" actId="20577"/>
+      <pc:chgData name="202304239" userId="ab1adf7a-b8eb-4038-b404-de23e20d8a3a" providerId="ADAL" clId="{6C0E59ED-D716-49AF-B2FA-B94E7B8E5A8C}" dt="2026-10-06T05:58:20.567" v="1077" actId="14100"/>
       <pc:docMkLst>
         <pc:docMk/>
       </pc:docMkLst>
       <pc:sldChg chg="addSp delSp modSp mod">
-        <pc:chgData name="202304239" userId="ab1adf7a-b8eb-4038-b404-de23e20d8a3a" providerId="ADAL" clId="{6C0E59ED-D716-49AF-B2FA-B94E7B8E5A8C}" dt="2026-10-06T05:57:41.783" v="1055" actId="20577"/>
+        <pc:chgData name="202304239" userId="ab1adf7a-b8eb-4038-b404-de23e20d8a3a" providerId="ADAL" clId="{6C0E59ED-D716-49AF-B2FA-B94E7B8E5A8C}" dt="2026-10-06T05:58:20.567" v="1077" actId="14100"/>
         <pc:sldMkLst>
           <pc:docMk/>
           <pc:sldMk cId="0" sldId="257"/>
@@ -167,7 +167,7 @@
           </ac:spMkLst>
         </pc:spChg>
         <pc:spChg chg="add del mod">
-          <ac:chgData name="202304239" userId="ab1adf7a-b8eb-4038-b404-de23e20d8a3a" providerId="ADAL" clId="{6C0E59ED-D716-49AF-B2FA-B94E7B8E5A8C}" dt="2026-10-06T05:57:41.783" v="1055" actId="20577"/>
+          <ac:chgData name="202304239" userId="ab1adf7a-b8eb-4038-b404-de23e20d8a3a" providerId="ADAL" clId="{6C0E59ED-D716-49AF-B2FA-B94E7B8E5A8C}" dt="2026-10-06T05:58:20.567" v="1077" actId="14100"/>
           <ac:spMkLst>
             <pc:docMk/>
             <pc:sldMk cId="0" sldId="257"/>
@@ -5122,7 +5122,7 @@
         <p:spPr>
           <a:xfrm>
             <a:off x="548640" y="1280160"/>
-            <a:ext cx="4635835" cy="2649443"/>
+            <a:ext cx="10907239" cy="3972882"/>
           </a:xfrm>
           <a:prstGeom prst="rect">
             <a:avLst/>
@@ -5141,17 +5141,17 @@
               </a:spcAft>
             </a:pPr>
             <a:r>
-              <a:rPr lang="ja-JP" altLang="en-US" sz="1900"/>
+              <a:rPr lang="ja-JP" altLang="en-US" sz="2800"/>
               <a:t>①</a:t>
             </a:r>
             <a:r>
-              <a:rPr lang="ja-JP" altLang="en-US" sz="1900" b="0">
+              <a:rPr lang="ja-JP" altLang="en-US" sz="2800" b="0">
                 <a:latin typeface="+mn-lt"/>
                 <a:ea typeface="+mn-ea"/>
               </a:rPr>
               <a:t>前回の疑問点の解決</a:t>
             </a:r>
-            <a:endParaRPr lang="en-US" altLang="ja-JP" sz="1900" b="0">
+            <a:endParaRPr lang="en-US" altLang="ja-JP" sz="2800" b="0">
               <a:latin typeface="+mn-lt"/>
               <a:ea typeface="+mn-ea"/>
             </a:endParaRPr>
@@ -5159,60 +5159,60 @@
           <a:p>
             <a:pPr lvl="0"/>
             <a:r>
-              <a:rPr lang="en-US" b="1"/>
+              <a:rPr lang="en-US" sz="2800" b="1"/>
               <a:t>① 1.2〜1.3 は「引く」？「割る」？</a:t>
             </a:r>
-            <a:endParaRPr lang="en-US"/>
+            <a:endParaRPr lang="en-US" sz="2800"/>
           </a:p>
           <a:p>
             <a:pPr lvl="0"/>
             <a:r>
-              <a:rPr lang="en-US" b="1"/>
+              <a:rPr lang="en-US" sz="2800" b="1"/>
               <a:t>② 何も無い空の分布はどこから来たのか</a:t>
             </a:r>
-            <a:endParaRPr lang="en-US"/>
+            <a:endParaRPr lang="en-US" sz="2800"/>
           </a:p>
           <a:p>
             <a:pPr lvl="0"/>
             <a:r>
-              <a:rPr lang="en-US" b="1"/>
+              <a:rPr lang="en-US" sz="2800" b="1"/>
               <a:t>③ 何も無い空での係数</a:t>
             </a:r>
-            <a:endParaRPr lang="en-US"/>
+            <a:endParaRPr lang="en-US" sz="2800"/>
           </a:p>
           <a:p>
             <a:pPr lvl="0"/>
             <a:r>
-              <a:rPr lang="en-US" b="1"/>
+              <a:rPr lang="en-US" sz="2800" b="1"/>
               <a:t>④ ICS とハローは本当に縮退しているのか</a:t>
             </a:r>
-            <a:endParaRPr lang="en-US"/>
+            <a:endParaRPr lang="en-US" sz="2800"/>
           </a:p>
           <a:p>
             <a:pPr lvl="0"/>
             <a:r>
-              <a:rPr lang="en-US" b="1"/>
+              <a:rPr lang="en-US" sz="2800" b="1"/>
               <a:t>⑤ 矮小銀河の標準的な方法は何か</a:t>
             </a:r>
             <a:br>
-              <a:rPr lang="en-US"/>
+              <a:rPr lang="en-US" sz="2800"/>
             </a:br>
-            <a:endParaRPr lang="en-US"/>
+            <a:endParaRPr lang="en-US" sz="2800"/>
           </a:p>
           <a:p>
             <a:pPr lvl="0"/>
             <a:r>
-              <a:rPr lang="ja-JP" altLang="en-US" sz="1900" b="1"/>
+              <a:rPr lang="ja-JP" altLang="en-US" sz="2800" b="1"/>
               <a:t>②</a:t>
             </a:r>
             <a:r>
-              <a:rPr lang="ja-JP" altLang="en-US" sz="1900" b="1">
+              <a:rPr lang="ja-JP" altLang="en-US" sz="2800" b="1">
                 <a:latin typeface="+mn-lt"/>
                 <a:ea typeface="+mn-ea"/>
               </a:rPr>
               <a:t>論文拡張</a:t>
             </a:r>
-            <a:endParaRPr lang="ja-JP" sz="1900" b="1">
+            <a:endParaRPr lang="ja-JP" sz="2800" b="1">
               <a:latin typeface="+mn-lt"/>
               <a:ea typeface="+mn-ea"/>
             </a:endParaRPr>
@@ -5224,12 +5224,16 @@
               </a:spcAft>
             </a:pPr>
             <a:r>
-              <a:rPr lang="ja-JP" sz="1600" b="0">
+              <a:rPr lang="ja-JP" sz="2400" b="0">
                 <a:latin typeface="+mn-lt"/>
                 <a:ea typeface="+mn-ea"/>
               </a:rPr>
               <a:t>　　</a:t>
             </a:r>
+            <a:endParaRPr lang="ja-JP" sz="1600" b="0">
+              <a:latin typeface="+mn-lt"/>
+              <a:ea typeface="+mn-ea"/>
+            </a:endParaRPr>
           </a:p>
         </p:txBody>
       </p:sp>

</xml_diff>

<commit_message>
slides: 本人の編集版を更新 (10-06 15:07)
</commit_message>
<xml_diff>
--- a/slides/2026-10-09_研究報告_10枚版.pptx
+++ b/slides/2026-10-09_研究報告_10枚版.pptx
@@ -10,8 +10,8 @@
   <p:sldIdLst>
     <p:sldId id="256" r:id="rId2"/>
     <p:sldId id="257" r:id="rId3"/>
-    <p:sldId id="258" r:id="rId4"/>
-    <p:sldId id="259" r:id="rId5"/>
+    <p:sldId id="266" r:id="rId4"/>
+    <p:sldId id="267" r:id="rId5"/>
     <p:sldId id="260" r:id="rId6"/>
     <p:sldId id="261" r:id="rId7"/>
     <p:sldId id="262" r:id="rId8"/>
@@ -148,7 +148,7 @@
   <pc:docChgLst>
     <pc:chgData name="202304239" userId="ab1adf7a-b8eb-4038-b404-de23e20d8a3a" providerId="ADAL" clId="{6C0E59ED-D716-49AF-B2FA-B94E7B8E5A8C}"/>
     <pc:docChg chg="undo custSel addSld delSld modSld sldOrd">
-      <pc:chgData name="202304239" userId="ab1adf7a-b8eb-4038-b404-de23e20d8a3a" providerId="ADAL" clId="{6C0E59ED-D716-49AF-B2FA-B94E7B8E5A8C}" dt="2026-10-06T05:58:20.567" v="1077" actId="14100"/>
+      <pc:chgData name="202304239" userId="ab1adf7a-b8eb-4038-b404-de23e20d8a3a" providerId="ADAL" clId="{6C0E59ED-D716-49AF-B2FA-B94E7B8E5A8C}" dt="2026-10-06T06:07:35.690" v="1080" actId="2696"/>
       <pc:docMkLst>
         <pc:docMk/>
       </pc:docMkLst>
@@ -183,15 +183,15 @@
           </ac:picMkLst>
         </pc:picChg>
       </pc:sldChg>
-      <pc:sldChg chg="modSp mod">
-        <pc:chgData name="202304239" userId="ab1adf7a-b8eb-4038-b404-de23e20d8a3a" providerId="ADAL" clId="{6C0E59ED-D716-49AF-B2FA-B94E7B8E5A8C}" dt="2026-10-02T01:15:41.310" v="14" actId="1076"/>
+      <pc:sldChg chg="modSp del mod">
+        <pc:chgData name="202304239" userId="ab1adf7a-b8eb-4038-b404-de23e20d8a3a" providerId="ADAL" clId="{6C0E59ED-D716-49AF-B2FA-B94E7B8E5A8C}" dt="2026-10-06T06:07:35.690" v="1080" actId="2696"/>
         <pc:sldMkLst>
           <pc:docMk/>
           <pc:sldMk cId="0" sldId="258"/>
         </pc:sldMkLst>
       </pc:sldChg>
-      <pc:sldChg chg="modSp mod">
-        <pc:chgData name="202304239" userId="ab1adf7a-b8eb-4038-b404-de23e20d8a3a" providerId="ADAL" clId="{6C0E59ED-D716-49AF-B2FA-B94E7B8E5A8C}" dt="2026-10-05T03:38:03.028" v="92" actId="20577"/>
+      <pc:sldChg chg="modSp del mod">
+        <pc:chgData name="202304239" userId="ab1adf7a-b8eb-4038-b404-de23e20d8a3a" providerId="ADAL" clId="{6C0E59ED-D716-49AF-B2FA-B94E7B8E5A8C}" dt="2026-10-06T06:07:35.689" v="1079" actId="2696"/>
         <pc:sldMkLst>
           <pc:docMk/>
           <pc:sldMk cId="0" sldId="259"/>
@@ -281,6 +281,13 @@
           </ac:spMkLst>
         </pc:spChg>
       </pc:sldChg>
+      <pc:sldChg chg="add">
+        <pc:chgData name="202304239" userId="ab1adf7a-b8eb-4038-b404-de23e20d8a3a" providerId="ADAL" clId="{6C0E59ED-D716-49AF-B2FA-B94E7B8E5A8C}" dt="2026-10-06T06:07:35.672" v="1078"/>
+        <pc:sldMkLst>
+          <pc:docMk/>
+          <pc:sldMk cId="2393486084" sldId="266"/>
+        </pc:sldMkLst>
+      </pc:sldChg>
       <pc:sldChg chg="modSp mod">
         <pc:chgData name="202304239" userId="ab1adf7a-b8eb-4038-b404-de23e20d8a3a" providerId="ADAL" clId="{6C0E59ED-D716-49AF-B2FA-B94E7B8E5A8C}" dt="2026-10-05T05:54:48.411" v="799" actId="20577"/>
         <pc:sldMkLst>
@@ -295,6 +302,13 @@
             <ac:spMk id="2" creationId="{00000000-0000-0000-0000-000000000000}"/>
           </ac:spMkLst>
         </pc:spChg>
+      </pc:sldChg>
+      <pc:sldChg chg="add">
+        <pc:chgData name="202304239" userId="ab1adf7a-b8eb-4038-b404-de23e20d8a3a" providerId="ADAL" clId="{6C0E59ED-D716-49AF-B2FA-B94E7B8E5A8C}" dt="2026-10-06T06:07:35.672" v="1078"/>
+        <pc:sldMkLst>
+          <pc:docMk/>
+          <pc:sldMk cId="99932586" sldId="267"/>
+        </pc:sldMkLst>
       </pc:sldChg>
       <pc:sldChg chg="ord">
         <pc:chgData name="202304239" userId="ab1adf7a-b8eb-4038-b404-de23e20d8a3a" providerId="ADAL" clId="{6C0E59ED-D716-49AF-B2FA-B94E7B8E5A8C}" dt="2026-10-05T05:30:57.405" v="739"/>
@@ -1193,7 +1207,7 @@
           <a:lstStyle/>
           <a:p>
             <a:r>
-              <a:t>何も無い空 23 か所 × ビン 2〜10 (207 個): 平均 +0.08、ばらつき 1.19。平均が 0 からずれていない (＝引く量は無い) のに、幅が広い (＝割る量がある)。定義: 較正後の σ ＝ 名目の σ ÷ 1.2〜1.3。同じことを『名目 5 × 1.2〜1.3 ≈ 6〜6.5σ 以上を本当の 5σ とみなす』と言い換えられる。限界: 23 か所 (207 個) では 3σ くらいまでの分布しか見えない。17σ のような大きい値でも同じ倍率かは仮定。標準の方法: McDaniel ほか (2024, arXiv:2311.04982) とその更新 (2026, arXiv:2605.25586) は、高緯度の何も無い方向 6,500 か所を解析し、その結果の分布で『信号が無いときの分布』を決めて有意度を出す。理由は『名目の計算は背景モデルのずれや見えない天体を考えていないので、信号が無い場合の分布として不十分』。</a:t>
+              <a:t>何も無い空: |b| &gt; 20°、既知の標的から 20° 以上、互いに 20° 以上離した 23 か所 (code/target_geometry.py make_control_fields)。解析は矮小銀河と同じ (code/apply_v20_method_targets.py、半径 10°、1° セル、公式の露出、Totani 方式の MCMC で最良値)。ハローの型紙は典型的な矮小銀河 (θs = 0.1°, 距離 100 kpc)。σ = √(2Δln L) をハローの符号で符号付け。207 個 = 23 か所 × ビン 2〜10。平均 +0.08、標準偏差 1.18。|σ|&gt;2: 実測 10.6% (+側 6.3%、−側 4.3%)、理論 4.6% (各 2.3%)。置き方を変えた 3 組を足して 92 か所: 20.8 GeV で 1.24 倍 (1.15〜1.32)。</a:t>
             </a:r>
           </a:p>
         </p:txBody>
@@ -1211,6 +1225,11 @@
         <p:spPr/>
       </p:sp>
     </p:spTree>
+    <p:extLst>
+      <p:ext uri="{BB962C8B-B14F-4D97-AF65-F5344CB8AC3E}">
+        <p14:creationId xmlns:p14="http://schemas.microsoft.com/office/powerpoint/2010/main" val="4056977363"/>
+      </p:ext>
+    </p:extLst>
   </p:cSld>
   <p:clrMapOvr>
     <a:masterClrMapping/>
@@ -1263,7 +1282,7 @@
           <a:lstStyle/>
           <a:p>
             <a:r>
-              <a:t>何も無い空: |b| &gt; 20°、既知の標的から離し、互いに 20° 以上離した 23 か所。矮小銀河と同じ解析 (半径 10°、等方・ガス・ICS・点源・ハロー、1° セル)。偽の空: 天の川の解析の『ハローなしの最良の予測』にポアソン乱数を足した光子の地図を 300 枚 × 13 ビン作り、同じ解析をした (code/mw_null_pseudo.py)。ばらつき 0.89〜1.06。偽の空は型紙そのものから作るので、型紙のずれは入らない。だから 1.0 になるのは当然で、差の 1.2〜1.3 が型紙のずれ。Fermi チームの何も無い空 (blank fields) も『見えない天体と背景モデルの不確かさを含めるため』に使う (McDaniel ほか 2024)。</a:t>
+              <a:t>引く/割る: code/slides_1009/q1_calc.py。|σ|&gt;2 の割合 実測 10.6%、理論 4.6%、平均を引くと 10.1%、1.19 で割ると 4.8%。偽の空: 天の川の解析の『ハローなしの最良の予測』にポアソン乱数を足した地図 (code/mw_null_pseudo.py)。旧露出 300 枚 × 13 ビンで 0.89〜1.06、公式の露出 120 枚 × ビン 1〜6 で 0.87〜1.10 (20.8 GeV で 1.00)。何も無い空で 8 個の係数を合わせてよいか: 何も無い空にも背景の光 (遠い銀河・ガス・ICS・点源) はあるので、その係数は合わせる必要がある。ハローの係数も自由にする。最初から 0 と決めると『0 になるか』の試験にならないため。Fermi: McDaniel et al. 2024, PRD (arXiv:2311.04982)、更新 arXiv:2605.25586。高緯度の何も無い方向 6,500 か所で、信号が無いときの分布を実測。限界: 207 個では 3σ くらいまでしか確かめられない。17σ でも同じ倍率かは仮定。</a:t>
             </a:r>
           </a:p>
         </p:txBody>
@@ -1281,6 +1300,11 @@
         <p:spPr/>
       </p:sp>
     </p:spTree>
+    <p:extLst>
+      <p:ext uri="{BB962C8B-B14F-4D97-AF65-F5344CB8AC3E}">
+        <p14:creationId xmlns:p14="http://schemas.microsoft.com/office/powerpoint/2010/main" val="387998353"/>
+      </p:ext>
+    </p:extLst>
   </p:cSld>
   <p:clrMapOvr>
     <a:masterClrMapping/>
@@ -5282,7 +5306,7 @@
                 <a:latin typeface="+mj-lt"/>
                 <a:ea typeface="+mj-ea"/>
               </a:rPr>
-              <a:t>先週の疑問①：1.2〜1.3 は「引く」？「割る」？</a:t>
+              <a:t>先週の疑問①②：何も無い空で試したこと</a:t>
             </a:r>
           </a:p>
         </p:txBody>
@@ -5295,8 +5319,8 @@
         </p:nvSpPr>
         <p:spPr>
           <a:xfrm>
-            <a:off x="548640" y="1280160"/>
-            <a:ext cx="5852160" cy="4937760"/>
+            <a:off x="457200" y="1371600"/>
+            <a:ext cx="6400800" cy="5394960"/>
           </a:xfrm>
           <a:prstGeom prst="rect">
             <a:avLst/>
@@ -5309,87 +5333,171 @@
           </a:bodyPr>
           <a:lstStyle/>
           <a:p>
-            <a:pPr>
+            <a:pPr marL="274320" indent="-274320">
               <a:spcAft>
                 <a:spcPts val="500"/>
               </a:spcAft>
             </a:pPr>
             <a:r>
-              <a:rPr lang="ja-JP" sz="1700" b="0">
+              <a:rPr lang="ja-JP" sz="1600" b="1">
                 <a:latin typeface="+mn-lt"/>
                 <a:ea typeface="+mn-ea"/>
               </a:rPr>
-              <a:t>・何も無い空で σ を測ると、真ん中は 0 のまま、幅だけ 1.2 倍に広がる（右の図）</a:t>
-            </a:r>
-          </a:p>
-          <a:p>
-            <a:pPr>
+              <a:t>・目的：この計算が出す σ を信じてよいか確かめる</a:t>
+            </a:r>
+          </a:p>
+          <a:p>
+            <a:pPr marL="548640" indent="0">
               <a:spcAft>
                 <a:spcPts val="500"/>
               </a:spcAft>
             </a:pPr>
             <a:r>
-              <a:rPr lang="ja-JP" sz="1700" b="1">
+              <a:rPr lang="ja-JP" sz="1300" b="0">
                 <a:latin typeface="+mn-lt"/>
                 <a:ea typeface="+mn-ea"/>
               </a:rPr>
-              <a:t>・「ずれ」ではなく「伸び」→ 引くのではなく割る</a:t>
-            </a:r>
-          </a:p>
-          <a:p>
-            <a:pPr>
+              <a:t>σ ＝ 「ハローを入れた方が光の地図によく合う」というもっともらしさ</a:t>
+            </a:r>
+          </a:p>
+          <a:p>
+            <a:pPr marL="548640" indent="0">
               <a:spcAft>
                 <a:spcPts val="500"/>
               </a:spcAft>
             </a:pPr>
             <a:r>
-              <a:rPr lang="ja-JP" sz="1400" b="0">
+              <a:rPr lang="ja-JP" sz="1300" b="0">
                 <a:latin typeface="+mn-lt"/>
                 <a:ea typeface="+mn-ea"/>
               </a:rPr>
-              <a:t>　　たとえ：目盛りが 1.2 倍に伸びた定規。引き算では直らず、1.2 で割ると直る</a:t>
-            </a:r>
-          </a:p>
-          <a:p>
-            <a:pPr>
+              <a:t>ハローが無い場所なら σ ≈ 0 になるはず。本当にそうなるか見る（体重計に何も乗せず 0 を指すか見るのと同じ）</a:t>
+            </a:r>
+          </a:p>
+          <a:p>
+            <a:pPr marL="274320" indent="-274320">
               <a:spcAft>
                 <a:spcPts val="500"/>
               </a:spcAft>
             </a:pPr>
             <a:r>
-              <a:rPr lang="ja-JP" sz="1700" b="0">
+              <a:rPr lang="ja-JP" sz="1600" b="1">
                 <a:latin typeface="+mn-lt"/>
                 <a:ea typeface="+mn-ea"/>
               </a:rPr>
-              <a:t>・グラフに「名目 6σ 以上が、本当の 5σ」と線を引いても同じこと（割るのと同じ意味）</a:t>
-            </a:r>
-          </a:p>
-          <a:p>
-            <a:pPr>
+              <a:t>・やり方</a:t>
+            </a:r>
+          </a:p>
+          <a:p>
+            <a:pPr marL="548640" indent="0">
               <a:spcAft>
                 <a:spcPts val="500"/>
               </a:spcAft>
             </a:pPr>
             <a:r>
-              <a:rPr lang="ja-JP" sz="1700" b="0">
+              <a:rPr lang="ja-JP" sz="1300" b="0">
                 <a:latin typeface="+mn-lt"/>
                 <a:ea typeface="+mn-ea"/>
               </a:rPr>
-              <a:t>・1.2 は σ の値ではなく倍率。「1.2σ 以下は使えない」という意味ではない</a:t>
-            </a:r>
-          </a:p>
-          <a:p>
-            <a:pPr>
+              <a:t>① 天の川から離れ、既知の天体（矮小銀河など）から 20° 以上離れた空を 23 か所選んだ</a:t>
+            </a:r>
+          </a:p>
+          <a:p>
+            <a:pPr marL="548640" indent="0">
               <a:spcAft>
                 <a:spcPts val="500"/>
               </a:spcAft>
             </a:pPr>
             <a:r>
-              <a:rPr lang="ja-JP" sz="1700" b="0">
+              <a:rPr lang="ja-JP" sz="1300" b="0">
                 <a:latin typeface="+mn-lt"/>
                 <a:ea typeface="+mn-ea"/>
               </a:rPr>
-              <a:t>・Fermi チームの標準：何も無い空の分布そのものと比べる（6,500 か所）。割るのは、その分布が「幅の広い山」だとしたときの簡単な版</a:t>
+              <a:t>② 各場所で半径 10° の範囲の光子を数えた</a:t>
+            </a:r>
+          </a:p>
+          <a:p>
+            <a:pPr marL="548640" indent="0">
+              <a:spcAft>
+                <a:spcPts val="500"/>
+              </a:spcAft>
+            </a:pPr>
+            <a:r>
+              <a:rPr lang="ja-JP" sz="1300" b="0">
+                <a:latin typeface="+mn-lt"/>
+                <a:ea typeface="+mn-ea"/>
+              </a:rPr>
+              <a:t>③ 背景 4 つ（等方・ガス・ICS・点源）＋ハローの型紙で、天の川と同じ MCMC で合わせた</a:t>
+            </a:r>
+          </a:p>
+          <a:p>
+            <a:pPr marL="548640" indent="0">
+              <a:spcAft>
+                <a:spcPts val="500"/>
+              </a:spcAft>
+            </a:pPr>
+            <a:r>
+              <a:rPr lang="ja-JP" sz="1300" b="0">
+                <a:latin typeface="+mn-lt"/>
+                <a:ea typeface="+mn-ea"/>
+              </a:rPr>
+              <a:t>④ ハローあり／なしの点数の差から σ を出した（9 つのエネルギーで、計 207 個）</a:t>
+            </a:r>
+          </a:p>
+          <a:p>
+            <a:pPr marL="274320" indent="-274320">
+              <a:spcAft>
+                <a:spcPts val="500"/>
+              </a:spcAft>
+            </a:pPr>
+            <a:r>
+              <a:rPr lang="ja-JP" sz="1600" b="1">
+                <a:latin typeface="+mn-lt"/>
+                <a:ea typeface="+mn-ea"/>
+              </a:rPr>
+              <a:t>・結果：σ は 0 のまわりに散らばるが、散らばりが計算の予想の 1.2 倍広い</a:t>
+            </a:r>
+          </a:p>
+          <a:p>
+            <a:pPr marL="548640" indent="0">
+              <a:spcAft>
+                <a:spcPts val="500"/>
+              </a:spcAft>
+            </a:pPr>
+            <a:r>
+              <a:rPr lang="ja-JP" sz="1300" b="0">
+                <a:latin typeface="+mn-lt"/>
+                <a:ea typeface="+mn-ea"/>
+              </a:rPr>
+              <a:t>±2σ を超えた場所：予想 4.6% → 実測 10.6%（プラス側もマイナス側も増えた）</a:t>
+            </a:r>
+          </a:p>
+          <a:p>
+            <a:pPr marL="274320" indent="-274320">
+              <a:spcAft>
+                <a:spcPts val="500"/>
+              </a:spcAft>
+            </a:pPr>
+            <a:r>
+              <a:rPr lang="ja-JP" sz="1600" b="1">
+                <a:latin typeface="+mn-lt"/>
+                <a:ea typeface="+mn-ea"/>
+              </a:rPr>
+              <a:t>・意味：何も無いのに大きな σ が出やすい ＝ この計算は σ を 1.2 倍大きめに出すクセがある</a:t>
+            </a:r>
+          </a:p>
+          <a:p>
+            <a:pPr marL="548640" indent="0">
+              <a:spcAft>
+                <a:spcPts val="500"/>
+              </a:spcAft>
+            </a:pPr>
+            <a:r>
+              <a:rPr lang="ja-JP" sz="1300" b="0">
+                <a:latin typeface="+mn-lt"/>
+                <a:ea typeface="+mn-ea"/>
+              </a:rPr>
+              <a:t>→ 本番の 17.6σ も、その分を割り引いて読む必要がある（÷1.2〜1.3 → 14〜15σ）</a:t>
             </a:r>
           </a:p>
         </p:txBody>
@@ -5410,8 +5518,8 @@
         </p:blipFill>
         <p:spPr>
           <a:xfrm>
-            <a:off x="6492240" y="1463040"/>
-            <a:ext cx="5486400" cy="3072384"/>
+            <a:off x="6949440" y="1737360"/>
+            <a:ext cx="5029200" cy="2816352"/>
           </a:xfrm>
           <a:prstGeom prst="rect">
             <a:avLst/>
@@ -5419,6 +5527,11 @@
         </p:spPr>
       </p:pic>
     </p:spTree>
+    <p:extLst>
+      <p:ext uri="{BB962C8B-B14F-4D97-AF65-F5344CB8AC3E}">
+        <p14:creationId xmlns:p14="http://schemas.microsoft.com/office/powerpoint/2010/main" val="2393486084"/>
+      </p:ext>
+    </p:extLst>
   </p:cSld>
   <p:clrMapOvr>
     <a:masterClrMapping/>
@@ -5463,7 +5576,7 @@
                 <a:latin typeface="+mj-lt"/>
                 <a:ea typeface="+mj-ea"/>
               </a:rPr>
-              <a:t>先週の疑問②：何も無い空はどこから？パラメータ 0 ではだめ？</a:t>
+              <a:t>先週の疑問①②：なぜ「割る」？　0 にするのではだめ？</a:t>
             </a:r>
           </a:p>
         </p:txBody>
@@ -5476,8 +5589,8 @@
         </p:nvSpPr>
         <p:spPr>
           <a:xfrm>
-            <a:off x="548640" y="1280160"/>
-            <a:ext cx="5852160" cy="4937760"/>
+            <a:off x="457200" y="1371600"/>
+            <a:ext cx="6400800" cy="5394960"/>
           </a:xfrm>
           <a:prstGeom prst="rect">
             <a:avLst/>
@@ -5490,108 +5603,178 @@
           </a:bodyPr>
           <a:lstStyle/>
           <a:p>
-            <a:pPr>
+            <a:pPr marL="274320" indent="-274320">
               <a:spcAft>
                 <a:spcPts val="500"/>
               </a:spcAft>
             </a:pPr>
             <a:r>
-              <a:rPr lang="ja-JP" sz="1700" b="0">
+              <a:rPr lang="ja-JP" sz="1600" b="1">
                 <a:latin typeface="+mn-lt"/>
                 <a:ea typeface="+mn-ea"/>
               </a:rPr>
-              <a:t>・本物の何も無い空：既知の天体が無い高緯度の 23 か所を、実際のデータから取った</a:t>
-            </a:r>
-          </a:p>
-          <a:p>
-            <a:pPr>
+              <a:t>・なぜ「引く」ではなく「割る」のか</a:t>
+            </a:r>
+          </a:p>
+          <a:p>
+            <a:pPr marL="548640" indent="0">
               <a:spcAft>
                 <a:spcPts val="500"/>
               </a:spcAft>
             </a:pPr>
             <a:r>
-              <a:rPr lang="ja-JP" sz="1400" b="0">
+              <a:rPr lang="ja-JP" sz="1300" b="0">
                 <a:latin typeface="+mn-lt"/>
                 <a:ea typeface="+mn-ea"/>
               </a:rPr>
-              <a:t>　　「何も無い」＝探している天体が無い。背景の光（ガス・ICS・遠い銀河）はどこにでもある → だから係数を合わせる</a:t>
-            </a:r>
-          </a:p>
-          <a:p>
-            <a:pPr>
+              <a:t>「引く」が正しいのは、全部が同じ向きにずれたとき（体重計が全員 +2 kg 多く出る → 2 引けば直る）</a:t>
+            </a:r>
+          </a:p>
+          <a:p>
+            <a:pPr marL="548640" indent="0">
               <a:spcAft>
                 <a:spcPts val="500"/>
               </a:spcAft>
             </a:pPr>
             <a:r>
-              <a:rPr lang="ja-JP" sz="1700" b="0">
+              <a:rPr lang="ja-JP" sz="1300" b="0">
                 <a:latin typeface="+mn-lt"/>
                 <a:ea typeface="+mn-ea"/>
               </a:rPr>
-              <a:t>・パラメータ 0（ハロー＝0 で偽の空を作る）もやった → ばらつきは 1.0</a:t>
-            </a:r>
-          </a:p>
-          <a:p>
-            <a:pPr>
+              <a:t>実測は、平均がほぼ 0（+0.08）のまま、プラスにもマイナスにも広がった</a:t>
+            </a:r>
+          </a:p>
+          <a:p>
+            <a:pPr marL="548640" indent="0">
               <a:spcAft>
                 <a:spcPts val="500"/>
               </a:spcAft>
             </a:pPr>
             <a:r>
-              <a:rPr lang="ja-JP" sz="1400" b="0">
+              <a:rPr lang="ja-JP" sz="1300" b="0">
                 <a:latin typeface="+mn-lt"/>
                 <a:ea typeface="+mn-ea"/>
               </a:rPr>
-              <a:t>　　→ 計算のやり方そのものは正しい</a:t>
-            </a:r>
-          </a:p>
-          <a:p>
-            <a:pPr>
+              <a:t>0.08 引いても 10.6% → 10.1% でほぼ直らない。1.19 で割ると 4.8% で理論どおり（右の図）</a:t>
+            </a:r>
+          </a:p>
+          <a:p>
+            <a:pPr marL="274320" indent="-274320">
               <a:spcAft>
                 <a:spcPts val="500"/>
               </a:spcAft>
             </a:pPr>
             <a:r>
-              <a:rPr lang="ja-JP" sz="1700" b="1">
+              <a:rPr lang="ja-JP" sz="1600" b="1">
                 <a:latin typeface="+mn-lt"/>
                 <a:ea typeface="+mn-ea"/>
               </a:rPr>
-              <a:t>・2 つの差（1.2 と 1.0）が、本物の空にしかないもの</a:t>
-            </a:r>
-          </a:p>
-          <a:p>
-            <a:pPr>
+              <a:t>・先生の案「パラメータを 0 にして試す」</a:t>
+            </a:r>
+          </a:p>
+          <a:p>
+            <a:pPr marL="548640" indent="0">
               <a:spcAft>
                 <a:spcPts val="500"/>
               </a:spcAft>
             </a:pPr>
             <a:r>
-              <a:rPr lang="ja-JP" sz="1400" b="0">
+              <a:rPr lang="ja-JP" sz="1300" b="0">
                 <a:latin typeface="+mn-lt"/>
                 <a:ea typeface="+mn-ea"/>
               </a:rPr>
-              <a:t>　　型紙のずれ・まだ見つかっていない暗い天体</a:t>
-            </a:r>
-          </a:p>
-          <a:p>
-            <a:pPr>
+              <a:t>これもやった：ハロー＝0 の偽の光子地図を作り、同じ計算 → 散らばりは 1.0 倍（予想どおり）</a:t>
+            </a:r>
+          </a:p>
+          <a:p>
+            <a:pPr marL="548640" indent="0">
               <a:spcAft>
                 <a:spcPts val="500"/>
               </a:spcAft>
             </a:pPr>
             <a:r>
-              <a:rPr lang="ja-JP" sz="1700" b="0">
+              <a:rPr lang="ja-JP" sz="1300" b="0">
                 <a:latin typeface="+mn-lt"/>
                 <a:ea typeface="+mn-ea"/>
               </a:rPr>
-              <a:t>・本物の空を使うのは、それを測るため（Fermi チームの標準と同じ）</a:t>
+              <a:t>おかしい案ではない。ただし分かるのは「計算の道具は正しい」まで</a:t>
+            </a:r>
+          </a:p>
+          <a:p>
+            <a:pPr marL="548640" indent="0">
+              <a:spcAft>
+                <a:spcPts val="500"/>
+              </a:spcAft>
+            </a:pPr>
+            <a:r>
+              <a:rPr lang="ja-JP" sz="1300" b="0">
+                <a:latin typeface="+mn-lt"/>
+                <a:ea typeface="+mn-ea"/>
+              </a:rPr>
+              <a:t>偽の地図は型紙そのものから作るので、「型紙と本物の空のずれ」が入っていない</a:t>
+            </a:r>
+          </a:p>
+          <a:p>
+            <a:pPr marL="548640" indent="0">
+              <a:spcAft>
+                <a:spcPts val="500"/>
+              </a:spcAft>
+            </a:pPr>
+            <a:r>
+              <a:rPr lang="ja-JP" sz="1300" b="0">
+                <a:latin typeface="+mn-lt"/>
+                <a:ea typeface="+mn-ea"/>
+              </a:rPr>
+              <a:t>本物の空 1.2 倍 − 偽の空 1.0 倍 の差が、型紙のずれ（と見えない暗い天体）の分 → だから本物の空も要る</a:t>
+            </a:r>
+          </a:p>
+          <a:p>
+            <a:pPr marL="274320" indent="-274320">
+              <a:spcAft>
+                <a:spcPts val="500"/>
+              </a:spcAft>
+            </a:pPr>
+            <a:r>
+              <a:rPr lang="ja-JP" sz="1600" b="1">
+                <a:latin typeface="+mn-lt"/>
+                <a:ea typeface="+mn-ea"/>
+              </a:rPr>
+              <a:t>・専門家も同じことをしている</a:t>
+            </a:r>
+          </a:p>
+          <a:p>
+            <a:pPr marL="548640" indent="0">
+              <a:spcAft>
+                <a:spcPts val="500"/>
+              </a:spcAft>
+            </a:pPr>
+            <a:r>
+              <a:rPr lang="ja-JP" sz="1300" b="0">
+                <a:latin typeface="+mn-lt"/>
+                <a:ea typeface="+mn-ea"/>
+              </a:rPr>
+              <a:t>Fermi 望遠鏡のチーム自身の矮小銀河の論文（McDaniel ほか 2024）も、何も無い空 6,500 か所で同じ確認をしている</a:t>
+            </a:r>
+          </a:p>
+          <a:p>
+            <a:pPr marL="548640" indent="0">
+              <a:spcAft>
+                <a:spcPts val="500"/>
+              </a:spcAft>
+            </a:pPr>
+            <a:r>
+              <a:rPr lang="ja-JP" sz="1300" b="0">
+                <a:latin typeface="+mn-lt"/>
+                <a:ea typeface="+mn-ea"/>
+              </a:rPr>
+              <a:t>理由も同じ：「背景の型紙のずれや、見えない天体の影響は、計算だけでは分からない」</a:t>
             </a:r>
           </a:p>
         </p:txBody>
       </p:sp>
       <p:pic>
         <p:nvPicPr>
-          <p:cNvPr id="4" name="Picture 3" descr="f1009_null_compare.png"/>
+          <p:cNvPr id="4" name="Picture 3" descr="f1009_q1_tail.png"/>
           <p:cNvPicPr>
             <a:picLocks noChangeAspect="1"/>
           </p:cNvPicPr>
@@ -5605,8 +5788,8 @@
         </p:blipFill>
         <p:spPr>
           <a:xfrm>
-            <a:off x="6583680" y="1463040"/>
-            <a:ext cx="5303520" cy="3592707"/>
+            <a:off x="6949440" y="1737360"/>
+            <a:ext cx="5029200" cy="3073400"/>
           </a:xfrm>
           <a:prstGeom prst="rect">
             <a:avLst/>
@@ -5614,6 +5797,11 @@
         </p:spPr>
       </p:pic>
     </p:spTree>
+    <p:extLst>
+      <p:ext uri="{BB962C8B-B14F-4D97-AF65-F5344CB8AC3E}">
+        <p14:creationId xmlns:p14="http://schemas.microsoft.com/office/powerpoint/2010/main" val="99932586"/>
+      </p:ext>
+    </p:extLst>
   </p:cSld>
   <p:clrMapOvr>
     <a:masterClrMapping/>

</xml_diff>

<commit_message>
slides: 本人の編集版を更新 (10-07 16:56)
</commit_message>
<xml_diff>
--- a/slides/2026-10-09_研究報告_10枚版.pptx
+++ b/slides/2026-10-09_研究報告_10枚版.pptx
@@ -10,8 +10,8 @@
   <p:sldIdLst>
     <p:sldId id="256" r:id="rId2"/>
     <p:sldId id="257" r:id="rId3"/>
-    <p:sldId id="266" r:id="rId4"/>
-    <p:sldId id="267" r:id="rId5"/>
+    <p:sldId id="267" r:id="rId4"/>
+    <p:sldId id="266" r:id="rId5"/>
     <p:sldId id="260" r:id="rId6"/>
     <p:sldId id="261" r:id="rId7"/>
     <p:sldId id="262" r:id="rId8"/>
@@ -148,7 +148,7 @@
   <pc:docChgLst>
     <pc:chgData name="202304239" userId="ab1adf7a-b8eb-4038-b404-de23e20d8a3a" providerId="ADAL" clId="{6C0E59ED-D716-49AF-B2FA-B94E7B8E5A8C}"/>
     <pc:docChg chg="undo custSel addSld delSld modSld sldOrd">
-      <pc:chgData name="202304239" userId="ab1adf7a-b8eb-4038-b404-de23e20d8a3a" providerId="ADAL" clId="{6C0E59ED-D716-49AF-B2FA-B94E7B8E5A8C}" dt="2026-10-06T06:07:35.690" v="1080" actId="2696"/>
+      <pc:chgData name="202304239" userId="ab1adf7a-b8eb-4038-b404-de23e20d8a3a" providerId="ADAL" clId="{6C0E59ED-D716-49AF-B2FA-B94E7B8E5A8C}" dt="2026-10-07T07:55:44.545" v="1082"/>
       <pc:docMkLst>
         <pc:docMk/>
       </pc:docMkLst>
@@ -196,14 +196,6 @@
           <pc:docMk/>
           <pc:sldMk cId="0" sldId="259"/>
         </pc:sldMkLst>
-        <pc:spChg chg="mod">
-          <ac:chgData name="202304239" userId="ab1adf7a-b8eb-4038-b404-de23e20d8a3a" providerId="ADAL" clId="{6C0E59ED-D716-49AF-B2FA-B94E7B8E5A8C}" dt="2026-10-05T03:38:03.028" v="92" actId="20577"/>
-          <ac:spMkLst>
-            <pc:docMk/>
-            <pc:sldMk cId="0" sldId="259"/>
-            <ac:spMk id="3" creationId="{00000000-0000-0000-0000-000000000000}"/>
-          </ac:spMkLst>
-        </pc:spChg>
       </pc:sldChg>
       <pc:sldChg chg="modSp mod">
         <pc:chgData name="202304239" userId="ab1adf7a-b8eb-4038-b404-de23e20d8a3a" providerId="ADAL" clId="{6C0E59ED-D716-49AF-B2FA-B94E7B8E5A8C}" dt="2026-10-05T05:17:02.100" v="689" actId="5793"/>
@@ -234,14 +226,6 @@
             <ac:spMk id="4" creationId="{00000000-0000-0000-0000-000000000000}"/>
           </ac:spMkLst>
         </pc:spChg>
-        <pc:spChg chg="del mod">
-          <ac:chgData name="202304239" userId="ab1adf7a-b8eb-4038-b404-de23e20d8a3a" providerId="ADAL" clId="{6C0E59ED-D716-49AF-B2FA-B94E7B8E5A8C}" dt="2026-10-05T04:13:08.928" v="327" actId="478"/>
-          <ac:spMkLst>
-            <pc:docMk/>
-            <pc:sldMk cId="0" sldId="263"/>
-            <ac:spMk id="8" creationId="{F85CD606-E3CE-F314-B3EE-F3D7028115CB}"/>
-          </ac:spMkLst>
-        </pc:spChg>
       </pc:sldChg>
       <pc:sldChg chg="modSp mod">
         <pc:chgData name="202304239" userId="ab1adf7a-b8eb-4038-b404-de23e20d8a3a" providerId="ADAL" clId="{6C0E59ED-D716-49AF-B2FA-B94E7B8E5A8C}" dt="2026-10-05T05:26:33.852" v="737" actId="20577"/>
@@ -266,42 +250,12 @@
           </ac:spMkLst>
         </pc:spChg>
       </pc:sldChg>
-      <pc:sldChg chg="modSp mod">
-        <pc:chgData name="202304239" userId="ab1adf7a-b8eb-4038-b404-de23e20d8a3a" providerId="ADAL" clId="{6C0E59ED-D716-49AF-B2FA-B94E7B8E5A8C}" dt="2026-10-05T05:54:05.449" v="781" actId="20577"/>
-        <pc:sldMkLst>
-          <pc:docMk/>
-          <pc:sldMk cId="0" sldId="266"/>
-        </pc:sldMkLst>
-        <pc:spChg chg="mod">
-          <ac:chgData name="202304239" userId="ab1adf7a-b8eb-4038-b404-de23e20d8a3a" providerId="ADAL" clId="{6C0E59ED-D716-49AF-B2FA-B94E7B8E5A8C}" dt="2026-10-05T05:54:05.449" v="781" actId="20577"/>
-          <ac:spMkLst>
-            <pc:docMk/>
-            <pc:sldMk cId="0" sldId="266"/>
-            <ac:spMk id="3" creationId="{00000000-0000-0000-0000-000000000000}"/>
-          </ac:spMkLst>
-        </pc:spChg>
-      </pc:sldChg>
-      <pc:sldChg chg="add">
-        <pc:chgData name="202304239" userId="ab1adf7a-b8eb-4038-b404-de23e20d8a3a" providerId="ADAL" clId="{6C0E59ED-D716-49AF-B2FA-B94E7B8E5A8C}" dt="2026-10-06T06:07:35.672" v="1078"/>
+      <pc:sldChg chg="add ord">
+        <pc:chgData name="202304239" userId="ab1adf7a-b8eb-4038-b404-de23e20d8a3a" providerId="ADAL" clId="{6C0E59ED-D716-49AF-B2FA-B94E7B8E5A8C}" dt="2026-10-07T07:55:44.545" v="1082"/>
         <pc:sldMkLst>
           <pc:docMk/>
           <pc:sldMk cId="2393486084" sldId="266"/>
         </pc:sldMkLst>
-      </pc:sldChg>
-      <pc:sldChg chg="modSp mod">
-        <pc:chgData name="202304239" userId="ab1adf7a-b8eb-4038-b404-de23e20d8a3a" providerId="ADAL" clId="{6C0E59ED-D716-49AF-B2FA-B94E7B8E5A8C}" dt="2026-10-05T05:54:48.411" v="799" actId="20577"/>
-        <pc:sldMkLst>
-          <pc:docMk/>
-          <pc:sldMk cId="0" sldId="267"/>
-        </pc:sldMkLst>
-        <pc:spChg chg="mod">
-          <ac:chgData name="202304239" userId="ab1adf7a-b8eb-4038-b404-de23e20d8a3a" providerId="ADAL" clId="{6C0E59ED-D716-49AF-B2FA-B94E7B8E5A8C}" dt="2026-10-05T05:54:48.411" v="799" actId="20577"/>
-          <ac:spMkLst>
-            <pc:docMk/>
-            <pc:sldMk cId="0" sldId="267"/>
-            <ac:spMk id="2" creationId="{00000000-0000-0000-0000-000000000000}"/>
-          </ac:spMkLst>
-        </pc:spChg>
       </pc:sldChg>
       <pc:sldChg chg="add">
         <pc:chgData name="202304239" userId="ab1adf7a-b8eb-4038-b404-de23e20d8a3a" providerId="ADAL" clId="{6C0E59ED-D716-49AF-B2FA-B94E7B8E5A8C}" dt="2026-10-06T06:07:35.672" v="1078"/>
@@ -309,294 +263,6 @@
           <pc:docMk/>
           <pc:sldMk cId="99932586" sldId="267"/>
         </pc:sldMkLst>
-      </pc:sldChg>
-      <pc:sldChg chg="ord">
-        <pc:chgData name="202304239" userId="ab1adf7a-b8eb-4038-b404-de23e20d8a3a" providerId="ADAL" clId="{6C0E59ED-D716-49AF-B2FA-B94E7B8E5A8C}" dt="2026-10-05T05:30:57.405" v="739"/>
-        <pc:sldMkLst>
-          <pc:docMk/>
-          <pc:sldMk cId="0" sldId="269"/>
-        </pc:sldMkLst>
-      </pc:sldChg>
-      <pc:sldChg chg="ord">
-        <pc:chgData name="202304239" userId="ab1adf7a-b8eb-4038-b404-de23e20d8a3a" providerId="ADAL" clId="{6C0E59ED-D716-49AF-B2FA-B94E7B8E5A8C}" dt="2026-10-05T05:39:41.974" v="743"/>
-        <pc:sldMkLst>
-          <pc:docMk/>
-          <pc:sldMk cId="0" sldId="275"/>
-        </pc:sldMkLst>
-      </pc:sldChg>
-      <pc:sldChg chg="delSp mod">
-        <pc:chgData name="202304239" userId="ab1adf7a-b8eb-4038-b404-de23e20d8a3a" providerId="ADAL" clId="{6C0E59ED-D716-49AF-B2FA-B94E7B8E5A8C}" dt="2026-10-05T05:40:15.426" v="744" actId="478"/>
-        <pc:sldMkLst>
-          <pc:docMk/>
-          <pc:sldMk cId="0" sldId="276"/>
-        </pc:sldMkLst>
-        <pc:spChg chg="del">
-          <ac:chgData name="202304239" userId="ab1adf7a-b8eb-4038-b404-de23e20d8a3a" providerId="ADAL" clId="{6C0E59ED-D716-49AF-B2FA-B94E7B8E5A8C}" dt="2026-10-05T05:40:15.426" v="744" actId="478"/>
-          <ac:spMkLst>
-            <pc:docMk/>
-            <pc:sldMk cId="0" sldId="276"/>
-            <ac:spMk id="8" creationId="{F85CD606-E3CE-F314-B3EE-F3D7028115CB}"/>
-          </ac:spMkLst>
-        </pc:spChg>
-      </pc:sldChg>
-      <pc:sldChg chg="modSp mod">
-        <pc:chgData name="202304239" userId="ab1adf7a-b8eb-4038-b404-de23e20d8a3a" providerId="ADAL" clId="{6C0E59ED-D716-49AF-B2FA-B94E7B8E5A8C}" dt="2026-10-05T05:57:59.931" v="864" actId="20577"/>
-        <pc:sldMkLst>
-          <pc:docMk/>
-          <pc:sldMk cId="0" sldId="283"/>
-        </pc:sldMkLst>
-        <pc:spChg chg="mod">
-          <ac:chgData name="202304239" userId="ab1adf7a-b8eb-4038-b404-de23e20d8a3a" providerId="ADAL" clId="{6C0E59ED-D716-49AF-B2FA-B94E7B8E5A8C}" dt="2026-10-05T05:57:59.931" v="864" actId="20577"/>
-          <ac:spMkLst>
-            <pc:docMk/>
-            <pc:sldMk cId="0" sldId="283"/>
-            <ac:spMk id="2" creationId="{00000000-0000-0000-0000-000000000000}"/>
-          </ac:spMkLst>
-        </pc:spChg>
-      </pc:sldChg>
-      <pc:sldChg chg="delSp modSp mod">
-        <pc:chgData name="202304239" userId="ab1adf7a-b8eb-4038-b404-de23e20d8a3a" providerId="ADAL" clId="{6C0E59ED-D716-49AF-B2FA-B94E7B8E5A8C}" dt="2026-10-05T05:16:45.639" v="688" actId="478"/>
-        <pc:sldMkLst>
-          <pc:docMk/>
-          <pc:sldMk cId="0" sldId="294"/>
-        </pc:sldMkLst>
-        <pc:spChg chg="mod">
-          <ac:chgData name="202304239" userId="ab1adf7a-b8eb-4038-b404-de23e20d8a3a" providerId="ADAL" clId="{6C0E59ED-D716-49AF-B2FA-B94E7B8E5A8C}" dt="2026-10-05T03:49:46.800" v="146" actId="20577"/>
-          <ac:spMkLst>
-            <pc:docMk/>
-            <pc:sldMk cId="0" sldId="294"/>
-            <ac:spMk id="3" creationId="{00000000-0000-0000-0000-000000000000}"/>
-          </ac:spMkLst>
-        </pc:spChg>
-        <pc:spChg chg="del">
-          <ac:chgData name="202304239" userId="ab1adf7a-b8eb-4038-b404-de23e20d8a3a" providerId="ADAL" clId="{6C0E59ED-D716-49AF-B2FA-B94E7B8E5A8C}" dt="2026-10-05T05:16:45.639" v="688" actId="478"/>
-          <ac:spMkLst>
-            <pc:docMk/>
-            <pc:sldMk cId="0" sldId="294"/>
-            <ac:spMk id="8" creationId="{F85CD606-E3CE-F314-B3EE-F3D7028115CB}"/>
-          </ac:spMkLst>
-        </pc:spChg>
-      </pc:sldChg>
-      <pc:sldChg chg="addSp modSp mod">
-        <pc:chgData name="202304239" userId="ab1adf7a-b8eb-4038-b404-de23e20d8a3a" providerId="ADAL" clId="{6C0E59ED-D716-49AF-B2FA-B94E7B8E5A8C}" dt="2026-10-05T03:51:16.698" v="185" actId="20577"/>
-        <pc:sldMkLst>
-          <pc:docMk/>
-          <pc:sldMk cId="0" sldId="295"/>
-        </pc:sldMkLst>
-        <pc:spChg chg="mod">
-          <ac:chgData name="202304239" userId="ab1adf7a-b8eb-4038-b404-de23e20d8a3a" providerId="ADAL" clId="{6C0E59ED-D716-49AF-B2FA-B94E7B8E5A8C}" dt="2026-10-05T03:51:16.698" v="185" actId="20577"/>
-          <ac:spMkLst>
-            <pc:docMk/>
-            <pc:sldMk cId="0" sldId="295"/>
-            <ac:spMk id="2" creationId="{00000000-0000-0000-0000-000000000000}"/>
-          </ac:spMkLst>
-        </pc:spChg>
-      </pc:sldChg>
-      <pc:sldChg chg="addSp modSp mod">
-        <pc:chgData name="202304239" userId="ab1adf7a-b8eb-4038-b404-de23e20d8a3a" providerId="ADAL" clId="{6C0E59ED-D716-49AF-B2FA-B94E7B8E5A8C}" dt="2026-10-05T05:09:57.079" v="571" actId="1076"/>
-        <pc:sldMkLst>
-          <pc:docMk/>
-          <pc:sldMk cId="0" sldId="297"/>
-        </pc:sldMkLst>
-        <pc:picChg chg="add mod">
-          <ac:chgData name="202304239" userId="ab1adf7a-b8eb-4038-b404-de23e20d8a3a" providerId="ADAL" clId="{6C0E59ED-D716-49AF-B2FA-B94E7B8E5A8C}" dt="2026-10-05T05:09:57.079" v="571" actId="1076"/>
-          <ac:picMkLst>
-            <pc:docMk/>
-            <pc:sldMk cId="0" sldId="297"/>
-            <ac:picMk id="5" creationId="{A90FDE7D-1E04-5388-2EF9-2BF6180BCFE4}"/>
-          </ac:picMkLst>
-        </pc:picChg>
-      </pc:sldChg>
-      <pc:sldChg chg="addSp delSp modSp mod">
-        <pc:chgData name="202304239" userId="ab1adf7a-b8eb-4038-b404-de23e20d8a3a" providerId="ADAL" clId="{6C0E59ED-D716-49AF-B2FA-B94E7B8E5A8C}" dt="2026-10-05T05:18:16.321" v="690" actId="478"/>
-        <pc:sldMkLst>
-          <pc:docMk/>
-          <pc:sldMk cId="0" sldId="299"/>
-        </pc:sldMkLst>
-        <pc:spChg chg="del">
-          <ac:chgData name="202304239" userId="ab1adf7a-b8eb-4038-b404-de23e20d8a3a" providerId="ADAL" clId="{6C0E59ED-D716-49AF-B2FA-B94E7B8E5A8C}" dt="2026-10-05T05:18:16.321" v="690" actId="478"/>
-          <ac:spMkLst>
-            <pc:docMk/>
-            <pc:sldMk cId="0" sldId="299"/>
-            <ac:spMk id="8" creationId="{F85CD606-E3CE-F314-B3EE-F3D7028115CB}"/>
-          </ac:spMkLst>
-        </pc:spChg>
-      </pc:sldChg>
-      <pc:sldChg chg="addSp modSp mod">
-        <pc:chgData name="202304239" userId="ab1adf7a-b8eb-4038-b404-de23e20d8a3a" providerId="ADAL" clId="{6C0E59ED-D716-49AF-B2FA-B94E7B8E5A8C}" dt="2026-10-05T03:47:04.200" v="139" actId="1076"/>
-        <pc:sldMkLst>
-          <pc:docMk/>
-          <pc:sldMk cId="0" sldId="308"/>
-        </pc:sldMkLst>
-        <pc:spChg chg="mod">
-          <ac:chgData name="202304239" userId="ab1adf7a-b8eb-4038-b404-de23e20d8a3a" providerId="ADAL" clId="{6C0E59ED-D716-49AF-B2FA-B94E7B8E5A8C}" dt="2026-10-05T03:47:04.200" v="139" actId="1076"/>
-          <ac:spMkLst>
-            <pc:docMk/>
-            <pc:sldMk cId="0" sldId="308"/>
-            <ac:spMk id="3" creationId="{00000000-0000-0000-0000-000000000000}"/>
-          </ac:spMkLst>
-        </pc:spChg>
-        <pc:spChg chg="add ord">
-          <ac:chgData name="202304239" userId="ab1adf7a-b8eb-4038-b404-de23e20d8a3a" providerId="ADAL" clId="{6C0E59ED-D716-49AF-B2FA-B94E7B8E5A8C}" dt="2026-10-05T03:46:28.757" v="136" actId="167"/>
-          <ac:spMkLst>
-            <pc:docMk/>
-            <pc:sldMk cId="0" sldId="308"/>
-            <ac:spMk id="4" creationId="{07B93427-A0EC-CAF4-55EC-F54270438D49}"/>
-          </ac:spMkLst>
-        </pc:spChg>
-      </pc:sldChg>
-      <pc:sldChg chg="ord">
-        <pc:chgData name="202304239" userId="ab1adf7a-b8eb-4038-b404-de23e20d8a3a" providerId="ADAL" clId="{6C0E59ED-D716-49AF-B2FA-B94E7B8E5A8C}" dt="2026-10-05T05:25:41.089" v="718"/>
-        <pc:sldMkLst>
-          <pc:docMk/>
-          <pc:sldMk cId="0" sldId="311"/>
-        </pc:sldMkLst>
-      </pc:sldChg>
-      <pc:sldChg chg="modSp mod">
-        <pc:chgData name="202304239" userId="ab1adf7a-b8eb-4038-b404-de23e20d8a3a" providerId="ADAL" clId="{6C0E59ED-D716-49AF-B2FA-B94E7B8E5A8C}" dt="2026-10-05T03:40:28.584" v="94" actId="20577"/>
-        <pc:sldMkLst>
-          <pc:docMk/>
-          <pc:sldMk cId="0" sldId="312"/>
-        </pc:sldMkLst>
-        <pc:spChg chg="mod">
-          <ac:chgData name="202304239" userId="ab1adf7a-b8eb-4038-b404-de23e20d8a3a" providerId="ADAL" clId="{6C0E59ED-D716-49AF-B2FA-B94E7B8E5A8C}" dt="2026-10-05T03:40:28.584" v="94" actId="20577"/>
-          <ac:spMkLst>
-            <pc:docMk/>
-            <pc:sldMk cId="0" sldId="312"/>
-            <ac:spMk id="2" creationId="{00000000-0000-0000-0000-000000000000}"/>
-          </ac:spMkLst>
-        </pc:spChg>
-      </pc:sldChg>
-      <pc:sldChg chg="ord">
-        <pc:chgData name="202304239" userId="ab1adf7a-b8eb-4038-b404-de23e20d8a3a" providerId="ADAL" clId="{6C0E59ED-D716-49AF-B2FA-B94E7B8E5A8C}" dt="2026-10-05T05:32:32.607" v="741"/>
-        <pc:sldMkLst>
-          <pc:docMk/>
-          <pc:sldMk cId="0" sldId="313"/>
-        </pc:sldMkLst>
-      </pc:sldChg>
-      <pc:sldChg chg="modSp mod">
-        <pc:chgData name="202304239" userId="ab1adf7a-b8eb-4038-b404-de23e20d8a3a" providerId="ADAL" clId="{6C0E59ED-D716-49AF-B2FA-B94E7B8E5A8C}" dt="2026-10-05T05:50:29.564" v="745" actId="6549"/>
-        <pc:sldMkLst>
-          <pc:docMk/>
-          <pc:sldMk cId="0" sldId="315"/>
-        </pc:sldMkLst>
-        <pc:spChg chg="mod">
-          <ac:chgData name="202304239" userId="ab1adf7a-b8eb-4038-b404-de23e20d8a3a" providerId="ADAL" clId="{6C0E59ED-D716-49AF-B2FA-B94E7B8E5A8C}" dt="2026-10-05T05:22:49.521" v="716" actId="113"/>
-          <ac:spMkLst>
-            <pc:docMk/>
-            <pc:sldMk cId="0" sldId="315"/>
-            <ac:spMk id="2" creationId="{00000000-0000-0000-0000-000000000000}"/>
-          </ac:spMkLst>
-        </pc:spChg>
-        <pc:spChg chg="mod">
-          <ac:chgData name="202304239" userId="ab1adf7a-b8eb-4038-b404-de23e20d8a3a" providerId="ADAL" clId="{6C0E59ED-D716-49AF-B2FA-B94E7B8E5A8C}" dt="2026-10-05T05:50:29.564" v="745" actId="6549"/>
-          <ac:spMkLst>
-            <pc:docMk/>
-            <pc:sldMk cId="0" sldId="315"/>
-            <ac:spMk id="4" creationId="{00000000-0000-0000-0000-000000000000}"/>
-          </ac:spMkLst>
-        </pc:spChg>
-      </pc:sldChg>
-      <pc:sldChg chg="del">
-        <pc:chgData name="202304239" userId="ab1adf7a-b8eb-4038-b404-de23e20d8a3a" providerId="ADAL" clId="{6C0E59ED-D716-49AF-B2FA-B94E7B8E5A8C}" dt="2026-10-05T04:15:43.044" v="352" actId="47"/>
-        <pc:sldMkLst>
-          <pc:docMk/>
-          <pc:sldMk cId="0" sldId="316"/>
-        </pc:sldMkLst>
-      </pc:sldChg>
-      <pc:sldChg chg="addSp modSp new mod ord">
-        <pc:chgData name="202304239" userId="ab1adf7a-b8eb-4038-b404-de23e20d8a3a" providerId="ADAL" clId="{6C0E59ED-D716-49AF-B2FA-B94E7B8E5A8C}" dt="2026-10-05T05:14:34.606" v="687" actId="20577"/>
-        <pc:sldMkLst>
-          <pc:docMk/>
-          <pc:sldMk cId="714849090" sldId="317"/>
-        </pc:sldMkLst>
-        <pc:spChg chg="mod">
-          <ac:chgData name="202304239" userId="ab1adf7a-b8eb-4038-b404-de23e20d8a3a" providerId="ADAL" clId="{6C0E59ED-D716-49AF-B2FA-B94E7B8E5A8C}" dt="2026-10-05T04:09:31.106" v="295" actId="1076"/>
-          <ac:spMkLst>
-            <pc:docMk/>
-            <pc:sldMk cId="714849090" sldId="317"/>
-            <ac:spMk id="9" creationId="{00000000-0000-0000-0000-000000000000}"/>
-          </ac:spMkLst>
-        </pc:spChg>
-        <pc:spChg chg="add mod">
-          <ac:chgData name="202304239" userId="ab1adf7a-b8eb-4038-b404-de23e20d8a3a" providerId="ADAL" clId="{6C0E59ED-D716-49AF-B2FA-B94E7B8E5A8C}" dt="2026-10-05T04:16:45.835" v="354" actId="1076"/>
-          <ac:spMkLst>
-            <pc:docMk/>
-            <pc:sldMk cId="714849090" sldId="317"/>
-            <ac:spMk id="11" creationId="{54EEC75A-A1BF-4B87-31AF-F8D21C7F155D}"/>
-          </ac:spMkLst>
-        </pc:spChg>
-        <pc:spChg chg="add mod">
-          <ac:chgData name="202304239" userId="ab1adf7a-b8eb-4038-b404-de23e20d8a3a" providerId="ADAL" clId="{6C0E59ED-D716-49AF-B2FA-B94E7B8E5A8C}" dt="2026-10-05T04:19:25.041" v="509" actId="1076"/>
-          <ac:spMkLst>
-            <pc:docMk/>
-            <pc:sldMk cId="714849090" sldId="317"/>
-            <ac:spMk id="13" creationId="{E198F735-7ED1-C6E3-B5DD-7E35C7F9775E}"/>
-          </ac:spMkLst>
-        </pc:spChg>
-        <pc:spChg chg="add mod">
-          <ac:chgData name="202304239" userId="ab1adf7a-b8eb-4038-b404-de23e20d8a3a" providerId="ADAL" clId="{6C0E59ED-D716-49AF-B2FA-B94E7B8E5A8C}" dt="2026-10-05T04:19:25.041" v="509" actId="1076"/>
-          <ac:spMkLst>
-            <pc:docMk/>
-            <pc:sldMk cId="714849090" sldId="317"/>
-            <ac:spMk id="15" creationId="{23677353-82B3-89C2-CBEC-1909E56DA99B}"/>
-          </ac:spMkLst>
-        </pc:spChg>
-        <pc:spChg chg="add mod">
-          <ac:chgData name="202304239" userId="ab1adf7a-b8eb-4038-b404-de23e20d8a3a" providerId="ADAL" clId="{6C0E59ED-D716-49AF-B2FA-B94E7B8E5A8C}" dt="2026-10-05T04:19:25.041" v="509" actId="1076"/>
-          <ac:spMkLst>
-            <pc:docMk/>
-            <pc:sldMk cId="714849090" sldId="317"/>
-            <ac:spMk id="17" creationId="{DF60EA9B-3568-50AE-F318-5AEA0A94F1C2}"/>
-          </ac:spMkLst>
-        </pc:spChg>
-        <pc:spChg chg="add mod">
-          <ac:chgData name="202304239" userId="ab1adf7a-b8eb-4038-b404-de23e20d8a3a" providerId="ADAL" clId="{6C0E59ED-D716-49AF-B2FA-B94E7B8E5A8C}" dt="2026-10-05T05:10:29.441" v="578" actId="20577"/>
-          <ac:spMkLst>
-            <pc:docMk/>
-            <pc:sldMk cId="714849090" sldId="317"/>
-            <ac:spMk id="19" creationId="{6D1ECAA1-9C93-8B93-42E6-5DEB46F41128}"/>
-          </ac:spMkLst>
-        </pc:spChg>
-        <pc:spChg chg="add mod">
-          <ac:chgData name="202304239" userId="ab1adf7a-b8eb-4038-b404-de23e20d8a3a" providerId="ADAL" clId="{6C0E59ED-D716-49AF-B2FA-B94E7B8E5A8C}" dt="2026-10-05T05:14:34.606" v="687" actId="20577"/>
-          <ac:spMkLst>
-            <pc:docMk/>
-            <pc:sldMk cId="714849090" sldId="317"/>
-            <ac:spMk id="21" creationId="{88A0B93D-F931-0B83-FEA8-D265EBDE0153}"/>
-          </ac:spMkLst>
-        </pc:spChg>
-        <pc:spChg chg="add mod">
-          <ac:chgData name="202304239" userId="ab1adf7a-b8eb-4038-b404-de23e20d8a3a" providerId="ADAL" clId="{6C0E59ED-D716-49AF-B2FA-B94E7B8E5A8C}" dt="2026-10-05T05:14:19.840" v="667" actId="208"/>
-          <ac:spMkLst>
-            <pc:docMk/>
-            <pc:sldMk cId="714849090" sldId="317"/>
-            <ac:spMk id="22" creationId="{4090149A-27C3-A32F-1A55-9F13A204AF79}"/>
-          </ac:spMkLst>
-        </pc:spChg>
-      </pc:sldChg>
-      <pc:sldChg chg="modSp mod">
-        <pc:chgData name="202304239" userId="ab1adf7a-b8eb-4038-b404-de23e20d8a3a" providerId="ADAL" clId="{6C0E59ED-D716-49AF-B2FA-B94E7B8E5A8C}" dt="2026-10-05T05:57:08.514" v="853" actId="20577"/>
-        <pc:sldMkLst>
-          <pc:docMk/>
-          <pc:sldMk cId="0" sldId="318"/>
-        </pc:sldMkLst>
-        <pc:spChg chg="mod">
-          <ac:chgData name="202304239" userId="ab1adf7a-b8eb-4038-b404-de23e20d8a3a" providerId="ADAL" clId="{6C0E59ED-D716-49AF-B2FA-B94E7B8E5A8C}" dt="2026-10-05T05:55:47.274" v="805" actId="404"/>
-          <ac:spMkLst>
-            <pc:docMk/>
-            <pc:sldMk cId="0" sldId="318"/>
-            <ac:spMk id="2" creationId="{00000000-0000-0000-0000-000000000000}"/>
-          </ac:spMkLst>
-        </pc:spChg>
-        <pc:spChg chg="mod">
-          <ac:chgData name="202304239" userId="ab1adf7a-b8eb-4038-b404-de23e20d8a3a" providerId="ADAL" clId="{6C0E59ED-D716-49AF-B2FA-B94E7B8E5A8C}" dt="2026-10-05T05:57:08.514" v="853" actId="20577"/>
-          <ac:spMkLst>
-            <pc:docMk/>
-            <pc:sldMk cId="0" sldId="318"/>
-            <ac:spMk id="6" creationId="{00000000-0000-0000-0000-000000000000}"/>
-          </ac:spMkLst>
-        </pc:spChg>
       </pc:sldChg>
     </pc:docChg>
   </pc:docChgLst>
@@ -685,7 +351,7 @@
           <a:p>
             <a:fld id="{B414FD46-9C41-4E77-8212-EE695A2FE528}" type="datetimeFigureOut">
               <a:rPr lang="en-US" smtClean="0"/>
-              <a:t>10/6/2026</a:t>
+              <a:t>10/7/2026</a:t>
             </a:fld>
             <a:endParaRPr lang="en-US"/>
           </a:p>
@@ -1207,7 +873,7 @@
           <a:lstStyle/>
           <a:p>
             <a:r>
-              <a:t>何も無い空: |b| &gt; 20°、既知の標的から 20° 以上、互いに 20° 以上離した 23 か所 (code/target_geometry.py make_control_fields)。解析は矮小銀河と同じ (code/apply_v20_method_targets.py、半径 10°、1° セル、公式の露出、Totani 方式の MCMC で最良値)。ハローの型紙は典型的な矮小銀河 (θs = 0.1°, 距離 100 kpc)。σ = √(2Δln L) をハローの符号で符号付け。207 個 = 23 か所 × ビン 2〜10。平均 +0.08、標準偏差 1.18。|σ|&gt;2: 実測 10.6% (+側 6.3%、−側 4.3%)、理論 4.6% (各 2.3%)。置き方を変えた 3 組を足して 92 か所: 20.8 GeV で 1.24 倍 (1.15〜1.32)。</a:t>
+              <a:t>引く/割る: code/slides_1009/q1_calc.py。|σ|&gt;2 の割合 実測 10.6%、理論 4.6%、平均を引くと 10.1%、1.19 で割ると 4.8%。偽の空: 天の川の解析の『ハローなしの最良の予測』にポアソン乱数を足した地図 (code/mw_null_pseudo.py)。旧露出 300 枚 × 13 ビンで 0.89〜1.06、公式の露出 120 枚 × ビン 1〜6 で 0.87〜1.10 (20.8 GeV で 1.00)。何も無い空で 8 個の係数を合わせてよいか: 何も無い空にも背景の光 (遠い銀河・ガス・ICS・点源) はあるので、その係数は合わせる必要がある。ハローの係数も自由にする。最初から 0 と決めると『0 になるか』の試験にならないため。Fermi: McDaniel et al. 2024, PRD (arXiv:2311.04982)、更新 arXiv:2605.25586。高緯度の何も無い方向 6,500 か所で、信号が無いときの分布を実測。限界: 207 個では 3σ くらいまでしか確かめられない。17σ でも同じ倍率かは仮定。</a:t>
             </a:r>
           </a:p>
         </p:txBody>
@@ -1227,7 +893,7 @@
     </p:spTree>
     <p:extLst>
       <p:ext uri="{BB962C8B-B14F-4D97-AF65-F5344CB8AC3E}">
-        <p14:creationId xmlns:p14="http://schemas.microsoft.com/office/powerpoint/2010/main" val="4056977363"/>
+        <p14:creationId xmlns:p14="http://schemas.microsoft.com/office/powerpoint/2010/main" val="387998353"/>
       </p:ext>
     </p:extLst>
   </p:cSld>
@@ -1282,7 +948,7 @@
           <a:lstStyle/>
           <a:p>
             <a:r>
-              <a:t>引く/割る: code/slides_1009/q1_calc.py。|σ|&gt;2 の割合 実測 10.6%、理論 4.6%、平均を引くと 10.1%、1.19 で割ると 4.8%。偽の空: 天の川の解析の『ハローなしの最良の予測』にポアソン乱数を足した地図 (code/mw_null_pseudo.py)。旧露出 300 枚 × 13 ビンで 0.89〜1.06、公式の露出 120 枚 × ビン 1〜6 で 0.87〜1.10 (20.8 GeV で 1.00)。何も無い空で 8 個の係数を合わせてよいか: 何も無い空にも背景の光 (遠い銀河・ガス・ICS・点源) はあるので、その係数は合わせる必要がある。ハローの係数も自由にする。最初から 0 と決めると『0 になるか』の試験にならないため。Fermi: McDaniel et al. 2024, PRD (arXiv:2311.04982)、更新 arXiv:2605.25586。高緯度の何も無い方向 6,500 か所で、信号が無いときの分布を実測。限界: 207 個では 3σ くらいまでしか確かめられない。17σ でも同じ倍率かは仮定。</a:t>
+              <a:t>何も無い空: |b| &gt; 20°、既知の標的から 20° 以上、互いに 20° 以上離した 23 か所 (code/target_geometry.py make_control_fields)。解析は矮小銀河と同じ (code/apply_v20_method_targets.py、半径 10°、1° セル、公式の露出、Totani 方式の MCMC で最良値)。ハローの型紙は典型的な矮小銀河 (θs = 0.1°, 距離 100 kpc)。σ = √(2Δln L) をハローの符号で符号付け。207 個 = 23 か所 × ビン 2〜10。平均 +0.08、標準偏差 1.18。|σ|&gt;2: 実測 10.6% (+側 6.3%、−側 4.3%)、理論 4.6% (各 2.3%)。置き方を変えた 3 組を足して 92 か所: 20.8 GeV で 1.24 倍 (1.15〜1.32)。</a:t>
             </a:r>
           </a:p>
         </p:txBody>
@@ -1302,7 +968,7 @@
     </p:spTree>
     <p:extLst>
       <p:ext uri="{BB962C8B-B14F-4D97-AF65-F5344CB8AC3E}">
-        <p14:creationId xmlns:p14="http://schemas.microsoft.com/office/powerpoint/2010/main" val="387998353"/>
+        <p14:creationId xmlns:p14="http://schemas.microsoft.com/office/powerpoint/2010/main" val="4056977363"/>
       </p:ext>
     </p:extLst>
   </p:cSld>
@@ -1809,7 +1475,7 @@
           <a:p>
             <a:fld id="{030FFF5C-2D96-4D39-AE5C-E4AC30C80AB5}" type="datetimeFigureOut">
               <a:rPr lang="en-US" smtClean="0"/>
-              <a:t>10/6/2026</a:t>
+              <a:t>10/7/2026</a:t>
             </a:fld>
             <a:endParaRPr lang="en-US"/>
           </a:p>
@@ -2007,7 +1673,7 @@
           <a:p>
             <a:fld id="{030FFF5C-2D96-4D39-AE5C-E4AC30C80AB5}" type="datetimeFigureOut">
               <a:rPr lang="en-US" smtClean="0"/>
-              <a:t>10/6/2026</a:t>
+              <a:t>10/7/2026</a:t>
             </a:fld>
             <a:endParaRPr lang="en-US"/>
           </a:p>
@@ -2215,7 +1881,7 @@
           <a:p>
             <a:fld id="{030FFF5C-2D96-4D39-AE5C-E4AC30C80AB5}" type="datetimeFigureOut">
               <a:rPr lang="en-US" smtClean="0"/>
-              <a:t>10/6/2026</a:t>
+              <a:t>10/7/2026</a:t>
             </a:fld>
             <a:endParaRPr lang="en-US"/>
           </a:p>
@@ -2413,7 +2079,7 @@
           <a:p>
             <a:fld id="{030FFF5C-2D96-4D39-AE5C-E4AC30C80AB5}" type="datetimeFigureOut">
               <a:rPr lang="en-US" smtClean="0"/>
-              <a:t>10/6/2026</a:t>
+              <a:t>10/7/2026</a:t>
             </a:fld>
             <a:endParaRPr lang="en-US"/>
           </a:p>
@@ -2688,7 +2354,7 @@
           <a:p>
             <a:fld id="{030FFF5C-2D96-4D39-AE5C-E4AC30C80AB5}" type="datetimeFigureOut">
               <a:rPr lang="en-US" smtClean="0"/>
-              <a:t>10/6/2026</a:t>
+              <a:t>10/7/2026</a:t>
             </a:fld>
             <a:endParaRPr lang="en-US"/>
           </a:p>
@@ -2953,7 +2619,7 @@
           <a:p>
             <a:fld id="{030FFF5C-2D96-4D39-AE5C-E4AC30C80AB5}" type="datetimeFigureOut">
               <a:rPr lang="en-US" smtClean="0"/>
-              <a:t>10/6/2026</a:t>
+              <a:t>10/7/2026</a:t>
             </a:fld>
             <a:endParaRPr lang="en-US"/>
           </a:p>
@@ -3365,7 +3031,7 @@
           <a:p>
             <a:fld id="{030FFF5C-2D96-4D39-AE5C-E4AC30C80AB5}" type="datetimeFigureOut">
               <a:rPr lang="en-US" smtClean="0"/>
-              <a:t>10/6/2026</a:t>
+              <a:t>10/7/2026</a:t>
             </a:fld>
             <a:endParaRPr lang="en-US"/>
           </a:p>
@@ -3506,7 +3172,7 @@
           <a:p>
             <a:fld id="{030FFF5C-2D96-4D39-AE5C-E4AC30C80AB5}" type="datetimeFigureOut">
               <a:rPr lang="en-US" smtClean="0"/>
-              <a:t>10/6/2026</a:t>
+              <a:t>10/7/2026</a:t>
             </a:fld>
             <a:endParaRPr lang="en-US"/>
           </a:p>
@@ -3619,7 +3285,7 @@
           <a:p>
             <a:fld id="{030FFF5C-2D96-4D39-AE5C-E4AC30C80AB5}" type="datetimeFigureOut">
               <a:rPr lang="en-US" smtClean="0"/>
-              <a:t>10/6/2026</a:t>
+              <a:t>10/7/2026</a:t>
             </a:fld>
             <a:endParaRPr lang="en-US"/>
           </a:p>
@@ -3930,7 +3596,7 @@
           <a:p>
             <a:fld id="{030FFF5C-2D96-4D39-AE5C-E4AC30C80AB5}" type="datetimeFigureOut">
               <a:rPr lang="en-US" smtClean="0"/>
-              <a:t>10/6/2026</a:t>
+              <a:t>10/7/2026</a:t>
             </a:fld>
             <a:endParaRPr lang="en-US"/>
           </a:p>
@@ -4218,7 +3884,7 @@
           <a:p>
             <a:fld id="{030FFF5C-2D96-4D39-AE5C-E4AC30C80AB5}" type="datetimeFigureOut">
               <a:rPr lang="en-US" smtClean="0"/>
-              <a:t>10/6/2026</a:t>
+              <a:t>10/7/2026</a:t>
             </a:fld>
             <a:endParaRPr lang="en-US"/>
           </a:p>
@@ -4459,7 +4125,7 @@
           <a:p>
             <a:fld id="{030FFF5C-2D96-4D39-AE5C-E4AC30C80AB5}" type="datetimeFigureOut">
               <a:rPr lang="en-US" smtClean="0"/>
-              <a:t>10/6/2026</a:t>
+              <a:t>10/7/2026</a:t>
             </a:fld>
             <a:endParaRPr lang="en-US"/>
           </a:p>
@@ -5306,6 +4972,276 @@
                 <a:latin typeface="+mj-lt"/>
                 <a:ea typeface="+mj-ea"/>
               </a:rPr>
+              <a:t>先週の疑問①②：なぜ「割る」？　0 にするのではだめ？</a:t>
+            </a:r>
+          </a:p>
+        </p:txBody>
+      </p:sp>
+      <p:sp>
+        <p:nvSpPr>
+          <p:cNvPr id="3" name="TextBox 2"/>
+          <p:cNvSpPr txBox="1"/>
+          <p:nvPr/>
+        </p:nvSpPr>
+        <p:spPr>
+          <a:xfrm>
+            <a:off x="457200" y="1371600"/>
+            <a:ext cx="6400800" cy="5394960"/>
+          </a:xfrm>
+          <a:prstGeom prst="rect">
+            <a:avLst/>
+          </a:prstGeom>
+          <a:noFill/>
+        </p:spPr>
+        <p:txBody>
+          <a:bodyPr wrap="square">
+            <a:spAutoFit/>
+          </a:bodyPr>
+          <a:lstStyle/>
+          <a:p>
+            <a:pPr marL="274320" indent="-274320">
+              <a:spcAft>
+                <a:spcPts val="500"/>
+              </a:spcAft>
+            </a:pPr>
+            <a:r>
+              <a:rPr lang="ja-JP" sz="1600" b="1">
+                <a:latin typeface="+mn-lt"/>
+                <a:ea typeface="+mn-ea"/>
+              </a:rPr>
+              <a:t>・なぜ「引く」ではなく「割る」のか</a:t>
+            </a:r>
+          </a:p>
+          <a:p>
+            <a:pPr marL="548640" indent="0">
+              <a:spcAft>
+                <a:spcPts val="500"/>
+              </a:spcAft>
+            </a:pPr>
+            <a:r>
+              <a:rPr lang="ja-JP" sz="1300" b="0">
+                <a:latin typeface="+mn-lt"/>
+                <a:ea typeface="+mn-ea"/>
+              </a:rPr>
+              <a:t>「引く」が正しいのは、全部が同じ向きにずれたとき（体重計が全員 +2 kg 多く出る → 2 引けば直る）</a:t>
+            </a:r>
+          </a:p>
+          <a:p>
+            <a:pPr marL="548640" indent="0">
+              <a:spcAft>
+                <a:spcPts val="500"/>
+              </a:spcAft>
+            </a:pPr>
+            <a:r>
+              <a:rPr lang="ja-JP" sz="1300" b="0">
+                <a:latin typeface="+mn-lt"/>
+                <a:ea typeface="+mn-ea"/>
+              </a:rPr>
+              <a:t>実測は、平均がほぼ 0（+0.08）のまま、プラスにもマイナスにも広がった</a:t>
+            </a:r>
+          </a:p>
+          <a:p>
+            <a:pPr marL="548640" indent="0">
+              <a:spcAft>
+                <a:spcPts val="500"/>
+              </a:spcAft>
+            </a:pPr>
+            <a:r>
+              <a:rPr lang="ja-JP" sz="1300" b="0">
+                <a:latin typeface="+mn-lt"/>
+                <a:ea typeface="+mn-ea"/>
+              </a:rPr>
+              <a:t>0.08 引いても 10.6% → 10.1% でほぼ直らない。1.19 で割ると 4.8% で理論どおり（右の図）</a:t>
+            </a:r>
+          </a:p>
+          <a:p>
+            <a:pPr marL="274320" indent="-274320">
+              <a:spcAft>
+                <a:spcPts val="500"/>
+              </a:spcAft>
+            </a:pPr>
+            <a:r>
+              <a:rPr lang="ja-JP" sz="1600" b="1">
+                <a:latin typeface="+mn-lt"/>
+                <a:ea typeface="+mn-ea"/>
+              </a:rPr>
+              <a:t>・先生の案「パラメータを 0 にして試す」</a:t>
+            </a:r>
+          </a:p>
+          <a:p>
+            <a:pPr marL="548640" indent="0">
+              <a:spcAft>
+                <a:spcPts val="500"/>
+              </a:spcAft>
+            </a:pPr>
+            <a:r>
+              <a:rPr lang="ja-JP" sz="1300" b="0">
+                <a:latin typeface="+mn-lt"/>
+                <a:ea typeface="+mn-ea"/>
+              </a:rPr>
+              <a:t>これもやった：ハロー＝0 の偽の光子地図を作り、同じ計算 → 散らばりは 1.0 倍（予想どおり）</a:t>
+            </a:r>
+          </a:p>
+          <a:p>
+            <a:pPr marL="548640" indent="0">
+              <a:spcAft>
+                <a:spcPts val="500"/>
+              </a:spcAft>
+            </a:pPr>
+            <a:r>
+              <a:rPr lang="ja-JP" sz="1300" b="0">
+                <a:latin typeface="+mn-lt"/>
+                <a:ea typeface="+mn-ea"/>
+              </a:rPr>
+              <a:t>おかしい案ではない。ただし分かるのは「計算の道具は正しい」まで</a:t>
+            </a:r>
+          </a:p>
+          <a:p>
+            <a:pPr marL="548640" indent="0">
+              <a:spcAft>
+                <a:spcPts val="500"/>
+              </a:spcAft>
+            </a:pPr>
+            <a:r>
+              <a:rPr lang="ja-JP" sz="1300" b="0">
+                <a:latin typeface="+mn-lt"/>
+                <a:ea typeface="+mn-ea"/>
+              </a:rPr>
+              <a:t>偽の地図は型紙そのものから作るので、「型紙と本物の空のずれ」が入っていない</a:t>
+            </a:r>
+          </a:p>
+          <a:p>
+            <a:pPr marL="548640" indent="0">
+              <a:spcAft>
+                <a:spcPts val="500"/>
+              </a:spcAft>
+            </a:pPr>
+            <a:r>
+              <a:rPr lang="ja-JP" sz="1300" b="0">
+                <a:latin typeface="+mn-lt"/>
+                <a:ea typeface="+mn-ea"/>
+              </a:rPr>
+              <a:t>本物の空 1.2 倍 − 偽の空 1.0 倍 の差が、型紙のずれ（と見えない暗い天体）の分 → だから本物の空も要る</a:t>
+            </a:r>
+          </a:p>
+          <a:p>
+            <a:pPr marL="274320" indent="-274320">
+              <a:spcAft>
+                <a:spcPts val="500"/>
+              </a:spcAft>
+            </a:pPr>
+            <a:r>
+              <a:rPr lang="ja-JP" sz="1600" b="1">
+                <a:latin typeface="+mn-lt"/>
+                <a:ea typeface="+mn-ea"/>
+              </a:rPr>
+              <a:t>・専門家も同じことをしている</a:t>
+            </a:r>
+          </a:p>
+          <a:p>
+            <a:pPr marL="548640" indent="0">
+              <a:spcAft>
+                <a:spcPts val="500"/>
+              </a:spcAft>
+            </a:pPr>
+            <a:r>
+              <a:rPr lang="ja-JP" sz="1300" b="0">
+                <a:latin typeface="+mn-lt"/>
+                <a:ea typeface="+mn-ea"/>
+              </a:rPr>
+              <a:t>Fermi 望遠鏡のチーム自身の矮小銀河の論文（McDaniel ほか 2024）も、何も無い空 6,500 か所で同じ確認をしている</a:t>
+            </a:r>
+          </a:p>
+          <a:p>
+            <a:pPr marL="548640" indent="0">
+              <a:spcAft>
+                <a:spcPts val="500"/>
+              </a:spcAft>
+            </a:pPr>
+            <a:r>
+              <a:rPr lang="ja-JP" sz="1300" b="0">
+                <a:latin typeface="+mn-lt"/>
+                <a:ea typeface="+mn-ea"/>
+              </a:rPr>
+              <a:t>理由も同じ：「背景の型紙のずれや、見えない天体の影響は、計算だけでは分からない」</a:t>
+            </a:r>
+          </a:p>
+        </p:txBody>
+      </p:sp>
+      <p:pic>
+        <p:nvPicPr>
+          <p:cNvPr id="4" name="Picture 3" descr="f1009_q1_tail.png"/>
+          <p:cNvPicPr>
+            <a:picLocks noChangeAspect="1"/>
+          </p:cNvPicPr>
+          <p:nvPr/>
+        </p:nvPicPr>
+        <p:blipFill>
+          <a:blip r:embed="rId3"/>
+          <a:stretch>
+            <a:fillRect/>
+          </a:stretch>
+        </p:blipFill>
+        <p:spPr>
+          <a:xfrm>
+            <a:off x="6949440" y="1737360"/>
+            <a:ext cx="5029200" cy="3073400"/>
+          </a:xfrm>
+          <a:prstGeom prst="rect">
+            <a:avLst/>
+          </a:prstGeom>
+        </p:spPr>
+      </p:pic>
+    </p:spTree>
+    <p:extLst>
+      <p:ext uri="{BB962C8B-B14F-4D97-AF65-F5344CB8AC3E}">
+        <p14:creationId xmlns:p14="http://schemas.microsoft.com/office/powerpoint/2010/main" val="99932586"/>
+      </p:ext>
+    </p:extLst>
+  </p:cSld>
+  <p:clrMapOvr>
+    <a:masterClrMapping/>
+  </p:clrMapOvr>
+</p:sld>
+</file>
+
+<file path=ppt/slides/slide4.xml><?xml version="1.0" encoding="utf-8"?>
+<p:sld xmlns:a="http://schemas.openxmlformats.org/drawingml/2006/main" xmlns:r="http://schemas.openxmlformats.org/officeDocument/2006/relationships" xmlns:p="http://schemas.openxmlformats.org/presentationml/2006/main">
+  <p:cSld>
+    <p:spTree>
+      <p:nvGrpSpPr>
+        <p:cNvPr id="1" name=""/>
+        <p:cNvGrpSpPr/>
+        <p:nvPr/>
+      </p:nvGrpSpPr>
+      <p:grpSpPr>
+        <a:xfrm>
+          <a:off x="0" y="0"/>
+          <a:ext cx="0" cy="0"/>
+          <a:chOff x="0" y="0"/>
+          <a:chExt cx="0" cy="0"/>
+        </a:xfrm>
+      </p:grpSpPr>
+      <p:sp>
+        <p:nvSpPr>
+          <p:cNvPr id="2" name="Title 1"/>
+          <p:cNvSpPr>
+            <a:spLocks noGrp="1"/>
+          </p:cNvSpPr>
+          <p:nvPr>
+            <p:ph type="title"/>
+          </p:nvPr>
+        </p:nvSpPr>
+        <p:spPr/>
+        <p:txBody>
+          <a:bodyPr/>
+          <a:lstStyle/>
+          <a:p>
+            <a:r>
+              <a:rPr lang="ja-JP" sz="3000">
+                <a:latin typeface="+mj-lt"/>
+                <a:ea typeface="+mj-ea"/>
+              </a:rPr>
               <a:t>先週の疑問①②：何も無い空で試したこと</a:t>
             </a:r>
           </a:p>
@@ -5530,276 +5466,6 @@
     <p:extLst>
       <p:ext uri="{BB962C8B-B14F-4D97-AF65-F5344CB8AC3E}">
         <p14:creationId xmlns:p14="http://schemas.microsoft.com/office/powerpoint/2010/main" val="2393486084"/>
-      </p:ext>
-    </p:extLst>
-  </p:cSld>
-  <p:clrMapOvr>
-    <a:masterClrMapping/>
-  </p:clrMapOvr>
-</p:sld>
-</file>
-
-<file path=ppt/slides/slide4.xml><?xml version="1.0" encoding="utf-8"?>
-<p:sld xmlns:a="http://schemas.openxmlformats.org/drawingml/2006/main" xmlns:r="http://schemas.openxmlformats.org/officeDocument/2006/relationships" xmlns:p="http://schemas.openxmlformats.org/presentationml/2006/main">
-  <p:cSld>
-    <p:spTree>
-      <p:nvGrpSpPr>
-        <p:cNvPr id="1" name=""/>
-        <p:cNvGrpSpPr/>
-        <p:nvPr/>
-      </p:nvGrpSpPr>
-      <p:grpSpPr>
-        <a:xfrm>
-          <a:off x="0" y="0"/>
-          <a:ext cx="0" cy="0"/>
-          <a:chOff x="0" y="0"/>
-          <a:chExt cx="0" cy="0"/>
-        </a:xfrm>
-      </p:grpSpPr>
-      <p:sp>
-        <p:nvSpPr>
-          <p:cNvPr id="2" name="Title 1"/>
-          <p:cNvSpPr>
-            <a:spLocks noGrp="1"/>
-          </p:cNvSpPr>
-          <p:nvPr>
-            <p:ph type="title"/>
-          </p:nvPr>
-        </p:nvSpPr>
-        <p:spPr/>
-        <p:txBody>
-          <a:bodyPr/>
-          <a:lstStyle/>
-          <a:p>
-            <a:r>
-              <a:rPr lang="ja-JP" sz="3000">
-                <a:latin typeface="+mj-lt"/>
-                <a:ea typeface="+mj-ea"/>
-              </a:rPr>
-              <a:t>先週の疑問①②：なぜ「割る」？　0 にするのではだめ？</a:t>
-            </a:r>
-          </a:p>
-        </p:txBody>
-      </p:sp>
-      <p:sp>
-        <p:nvSpPr>
-          <p:cNvPr id="3" name="TextBox 2"/>
-          <p:cNvSpPr txBox="1"/>
-          <p:nvPr/>
-        </p:nvSpPr>
-        <p:spPr>
-          <a:xfrm>
-            <a:off x="457200" y="1371600"/>
-            <a:ext cx="6400800" cy="5394960"/>
-          </a:xfrm>
-          <a:prstGeom prst="rect">
-            <a:avLst/>
-          </a:prstGeom>
-          <a:noFill/>
-        </p:spPr>
-        <p:txBody>
-          <a:bodyPr wrap="square">
-            <a:spAutoFit/>
-          </a:bodyPr>
-          <a:lstStyle/>
-          <a:p>
-            <a:pPr marL="274320" indent="-274320">
-              <a:spcAft>
-                <a:spcPts val="500"/>
-              </a:spcAft>
-            </a:pPr>
-            <a:r>
-              <a:rPr lang="ja-JP" sz="1600" b="1">
-                <a:latin typeface="+mn-lt"/>
-                <a:ea typeface="+mn-ea"/>
-              </a:rPr>
-              <a:t>・なぜ「引く」ではなく「割る」のか</a:t>
-            </a:r>
-          </a:p>
-          <a:p>
-            <a:pPr marL="548640" indent="0">
-              <a:spcAft>
-                <a:spcPts val="500"/>
-              </a:spcAft>
-            </a:pPr>
-            <a:r>
-              <a:rPr lang="ja-JP" sz="1300" b="0">
-                <a:latin typeface="+mn-lt"/>
-                <a:ea typeface="+mn-ea"/>
-              </a:rPr>
-              <a:t>「引く」が正しいのは、全部が同じ向きにずれたとき（体重計が全員 +2 kg 多く出る → 2 引けば直る）</a:t>
-            </a:r>
-          </a:p>
-          <a:p>
-            <a:pPr marL="548640" indent="0">
-              <a:spcAft>
-                <a:spcPts val="500"/>
-              </a:spcAft>
-            </a:pPr>
-            <a:r>
-              <a:rPr lang="ja-JP" sz="1300" b="0">
-                <a:latin typeface="+mn-lt"/>
-                <a:ea typeface="+mn-ea"/>
-              </a:rPr>
-              <a:t>実測は、平均がほぼ 0（+0.08）のまま、プラスにもマイナスにも広がった</a:t>
-            </a:r>
-          </a:p>
-          <a:p>
-            <a:pPr marL="548640" indent="0">
-              <a:spcAft>
-                <a:spcPts val="500"/>
-              </a:spcAft>
-            </a:pPr>
-            <a:r>
-              <a:rPr lang="ja-JP" sz="1300" b="0">
-                <a:latin typeface="+mn-lt"/>
-                <a:ea typeface="+mn-ea"/>
-              </a:rPr>
-              <a:t>0.08 引いても 10.6% → 10.1% でほぼ直らない。1.19 で割ると 4.8% で理論どおり（右の図）</a:t>
-            </a:r>
-          </a:p>
-          <a:p>
-            <a:pPr marL="274320" indent="-274320">
-              <a:spcAft>
-                <a:spcPts val="500"/>
-              </a:spcAft>
-            </a:pPr>
-            <a:r>
-              <a:rPr lang="ja-JP" sz="1600" b="1">
-                <a:latin typeface="+mn-lt"/>
-                <a:ea typeface="+mn-ea"/>
-              </a:rPr>
-              <a:t>・先生の案「パラメータを 0 にして試す」</a:t>
-            </a:r>
-          </a:p>
-          <a:p>
-            <a:pPr marL="548640" indent="0">
-              <a:spcAft>
-                <a:spcPts val="500"/>
-              </a:spcAft>
-            </a:pPr>
-            <a:r>
-              <a:rPr lang="ja-JP" sz="1300" b="0">
-                <a:latin typeface="+mn-lt"/>
-                <a:ea typeface="+mn-ea"/>
-              </a:rPr>
-              <a:t>これもやった：ハロー＝0 の偽の光子地図を作り、同じ計算 → 散らばりは 1.0 倍（予想どおり）</a:t>
-            </a:r>
-          </a:p>
-          <a:p>
-            <a:pPr marL="548640" indent="0">
-              <a:spcAft>
-                <a:spcPts val="500"/>
-              </a:spcAft>
-            </a:pPr>
-            <a:r>
-              <a:rPr lang="ja-JP" sz="1300" b="0">
-                <a:latin typeface="+mn-lt"/>
-                <a:ea typeface="+mn-ea"/>
-              </a:rPr>
-              <a:t>おかしい案ではない。ただし分かるのは「計算の道具は正しい」まで</a:t>
-            </a:r>
-          </a:p>
-          <a:p>
-            <a:pPr marL="548640" indent="0">
-              <a:spcAft>
-                <a:spcPts val="500"/>
-              </a:spcAft>
-            </a:pPr>
-            <a:r>
-              <a:rPr lang="ja-JP" sz="1300" b="0">
-                <a:latin typeface="+mn-lt"/>
-                <a:ea typeface="+mn-ea"/>
-              </a:rPr>
-              <a:t>偽の地図は型紙そのものから作るので、「型紙と本物の空のずれ」が入っていない</a:t>
-            </a:r>
-          </a:p>
-          <a:p>
-            <a:pPr marL="548640" indent="0">
-              <a:spcAft>
-                <a:spcPts val="500"/>
-              </a:spcAft>
-            </a:pPr>
-            <a:r>
-              <a:rPr lang="ja-JP" sz="1300" b="0">
-                <a:latin typeface="+mn-lt"/>
-                <a:ea typeface="+mn-ea"/>
-              </a:rPr>
-              <a:t>本物の空 1.2 倍 − 偽の空 1.0 倍 の差が、型紙のずれ（と見えない暗い天体）の分 → だから本物の空も要る</a:t>
-            </a:r>
-          </a:p>
-          <a:p>
-            <a:pPr marL="274320" indent="-274320">
-              <a:spcAft>
-                <a:spcPts val="500"/>
-              </a:spcAft>
-            </a:pPr>
-            <a:r>
-              <a:rPr lang="ja-JP" sz="1600" b="1">
-                <a:latin typeface="+mn-lt"/>
-                <a:ea typeface="+mn-ea"/>
-              </a:rPr>
-              <a:t>・専門家も同じことをしている</a:t>
-            </a:r>
-          </a:p>
-          <a:p>
-            <a:pPr marL="548640" indent="0">
-              <a:spcAft>
-                <a:spcPts val="500"/>
-              </a:spcAft>
-            </a:pPr>
-            <a:r>
-              <a:rPr lang="ja-JP" sz="1300" b="0">
-                <a:latin typeface="+mn-lt"/>
-                <a:ea typeface="+mn-ea"/>
-              </a:rPr>
-              <a:t>Fermi 望遠鏡のチーム自身の矮小銀河の論文（McDaniel ほか 2024）も、何も無い空 6,500 か所で同じ確認をしている</a:t>
-            </a:r>
-          </a:p>
-          <a:p>
-            <a:pPr marL="548640" indent="0">
-              <a:spcAft>
-                <a:spcPts val="500"/>
-              </a:spcAft>
-            </a:pPr>
-            <a:r>
-              <a:rPr lang="ja-JP" sz="1300" b="0">
-                <a:latin typeface="+mn-lt"/>
-                <a:ea typeface="+mn-ea"/>
-              </a:rPr>
-              <a:t>理由も同じ：「背景の型紙のずれや、見えない天体の影響は、計算だけでは分からない」</a:t>
-            </a:r>
-          </a:p>
-        </p:txBody>
-      </p:sp>
-      <p:pic>
-        <p:nvPicPr>
-          <p:cNvPr id="4" name="Picture 3" descr="f1009_q1_tail.png"/>
-          <p:cNvPicPr>
-            <a:picLocks noChangeAspect="1"/>
-          </p:cNvPicPr>
-          <p:nvPr/>
-        </p:nvPicPr>
-        <p:blipFill>
-          <a:blip r:embed="rId3"/>
-          <a:stretch>
-            <a:fillRect/>
-          </a:stretch>
-        </p:blipFill>
-        <p:spPr>
-          <a:xfrm>
-            <a:off x="6949440" y="1737360"/>
-            <a:ext cx="5029200" cy="3073400"/>
-          </a:xfrm>
-          <a:prstGeom prst="rect">
-            <a:avLst/>
-          </a:prstGeom>
-        </p:spPr>
-      </p:pic>
-    </p:spTree>
-    <p:extLst>
-      <p:ext uri="{BB962C8B-B14F-4D97-AF65-F5344CB8AC3E}">
-        <p14:creationId xmlns:p14="http://schemas.microsoft.com/office/powerpoint/2010/main" val="99932586"/>
       </p:ext>
     </p:extLst>
   </p:cSld>

</xml_diff>

<commit_message>
slides: 本人の編集版を更新 (10-07 17:35)
</commit_message>
<xml_diff>
--- a/slides/2026-10-09_研究報告_10枚版.pptx
+++ b/slides/2026-10-09_研究報告_10枚版.pptx
@@ -148,7 +148,7 @@
   <pc:docChgLst>
     <pc:chgData name="202304239" userId="ab1adf7a-b8eb-4038-b404-de23e20d8a3a" providerId="ADAL" clId="{6C0E59ED-D716-49AF-B2FA-B94E7B8E5A8C}"/>
     <pc:docChg chg="undo custSel addSld delSld modSld sldOrd">
-      <pc:chgData name="202304239" userId="ab1adf7a-b8eb-4038-b404-de23e20d8a3a" providerId="ADAL" clId="{6C0E59ED-D716-49AF-B2FA-B94E7B8E5A8C}" dt="2026-10-07T07:55:44.545" v="1082"/>
+      <pc:chgData name="202304239" userId="ab1adf7a-b8eb-4038-b404-de23e20d8a3a" providerId="ADAL" clId="{6C0E59ED-D716-49AF-B2FA-B94E7B8E5A8C}" dt="2026-10-07T08:35:40.157" v="1089" actId="20577"/>
       <pc:docMkLst>
         <pc:docMk/>
       </pc:docMkLst>
@@ -257,12 +257,20 @@
           <pc:sldMk cId="2393486084" sldId="266"/>
         </pc:sldMkLst>
       </pc:sldChg>
-      <pc:sldChg chg="add">
-        <pc:chgData name="202304239" userId="ab1adf7a-b8eb-4038-b404-de23e20d8a3a" providerId="ADAL" clId="{6C0E59ED-D716-49AF-B2FA-B94E7B8E5A8C}" dt="2026-10-06T06:07:35.672" v="1078"/>
+      <pc:sldChg chg="modSp add mod">
+        <pc:chgData name="202304239" userId="ab1adf7a-b8eb-4038-b404-de23e20d8a3a" providerId="ADAL" clId="{6C0E59ED-D716-49AF-B2FA-B94E7B8E5A8C}" dt="2026-10-07T08:35:40.157" v="1089" actId="20577"/>
         <pc:sldMkLst>
           <pc:docMk/>
           <pc:sldMk cId="99932586" sldId="267"/>
         </pc:sldMkLst>
+        <pc:spChg chg="mod">
+          <ac:chgData name="202304239" userId="ab1adf7a-b8eb-4038-b404-de23e20d8a3a" providerId="ADAL" clId="{6C0E59ED-D716-49AF-B2FA-B94E7B8E5A8C}" dt="2026-10-07T08:35:40.157" v="1089" actId="20577"/>
+          <ac:spMkLst>
+            <pc:docMk/>
+            <pc:sldMk cId="99932586" sldId="267"/>
+            <ac:spMk id="2" creationId="{00000000-0000-0000-0000-000000000000}"/>
+          </ac:spMkLst>
+        </pc:spChg>
       </pc:sldChg>
     </pc:docChg>
   </pc:docChgLst>
@@ -4972,7 +4980,7 @@
                 <a:latin typeface="+mj-lt"/>
                 <a:ea typeface="+mj-ea"/>
               </a:rPr>
-              <a:t>先週の疑問①②：なぜ「割る」？　0 にするのではだめ？</a:t>
+              <a:t>先週の疑問①：なぜ「割る」？　0 にするのではだめ？</a:t>
             </a:r>
           </a:p>
         </p:txBody>

</xml_diff>

<commit_message>
slides: 本人の編集版を更新 (10-07 17:36)
</commit_message>
<xml_diff>
--- a/slides/2026-10-09_研究報告_10枚版.pptx
+++ b/slides/2026-10-09_研究報告_10枚版.pptx
@@ -148,7 +148,7 @@
   <pc:docChgLst>
     <pc:chgData name="202304239" userId="ab1adf7a-b8eb-4038-b404-de23e20d8a3a" providerId="ADAL" clId="{6C0E59ED-D716-49AF-B2FA-B94E7B8E5A8C}"/>
     <pc:docChg chg="undo custSel addSld delSld modSld sldOrd">
-      <pc:chgData name="202304239" userId="ab1adf7a-b8eb-4038-b404-de23e20d8a3a" providerId="ADAL" clId="{6C0E59ED-D716-49AF-B2FA-B94E7B8E5A8C}" dt="2026-10-07T08:35:40.157" v="1089" actId="20577"/>
+      <pc:chgData name="202304239" userId="ab1adf7a-b8eb-4038-b404-de23e20d8a3a" providerId="ADAL" clId="{6C0E59ED-D716-49AF-B2FA-B94E7B8E5A8C}" dt="2026-10-07T08:36:12.924" v="1123" actId="478"/>
       <pc:docMkLst>
         <pc:docMk/>
       </pc:docMkLst>
@@ -257,20 +257,28 @@
           <pc:sldMk cId="2393486084" sldId="266"/>
         </pc:sldMkLst>
       </pc:sldChg>
-      <pc:sldChg chg="modSp add mod">
-        <pc:chgData name="202304239" userId="ab1adf7a-b8eb-4038-b404-de23e20d8a3a" providerId="ADAL" clId="{6C0E59ED-D716-49AF-B2FA-B94E7B8E5A8C}" dt="2026-10-07T08:35:40.157" v="1089" actId="20577"/>
+      <pc:sldChg chg="delSp modSp add mod">
+        <pc:chgData name="202304239" userId="ab1adf7a-b8eb-4038-b404-de23e20d8a3a" providerId="ADAL" clId="{6C0E59ED-D716-49AF-B2FA-B94E7B8E5A8C}" dt="2026-10-07T08:36:12.924" v="1123" actId="478"/>
         <pc:sldMkLst>
           <pc:docMk/>
           <pc:sldMk cId="99932586" sldId="267"/>
         </pc:sldMkLst>
         <pc:spChg chg="mod">
-          <ac:chgData name="202304239" userId="ab1adf7a-b8eb-4038-b404-de23e20d8a3a" providerId="ADAL" clId="{6C0E59ED-D716-49AF-B2FA-B94E7B8E5A8C}" dt="2026-10-07T08:35:40.157" v="1089" actId="20577"/>
+          <ac:chgData name="202304239" userId="ab1adf7a-b8eb-4038-b404-de23e20d8a3a" providerId="ADAL" clId="{6C0E59ED-D716-49AF-B2FA-B94E7B8E5A8C}" dt="2026-10-07T08:36:07.573" v="1122" actId="20577"/>
           <ac:spMkLst>
             <pc:docMk/>
             <pc:sldMk cId="99932586" sldId="267"/>
             <ac:spMk id="2" creationId="{00000000-0000-0000-0000-000000000000}"/>
           </ac:spMkLst>
         </pc:spChg>
+        <pc:picChg chg="del">
+          <ac:chgData name="202304239" userId="ab1adf7a-b8eb-4038-b404-de23e20d8a3a" providerId="ADAL" clId="{6C0E59ED-D716-49AF-B2FA-B94E7B8E5A8C}" dt="2026-10-07T08:36:12.924" v="1123" actId="478"/>
+          <ac:picMkLst>
+            <pc:docMk/>
+            <pc:sldMk cId="99932586" sldId="267"/>
+            <ac:picMk id="4" creationId="{00000000-0000-0000-0000-000000000000}"/>
+          </ac:picMkLst>
+        </pc:picChg>
       </pc:sldChg>
     </pc:docChg>
   </pc:docChgLst>
@@ -4982,6 +4990,23 @@
               </a:rPr>
               <a:t>先週の疑問①：なぜ「割る」？　0 にするのではだめ？</a:t>
             </a:r>
+            <a:br>
+              <a:rPr lang="en-US" altLang="ja-JP" sz="3000">
+                <a:latin typeface="+mj-lt"/>
+                <a:ea typeface="+mj-ea"/>
+              </a:rPr>
+            </a:br>
+            <a:r>
+              <a:rPr lang="ja-JP" altLang="en-US" sz="3000">
+                <a:latin typeface="+mj-lt"/>
+                <a:ea typeface="+mj-ea"/>
+              </a:rPr>
+              <a:t>引くのも違うの？？</a:t>
+            </a:r>
+            <a:endParaRPr lang="ja-JP" sz="3000">
+              <a:latin typeface="+mj-lt"/>
+              <a:ea typeface="+mj-ea"/>
+            </a:endParaRPr>
           </a:p>
         </p:txBody>
       </p:sp>
@@ -5176,30 +5201,6 @@
           </a:p>
         </p:txBody>
       </p:sp>
-      <p:pic>
-        <p:nvPicPr>
-          <p:cNvPr id="4" name="Picture 3" descr="f1009_q1_tail.png"/>
-          <p:cNvPicPr>
-            <a:picLocks noChangeAspect="1"/>
-          </p:cNvPicPr>
-          <p:nvPr/>
-        </p:nvPicPr>
-        <p:blipFill>
-          <a:blip r:embed="rId3"/>
-          <a:stretch>
-            <a:fillRect/>
-          </a:stretch>
-        </p:blipFill>
-        <p:spPr>
-          <a:xfrm>
-            <a:off x="6949440" y="1737360"/>
-            <a:ext cx="5029200" cy="3073400"/>
-          </a:xfrm>
-          <a:prstGeom prst="rect">
-            <a:avLst/>
-          </a:prstGeom>
-        </p:spPr>
-      </p:pic>
     </p:spTree>
     <p:extLst>
       <p:ext uri="{BB962C8B-B14F-4D97-AF65-F5344CB8AC3E}">
@@ -5841,7 +5842,7 @@
         </p:nvGraphicFramePr>
         <p:xfrm>
           <a:off x="457200" y="1280160"/>
-          <a:ext cx="11247120" cy="2057400"/>
+          <a:ext cx="11247120" cy="2194560"/>
         </p:xfrm>
         <a:graphic>
           <a:graphicData uri="http://schemas.openxmlformats.org/drawingml/2006/table">

</xml_diff>

<commit_message>
slides: 本人の編集版を更新 (10-07 17:37)
</commit_message>
<xml_diff>
--- a/slides/2026-10-09_研究報告_10枚版.pptx
+++ b/slides/2026-10-09_研究報告_10枚版.pptx
@@ -148,7 +148,7 @@
   <pc:docChgLst>
     <pc:chgData name="202304239" userId="ab1adf7a-b8eb-4038-b404-de23e20d8a3a" providerId="ADAL" clId="{6C0E59ED-D716-49AF-B2FA-B94E7B8E5A8C}"/>
     <pc:docChg chg="undo custSel addSld delSld modSld sldOrd">
-      <pc:chgData name="202304239" userId="ab1adf7a-b8eb-4038-b404-de23e20d8a3a" providerId="ADAL" clId="{6C0E59ED-D716-49AF-B2FA-B94E7B8E5A8C}" dt="2026-10-07T08:36:12.924" v="1123" actId="478"/>
+      <pc:chgData name="202304239" userId="ab1adf7a-b8eb-4038-b404-de23e20d8a3a" providerId="ADAL" clId="{6C0E59ED-D716-49AF-B2FA-B94E7B8E5A8C}" dt="2026-10-07T08:36:17.027" v="1124" actId="1076"/>
       <pc:docMkLst>
         <pc:docMk/>
       </pc:docMkLst>
@@ -258,7 +258,7 @@
         </pc:sldMkLst>
       </pc:sldChg>
       <pc:sldChg chg="delSp modSp add mod">
-        <pc:chgData name="202304239" userId="ab1adf7a-b8eb-4038-b404-de23e20d8a3a" providerId="ADAL" clId="{6C0E59ED-D716-49AF-B2FA-B94E7B8E5A8C}" dt="2026-10-07T08:36:12.924" v="1123" actId="478"/>
+        <pc:chgData name="202304239" userId="ab1adf7a-b8eb-4038-b404-de23e20d8a3a" providerId="ADAL" clId="{6C0E59ED-D716-49AF-B2FA-B94E7B8E5A8C}" dt="2026-10-07T08:36:17.027" v="1124" actId="1076"/>
         <pc:sldMkLst>
           <pc:docMk/>
           <pc:sldMk cId="99932586" sldId="267"/>
@@ -269,6 +269,14 @@
             <pc:docMk/>
             <pc:sldMk cId="99932586" sldId="267"/>
             <ac:spMk id="2" creationId="{00000000-0000-0000-0000-000000000000}"/>
+          </ac:spMkLst>
+        </pc:spChg>
+        <pc:spChg chg="mod">
+          <ac:chgData name="202304239" userId="ab1adf7a-b8eb-4038-b404-de23e20d8a3a" providerId="ADAL" clId="{6C0E59ED-D716-49AF-B2FA-B94E7B8E5A8C}" dt="2026-10-07T08:36:17.027" v="1124" actId="1076"/>
+          <ac:spMkLst>
+            <pc:docMk/>
+            <pc:sldMk cId="99932586" sldId="267"/>
+            <ac:spMk id="3" creationId="{00000000-0000-0000-0000-000000000000}"/>
           </ac:spMkLst>
         </pc:spChg>
         <pc:picChg chg="del">
@@ -5018,7 +5026,7 @@
         </p:nvSpPr>
         <p:spPr>
           <a:xfrm>
-            <a:off x="457200" y="1371600"/>
+            <a:off x="328730" y="1840136"/>
             <a:ext cx="6400800" cy="5394960"/>
           </a:xfrm>
           <a:prstGeom prst="rect">

</xml_diff>